<commit_message>
Address zero-base presentation review round 2
</commit_message>
<xml_diff>
--- a/paper/presentations/heavy_tail_backup_intro/heavy_tail_backup_intro.pptx
+++ b/paper/presentations/heavy_tail_backup_intro/heavy_tail_backup_intro.pptx
@@ -2,17 +2,17 @@
 <file path=ppt/presentation.xml><?xml version="1.0" encoding="utf-8"?>
 <p:presentation xmlns:p="http://schemas.openxmlformats.org/presentationml/2006/main">
   <p:sldMasterIdLst>
-    <p:sldMasterId xmlns:r="http://schemas.openxmlformats.org/officeDocument/2006/relationships" id="2147483648" r:id="R359aa4f56f194104"/>
+    <p:sldMasterId xmlns:r="http://schemas.openxmlformats.org/officeDocument/2006/relationships" id="2147483648" r:id="Rc970b19ae99f49e9"/>
   </p:sldMasterIdLst>
   <p:notesMasterIdLst>
-    <p:notesMasterId xmlns:r="http://schemas.openxmlformats.org/officeDocument/2006/relationships" r:id="R9fd34200047c4e32"/>
+    <p:notesMasterId xmlns:r="http://schemas.openxmlformats.org/officeDocument/2006/relationships" r:id="Ra242a591518d4297"/>
   </p:notesMasterIdLst>
   <p:sldIdLst>
-    <p:sldId xmlns:r="http://schemas.openxmlformats.org/officeDocument/2006/relationships" id="256" r:id="R7a37c5171a544fc2"/>
-    <p:sldId xmlns:r="http://schemas.openxmlformats.org/officeDocument/2006/relationships" id="257" r:id="R8b93130d949a4b98"/>
-    <p:sldId xmlns:r="http://schemas.openxmlformats.org/officeDocument/2006/relationships" id="258" r:id="R70a9ccc102b84d27"/>
-    <p:sldId xmlns:r="http://schemas.openxmlformats.org/officeDocument/2006/relationships" id="259" r:id="R57c690585ffd4410"/>
-    <p:sldId xmlns:r="http://schemas.openxmlformats.org/officeDocument/2006/relationships" id="260" r:id="R8036421e75174f6a"/>
+    <p:sldId xmlns:r="http://schemas.openxmlformats.org/officeDocument/2006/relationships" id="256" r:id="R96467514c1ba4975"/>
+    <p:sldId xmlns:r="http://schemas.openxmlformats.org/officeDocument/2006/relationships" id="257" r:id="R4c2795f212bf4c8a"/>
+    <p:sldId xmlns:r="http://schemas.openxmlformats.org/officeDocument/2006/relationships" id="258" r:id="Rcf5f6be4f85544e1"/>
+    <p:sldId xmlns:r="http://schemas.openxmlformats.org/officeDocument/2006/relationships" id="259" r:id="Rb58692dd01f14a53"/>
+    <p:sldId xmlns:r="http://schemas.openxmlformats.org/officeDocument/2006/relationships" id="260" r:id="R77bcee06887e437d"/>
   </p:sldIdLst>
   <p:sldSz cx="12192000" cy="6858000"/>
   <p:notesSz cx="6858000" cy="9144000"/>
@@ -823,7 +823,7 @@
   </p:cSld>
   <p:clrMap bg1="lt1" tx1="dk1" bg2="lt2" tx2="dk2" accent1="accent1" accent2="accent2" accent3="accent3" accent4="accent4" accent5="accent5" accent6="accent6" hlink="hlink" folHlink="folHlink"/>
   <p:sldLayoutIdLst>
-    <p:sldLayoutId xmlns:r="http://schemas.openxmlformats.org/officeDocument/2006/relationships" id="2147483649" r:id="Rf9400277fb5a414e"/>
+    <p:sldLayoutId xmlns:r="http://schemas.openxmlformats.org/officeDocument/2006/relationships" id="2147483649" r:id="R86ab11ed5ac14d72"/>
   </p:sldLayoutIdLst>
   <p:txStyles>
     <p:titleStyle>
@@ -1122,7 +1122,7 @@
           <p:cNvPr id="1" name="">
             <a:extLst xmlns:a="http://schemas.openxmlformats.org/drawingml/2006/main">
               <a:ext uri="{FF2B5EF4-FFF2-40B4-BE49-F238E27FC236}">
-                <a16:creationId xmlns:a16="http://schemas.microsoft.com/office/drawing/2014/main" id="{B9946BC3-FC6A-4E25-A12B-9544DAE02D4A}"/>
+                <a16:creationId xmlns:a16="http://schemas.microsoft.com/office/drawing/2014/main" id="{2096FA08-6B73-48E4-AAF6-DC7938B11D45}"/>
               </a:ext>
             </a:extLst>
           </p:cNvPr>
@@ -1157,7 +1157,7 @@
           <p:cNvPr id="2" name="">
             <a:extLst xmlns:a="http://schemas.openxmlformats.org/drawingml/2006/main">
               <a:ext uri="{FF2B5EF4-FFF2-40B4-BE49-F238E27FC236}">
-                <a16:creationId xmlns:a16="http://schemas.microsoft.com/office/drawing/2014/main" id="{EB27F462-D1EA-477E-B00C-135EA5BEEC70}"/>
+                <a16:creationId xmlns:a16="http://schemas.microsoft.com/office/drawing/2014/main" id="{DC6FB8B7-DF15-46D0-80E4-708DFC5E3415}"/>
               </a:ext>
             </a:extLst>
           </p:cNvPr>
@@ -1192,7 +1192,7 @@
           <p:cNvPr id="3" name="">
             <a:extLst xmlns:a="http://schemas.openxmlformats.org/drawingml/2006/main">
               <a:ext uri="{FF2B5EF4-FFF2-40B4-BE49-F238E27FC236}">
-                <a16:creationId xmlns:a16="http://schemas.microsoft.com/office/drawing/2014/main" id="{15478353-33F6-45B0-9EA9-70EC9BDD4512}"/>
+                <a16:creationId xmlns:a16="http://schemas.microsoft.com/office/drawing/2014/main" id="{A933637D-3930-4562-8A6A-BB15529C4194}"/>
               </a:ext>
             </a:extLst>
           </p:cNvPr>
@@ -1256,7 +1256,7 @@
           <p:cNvPr id="4" name="">
             <a:extLst xmlns:a="http://schemas.openxmlformats.org/drawingml/2006/main">
               <a:ext uri="{FF2B5EF4-FFF2-40B4-BE49-F238E27FC236}">
-                <a16:creationId xmlns:a16="http://schemas.microsoft.com/office/drawing/2014/main" id="{3D8B766B-1BA0-4D37-B4AF-2FE37416F7A1}"/>
+                <a16:creationId xmlns:a16="http://schemas.microsoft.com/office/drawing/2014/main" id="{8F223D16-92C3-4A86-9EC8-8CDFF475E751}"/>
               </a:ext>
             </a:extLst>
           </p:cNvPr>
@@ -1320,7 +1320,7 @@
           <p:cNvPr id="5" name="">
             <a:extLst xmlns:a="http://schemas.openxmlformats.org/drawingml/2006/main">
               <a:ext uri="{FF2B5EF4-FFF2-40B4-BE49-F238E27FC236}">
-                <a16:creationId xmlns:a16="http://schemas.microsoft.com/office/drawing/2014/main" id="{4CBD3261-CD29-41DF-81EC-9FC2B8BCF8D9}"/>
+                <a16:creationId xmlns:a16="http://schemas.microsoft.com/office/drawing/2014/main" id="{F8029EA3-C8EC-4351-89FB-0BBFB2860FA7}"/>
               </a:ext>
             </a:extLst>
           </p:cNvPr>
@@ -1384,7 +1384,7 @@
           <p:cNvPr id="6" name="">
             <a:extLst xmlns:a="http://schemas.openxmlformats.org/drawingml/2006/main">
               <a:ext uri="{FF2B5EF4-FFF2-40B4-BE49-F238E27FC236}">
-                <a16:creationId xmlns:a16="http://schemas.microsoft.com/office/drawing/2014/main" id="{1CC278E8-7FF0-4E68-9C2D-AB56CBBA07FB}"/>
+                <a16:creationId xmlns:a16="http://schemas.microsoft.com/office/drawing/2014/main" id="{ECF03F08-548D-4783-93D4-BF78CEF0BE68}"/>
               </a:ext>
             </a:extLst>
           </p:cNvPr>
@@ -1448,7 +1448,7 @@
           <p:cNvPr id="7" name="">
             <a:extLst xmlns:a="http://schemas.openxmlformats.org/drawingml/2006/main">
               <a:ext uri="{FF2B5EF4-FFF2-40B4-BE49-F238E27FC236}">
-                <a16:creationId xmlns:a16="http://schemas.microsoft.com/office/drawing/2014/main" id="{63ABE8DE-0AE6-4665-AA4D-5CAA18827E5E}"/>
+                <a16:creationId xmlns:a16="http://schemas.microsoft.com/office/drawing/2014/main" id="{274D7BE7-2049-4AAA-8B5E-5C887D3791F1}"/>
               </a:ext>
             </a:extLst>
           </p:cNvPr>
@@ -1481,7 +1481,7 @@
           <p:cNvPr id="8" name="">
             <a:extLst xmlns:a="http://schemas.openxmlformats.org/drawingml/2006/main">
               <a:ext uri="{FF2B5EF4-FFF2-40B4-BE49-F238E27FC236}">
-                <a16:creationId xmlns:a16="http://schemas.microsoft.com/office/drawing/2014/main" id="{93890035-FFDB-45D1-8CD7-316C3FAFD3D6}"/>
+                <a16:creationId xmlns:a16="http://schemas.microsoft.com/office/drawing/2014/main" id="{995E59C3-396C-445E-8EDB-389C77DC0DDF}"/>
               </a:ext>
             </a:extLst>
           </p:cNvPr>
@@ -1545,7 +1545,7 @@
           <p:cNvPr id="9" name="">
             <a:extLst xmlns:a="http://schemas.openxmlformats.org/drawingml/2006/main">
               <a:ext uri="{FF2B5EF4-FFF2-40B4-BE49-F238E27FC236}">
-                <a16:creationId xmlns:a16="http://schemas.microsoft.com/office/drawing/2014/main" id="{D39A3701-AFD8-4354-848A-658E851B2923}"/>
+                <a16:creationId xmlns:a16="http://schemas.microsoft.com/office/drawing/2014/main" id="{29497AF7-393D-4196-83FF-9429847E33C8}"/>
               </a:ext>
             </a:extLst>
           </p:cNvPr>
@@ -1580,7 +1580,7 @@
           <p:cNvPr id="10" name="">
             <a:extLst xmlns:a="http://schemas.openxmlformats.org/drawingml/2006/main">
               <a:ext uri="{FF2B5EF4-FFF2-40B4-BE49-F238E27FC236}">
-                <a16:creationId xmlns:a16="http://schemas.microsoft.com/office/drawing/2014/main" id="{7A52418C-2FEA-41BB-A1BE-8ACBED135337}"/>
+                <a16:creationId xmlns:a16="http://schemas.microsoft.com/office/drawing/2014/main" id="{D25E7B43-5B77-41D2-96B6-F9581DE312CC}"/>
               </a:ext>
             </a:extLst>
           </p:cNvPr>
@@ -1644,7 +1644,7 @@
           <p:cNvPr id="11" name="">
             <a:extLst xmlns:a="http://schemas.openxmlformats.org/drawingml/2006/main">
               <a:ext uri="{FF2B5EF4-FFF2-40B4-BE49-F238E27FC236}">
-                <a16:creationId xmlns:a16="http://schemas.microsoft.com/office/drawing/2014/main" id="{E46D7769-017F-4747-8074-DEDCEECCEEA5}"/>
+                <a16:creationId xmlns:a16="http://schemas.microsoft.com/office/drawing/2014/main" id="{A782C2A4-7824-41B4-9F7D-116C18C5134D}"/>
               </a:ext>
             </a:extLst>
           </p:cNvPr>
@@ -1679,7 +1679,7 @@
           <p:cNvPr id="12" name="">
             <a:extLst xmlns:a="http://schemas.openxmlformats.org/drawingml/2006/main">
               <a:ext uri="{FF2B5EF4-FFF2-40B4-BE49-F238E27FC236}">
-                <a16:creationId xmlns:a16="http://schemas.microsoft.com/office/drawing/2014/main" id="{F40E7539-57D8-4DEC-BC11-47C0E788783C}"/>
+                <a16:creationId xmlns:a16="http://schemas.microsoft.com/office/drawing/2014/main" id="{60D44B20-1315-409D-A0F8-0136F935A7B4}"/>
               </a:ext>
             </a:extLst>
           </p:cNvPr>
@@ -1714,7 +1714,7 @@
           <p:cNvPr id="13" name="">
             <a:extLst xmlns:a="http://schemas.openxmlformats.org/drawingml/2006/main">
               <a:ext uri="{FF2B5EF4-FFF2-40B4-BE49-F238E27FC236}">
-                <a16:creationId xmlns:a16="http://schemas.microsoft.com/office/drawing/2014/main" id="{A405BCDC-C44F-4794-A757-B3CACDF8C895}"/>
+                <a16:creationId xmlns:a16="http://schemas.microsoft.com/office/drawing/2014/main" id="{28D1D086-AFD7-466B-8B3E-CBA63DB5411E}"/>
               </a:ext>
             </a:extLst>
           </p:cNvPr>
@@ -1778,7 +1778,7 @@
           <p:cNvPr id="14" name="">
             <a:extLst xmlns:a="http://schemas.openxmlformats.org/drawingml/2006/main">
               <a:ext uri="{FF2B5EF4-FFF2-40B4-BE49-F238E27FC236}">
-                <a16:creationId xmlns:a16="http://schemas.microsoft.com/office/drawing/2014/main" id="{D4553A31-5875-4E0D-B665-3936B53ADE0C}"/>
+                <a16:creationId xmlns:a16="http://schemas.microsoft.com/office/drawing/2014/main" id="{EBEBD19C-E75F-4416-AB3B-7EEA1B171046}"/>
               </a:ext>
             </a:extLst>
           </p:cNvPr>
@@ -1811,7 +1811,7 @@
           <p:cNvPr id="15" name="">
             <a:extLst xmlns:a="http://schemas.openxmlformats.org/drawingml/2006/main">
               <a:ext uri="{FF2B5EF4-FFF2-40B4-BE49-F238E27FC236}">
-                <a16:creationId xmlns:a16="http://schemas.microsoft.com/office/drawing/2014/main" id="{C73402BC-8EC9-48F4-844D-24CEA8E4E7F2}"/>
+                <a16:creationId xmlns:a16="http://schemas.microsoft.com/office/drawing/2014/main" id="{C6521D3A-C08D-470A-A94D-3D5FA5B7C75D}"/>
               </a:ext>
             </a:extLst>
           </p:cNvPr>
@@ -1875,7 +1875,7 @@
           <p:cNvPr id="16" name="">
             <a:extLst xmlns:a="http://schemas.openxmlformats.org/drawingml/2006/main">
               <a:ext uri="{FF2B5EF4-FFF2-40B4-BE49-F238E27FC236}">
-                <a16:creationId xmlns:a16="http://schemas.microsoft.com/office/drawing/2014/main" id="{92AD3DEA-28A2-4289-B149-120EA93AD699}"/>
+                <a16:creationId xmlns:a16="http://schemas.microsoft.com/office/drawing/2014/main" id="{F2A702A0-3E4E-4859-9920-09AF2FFC96FC}"/>
               </a:ext>
             </a:extLst>
           </p:cNvPr>
@@ -1910,7 +1910,7 @@
           <p:cNvPr id="17" name="">
             <a:extLst xmlns:a="http://schemas.openxmlformats.org/drawingml/2006/main">
               <a:ext uri="{FF2B5EF4-FFF2-40B4-BE49-F238E27FC236}">
-                <a16:creationId xmlns:a16="http://schemas.microsoft.com/office/drawing/2014/main" id="{FF19673E-2BD5-4FC4-B3FB-A88696AC305C}"/>
+                <a16:creationId xmlns:a16="http://schemas.microsoft.com/office/drawing/2014/main" id="{AED8AA2F-66B4-4262-ADFD-6DB267C16E27}"/>
               </a:ext>
             </a:extLst>
           </p:cNvPr>
@@ -1974,7 +1974,7 @@
           <p:cNvPr id="18" name="">
             <a:extLst xmlns:a="http://schemas.openxmlformats.org/drawingml/2006/main">
               <a:ext uri="{FF2B5EF4-FFF2-40B4-BE49-F238E27FC236}">
-                <a16:creationId xmlns:a16="http://schemas.microsoft.com/office/drawing/2014/main" id="{0D719422-EC35-4B76-9069-D490F5DA32C4}"/>
+                <a16:creationId xmlns:a16="http://schemas.microsoft.com/office/drawing/2014/main" id="{24291CF7-E3BA-4CDA-9CE9-1BCA65B2B1D5}"/>
               </a:ext>
             </a:extLst>
           </p:cNvPr>
@@ -2007,7 +2007,7 @@
           <p:cNvPr id="19" name="">
             <a:extLst xmlns:a="http://schemas.openxmlformats.org/drawingml/2006/main">
               <a:ext uri="{FF2B5EF4-FFF2-40B4-BE49-F238E27FC236}">
-                <a16:creationId xmlns:a16="http://schemas.microsoft.com/office/drawing/2014/main" id="{E1118FB5-FADD-4C5E-AAF4-7F008546EFDF}"/>
+                <a16:creationId xmlns:a16="http://schemas.microsoft.com/office/drawing/2014/main" id="{BFE764A4-2DCC-4D40-8FA7-B72667F58D11}"/>
               </a:ext>
             </a:extLst>
           </p:cNvPr>
@@ -2071,7 +2071,7 @@
           <p:cNvPr id="20" name="">
             <a:extLst xmlns:a="http://schemas.openxmlformats.org/drawingml/2006/main">
               <a:ext uri="{FF2B5EF4-FFF2-40B4-BE49-F238E27FC236}">
-                <a16:creationId xmlns:a16="http://schemas.microsoft.com/office/drawing/2014/main" id="{0E2E208A-34FF-470E-9F36-2C0BB2781654}"/>
+                <a16:creationId xmlns:a16="http://schemas.microsoft.com/office/drawing/2014/main" id="{95823C77-5B2A-4C02-9076-34585C3FA7BD}"/>
               </a:ext>
             </a:extLst>
           </p:cNvPr>
@@ -2106,7 +2106,7 @@
           <p:cNvPr id="21" name="">
             <a:extLst xmlns:a="http://schemas.openxmlformats.org/drawingml/2006/main">
               <a:ext uri="{FF2B5EF4-FFF2-40B4-BE49-F238E27FC236}">
-                <a16:creationId xmlns:a16="http://schemas.microsoft.com/office/drawing/2014/main" id="{73B7E802-AA64-4C93-8CB1-EDCC6D1E6E7D}"/>
+                <a16:creationId xmlns:a16="http://schemas.microsoft.com/office/drawing/2014/main" id="{EFF06C04-6578-4FDF-9D06-38AA5E024C77}"/>
               </a:ext>
             </a:extLst>
           </p:cNvPr>
@@ -2170,7 +2170,7 @@
           <p:cNvPr id="22" name="">
             <a:extLst xmlns:a="http://schemas.openxmlformats.org/drawingml/2006/main">
               <a:ext uri="{FF2B5EF4-FFF2-40B4-BE49-F238E27FC236}">
-                <a16:creationId xmlns:a16="http://schemas.microsoft.com/office/drawing/2014/main" id="{8FC0C6DA-3A18-4234-B579-3426DEA70387}"/>
+                <a16:creationId xmlns:a16="http://schemas.microsoft.com/office/drawing/2014/main" id="{A9533EAF-5CB1-4C37-B7A4-58A9E28B6D43}"/>
               </a:ext>
             </a:extLst>
           </p:cNvPr>
@@ -2203,7 +2203,7 @@
           <p:cNvPr id="23" name="">
             <a:extLst xmlns:a="http://schemas.openxmlformats.org/drawingml/2006/main">
               <a:ext uri="{FF2B5EF4-FFF2-40B4-BE49-F238E27FC236}">
-                <a16:creationId xmlns:a16="http://schemas.microsoft.com/office/drawing/2014/main" id="{096AB2AC-799C-4FA7-9271-2C1115670C2E}"/>
+                <a16:creationId xmlns:a16="http://schemas.microsoft.com/office/drawing/2014/main" id="{74017A17-5480-45FD-8089-87E765D148A6}"/>
               </a:ext>
             </a:extLst>
           </p:cNvPr>
@@ -2267,7 +2267,7 @@
           <p:cNvPr id="24" name="">
             <a:extLst xmlns:a="http://schemas.openxmlformats.org/drawingml/2006/main">
               <a:ext uri="{FF2B5EF4-FFF2-40B4-BE49-F238E27FC236}">
-                <a16:creationId xmlns:a16="http://schemas.microsoft.com/office/drawing/2014/main" id="{31CA025E-1499-4D6A-847F-6EEA3E1921E9}"/>
+                <a16:creationId xmlns:a16="http://schemas.microsoft.com/office/drawing/2014/main" id="{E01F370E-1C68-4C09-874D-993A8F4B0DCC}"/>
               </a:ext>
             </a:extLst>
           </p:cNvPr>
@@ -2302,7 +2302,7 @@
           <p:cNvPr id="25" name="">
             <a:extLst xmlns:a="http://schemas.openxmlformats.org/drawingml/2006/main">
               <a:ext uri="{FF2B5EF4-FFF2-40B4-BE49-F238E27FC236}">
-                <a16:creationId xmlns:a16="http://schemas.microsoft.com/office/drawing/2014/main" id="{D1DDE649-027B-42F9-8CAD-34D1E3B505A4}"/>
+                <a16:creationId xmlns:a16="http://schemas.microsoft.com/office/drawing/2014/main" id="{40C8591F-FC90-48A5-A3F9-D395265E0B59}"/>
               </a:ext>
             </a:extLst>
           </p:cNvPr>
@@ -2366,7 +2366,7 @@
           <p:cNvPr id="26" name="">
             <a:extLst xmlns:a="http://schemas.openxmlformats.org/drawingml/2006/main">
               <a:ext uri="{FF2B5EF4-FFF2-40B4-BE49-F238E27FC236}">
-                <a16:creationId xmlns:a16="http://schemas.microsoft.com/office/drawing/2014/main" id="{9EBF9ECE-EBEA-418E-BBD7-E106A6DC3349}"/>
+                <a16:creationId xmlns:a16="http://schemas.microsoft.com/office/drawing/2014/main" id="{A3C86A26-EC53-49F3-BA48-9158B2520FE0}"/>
               </a:ext>
             </a:extLst>
           </p:cNvPr>
@@ -2399,7 +2399,7 @@
           <p:cNvPr id="27" name="">
             <a:extLst xmlns:a="http://schemas.openxmlformats.org/drawingml/2006/main">
               <a:ext uri="{FF2B5EF4-FFF2-40B4-BE49-F238E27FC236}">
-                <a16:creationId xmlns:a16="http://schemas.microsoft.com/office/drawing/2014/main" id="{B89940DA-DD08-4C45-B107-CA51B9833446}"/>
+                <a16:creationId xmlns:a16="http://schemas.microsoft.com/office/drawing/2014/main" id="{9E6D2F0F-1290-456B-9946-FB6EF4DE2019}"/>
               </a:ext>
             </a:extLst>
           </p:cNvPr>
@@ -2463,7 +2463,7 @@
           <p:cNvPr id="28" name="">
             <a:extLst xmlns:a="http://schemas.openxmlformats.org/drawingml/2006/main">
               <a:ext uri="{FF2B5EF4-FFF2-40B4-BE49-F238E27FC236}">
-                <a16:creationId xmlns:a16="http://schemas.microsoft.com/office/drawing/2014/main" id="{D1F14C1C-B2C4-402B-944D-0AA846EBF401}"/>
+                <a16:creationId xmlns:a16="http://schemas.microsoft.com/office/drawing/2014/main" id="{46FE3E9A-12A2-432B-AE5E-61E4CFAB5214}"/>
               </a:ext>
             </a:extLst>
           </p:cNvPr>
@@ -2498,7 +2498,7 @@
           <p:cNvPr id="29" name="">
             <a:extLst xmlns:a="http://schemas.openxmlformats.org/drawingml/2006/main">
               <a:ext uri="{FF2B5EF4-FFF2-40B4-BE49-F238E27FC236}">
-                <a16:creationId xmlns:a16="http://schemas.microsoft.com/office/drawing/2014/main" id="{924A3A72-6CAE-4C22-A2FD-524B2AB3F3C0}"/>
+                <a16:creationId xmlns:a16="http://schemas.microsoft.com/office/drawing/2014/main" id="{9593E5B0-2046-4F2D-AE6D-1D8040515322}"/>
               </a:ext>
             </a:extLst>
           </p:cNvPr>
@@ -2562,7 +2562,7 @@
           <p:cNvPr id="30" name="">
             <a:extLst xmlns:a="http://schemas.openxmlformats.org/drawingml/2006/main">
               <a:ext uri="{FF2B5EF4-FFF2-40B4-BE49-F238E27FC236}">
-                <a16:creationId xmlns:a16="http://schemas.microsoft.com/office/drawing/2014/main" id="{70E96892-D90F-44D0-82A4-7C23DC145CDF}"/>
+                <a16:creationId xmlns:a16="http://schemas.microsoft.com/office/drawing/2014/main" id="{3E06AF58-65E5-4872-B5B0-6166673A1081}"/>
               </a:ext>
             </a:extLst>
           </p:cNvPr>
@@ -2595,7 +2595,7 @@
           <p:cNvPr id="31" name="">
             <a:extLst xmlns:a="http://schemas.openxmlformats.org/drawingml/2006/main">
               <a:ext uri="{FF2B5EF4-FFF2-40B4-BE49-F238E27FC236}">
-                <a16:creationId xmlns:a16="http://schemas.microsoft.com/office/drawing/2014/main" id="{4F56D385-D41C-4295-B33E-AC31BC7453BE}"/>
+                <a16:creationId xmlns:a16="http://schemas.microsoft.com/office/drawing/2014/main" id="{C7FA6AC3-BF5B-4B8D-A8C7-7BCA965284E8}"/>
               </a:ext>
             </a:extLst>
           </p:cNvPr>
@@ -2659,7 +2659,7 @@
           <p:cNvPr id="32" name="">
             <a:extLst xmlns:a="http://schemas.openxmlformats.org/drawingml/2006/main">
               <a:ext uri="{FF2B5EF4-FFF2-40B4-BE49-F238E27FC236}">
-                <a16:creationId xmlns:a16="http://schemas.microsoft.com/office/drawing/2014/main" id="{CF8E6963-8A1E-4CFC-951B-A8637C35515E}"/>
+                <a16:creationId xmlns:a16="http://schemas.microsoft.com/office/drawing/2014/main" id="{E9D5FCE6-6441-433B-8C2E-A97098773E17}"/>
               </a:ext>
             </a:extLst>
           </p:cNvPr>
@@ -2694,7 +2694,7 @@
           <p:cNvPr id="33" name="">
             <a:extLst xmlns:a="http://schemas.openxmlformats.org/drawingml/2006/main">
               <a:ext uri="{FF2B5EF4-FFF2-40B4-BE49-F238E27FC236}">
-                <a16:creationId xmlns:a16="http://schemas.microsoft.com/office/drawing/2014/main" id="{65E530F1-656E-4C01-B8E3-839C83021264}"/>
+                <a16:creationId xmlns:a16="http://schemas.microsoft.com/office/drawing/2014/main" id="{F049C692-25AE-4CD9-B325-3A97F1B0984E}"/>
               </a:ext>
             </a:extLst>
           </p:cNvPr>
@@ -2727,7 +2727,7 @@
           <p:cNvPr id="34" name="">
             <a:extLst xmlns:a="http://schemas.openxmlformats.org/drawingml/2006/main">
               <a:ext uri="{FF2B5EF4-FFF2-40B4-BE49-F238E27FC236}">
-                <a16:creationId xmlns:a16="http://schemas.microsoft.com/office/drawing/2014/main" id="{E436DDFF-F0E9-4D70-8934-B1572F2EB905}"/>
+                <a16:creationId xmlns:a16="http://schemas.microsoft.com/office/drawing/2014/main" id="{5A2A98B8-2C5C-4D7E-92F7-3F90A72EBF30}"/>
               </a:ext>
             </a:extLst>
           </p:cNvPr>
@@ -2791,7 +2791,7 @@
           <p:cNvPr id="35" name="">
             <a:extLst xmlns:a="http://schemas.openxmlformats.org/drawingml/2006/main">
               <a:ext uri="{FF2B5EF4-FFF2-40B4-BE49-F238E27FC236}">
-                <a16:creationId xmlns:a16="http://schemas.microsoft.com/office/drawing/2014/main" id="{265C0ED5-0F80-4C08-B453-5D08CB1F436A}"/>
+                <a16:creationId xmlns:a16="http://schemas.microsoft.com/office/drawing/2014/main" id="{156A5F5E-3980-4AFB-B13B-59EB2D229817}"/>
               </a:ext>
             </a:extLst>
           </p:cNvPr>
@@ -2826,7 +2826,7 @@
           <p:cNvPr id="36" name="">
             <a:extLst xmlns:a="http://schemas.openxmlformats.org/drawingml/2006/main">
               <a:ext uri="{FF2B5EF4-FFF2-40B4-BE49-F238E27FC236}">
-                <a16:creationId xmlns:a16="http://schemas.microsoft.com/office/drawing/2014/main" id="{C5172F74-BA9D-489E-8A76-56B101868370}"/>
+                <a16:creationId xmlns:a16="http://schemas.microsoft.com/office/drawing/2014/main" id="{6632B630-BBCF-45DF-AAEE-C78173A7A8E4}"/>
               </a:ext>
             </a:extLst>
           </p:cNvPr>
@@ -2859,7 +2859,7 @@
           <p:cNvPr id="37" name="">
             <a:extLst xmlns:a="http://schemas.openxmlformats.org/drawingml/2006/main">
               <a:ext uri="{FF2B5EF4-FFF2-40B4-BE49-F238E27FC236}">
-                <a16:creationId xmlns:a16="http://schemas.microsoft.com/office/drawing/2014/main" id="{352EAAA7-5197-4A76-B88C-AC1B7D0065E2}"/>
+                <a16:creationId xmlns:a16="http://schemas.microsoft.com/office/drawing/2014/main" id="{B1A62F42-B743-441F-87C0-C1EAF25324D0}"/>
               </a:ext>
             </a:extLst>
           </p:cNvPr>
@@ -2923,7 +2923,7 @@
           <p:cNvPr id="38" name="">
             <a:extLst xmlns:a="http://schemas.openxmlformats.org/drawingml/2006/main">
               <a:ext uri="{FF2B5EF4-FFF2-40B4-BE49-F238E27FC236}">
-                <a16:creationId xmlns:a16="http://schemas.microsoft.com/office/drawing/2014/main" id="{F667C1EE-79E9-40FB-9C9E-EBA2CB79FB89}"/>
+                <a16:creationId xmlns:a16="http://schemas.microsoft.com/office/drawing/2014/main" id="{5A6E4919-0A18-432F-AE00-1C4C51802D42}"/>
               </a:ext>
             </a:extLst>
           </p:cNvPr>
@@ -2956,7 +2956,7 @@
           <p:cNvPr id="39" name="">
             <a:extLst xmlns:a="http://schemas.openxmlformats.org/drawingml/2006/main">
               <a:ext uri="{FF2B5EF4-FFF2-40B4-BE49-F238E27FC236}">
-                <a16:creationId xmlns:a16="http://schemas.microsoft.com/office/drawing/2014/main" id="{7BBB6F7A-F361-4ECD-9661-3AD0CCCE0A2F}"/>
+                <a16:creationId xmlns:a16="http://schemas.microsoft.com/office/drawing/2014/main" id="{80D32151-340C-43FC-9236-FBFC9D0004B8}"/>
               </a:ext>
             </a:extLst>
           </p:cNvPr>
@@ -3020,7 +3020,7 @@
           <p:cNvPr id="40" name="">
             <a:extLst xmlns:a="http://schemas.openxmlformats.org/drawingml/2006/main">
               <a:ext uri="{FF2B5EF4-FFF2-40B4-BE49-F238E27FC236}">
-                <a16:creationId xmlns:a16="http://schemas.microsoft.com/office/drawing/2014/main" id="{90E640B5-DDD7-47F1-826F-F6847F881397}"/>
+                <a16:creationId xmlns:a16="http://schemas.microsoft.com/office/drawing/2014/main" id="{95990AD1-B21D-4E39-950E-A458D6F9C3E7}"/>
               </a:ext>
             </a:extLst>
           </p:cNvPr>
@@ -3053,7 +3053,7 @@
           <p:cNvPr id="41" name="">
             <a:extLst xmlns:a="http://schemas.openxmlformats.org/drawingml/2006/main">
               <a:ext uri="{FF2B5EF4-FFF2-40B4-BE49-F238E27FC236}">
-                <a16:creationId xmlns:a16="http://schemas.microsoft.com/office/drawing/2014/main" id="{1BDA43CF-928D-429F-B3BB-F96F92E46847}"/>
+                <a16:creationId xmlns:a16="http://schemas.microsoft.com/office/drawing/2014/main" id="{23291CB0-4913-4B85-AFFD-7C33CE7EFCA4}"/>
               </a:ext>
             </a:extLst>
           </p:cNvPr>
@@ -3117,7 +3117,7 @@
           <p:cNvPr id="42" name="">
             <a:extLst xmlns:a="http://schemas.openxmlformats.org/drawingml/2006/main">
               <a:ext uri="{FF2B5EF4-FFF2-40B4-BE49-F238E27FC236}">
-                <a16:creationId xmlns:a16="http://schemas.microsoft.com/office/drawing/2014/main" id="{6EA7343A-824A-4CD3-8CF6-DAE183DC99A0}"/>
+                <a16:creationId xmlns:a16="http://schemas.microsoft.com/office/drawing/2014/main" id="{7EBF0B8B-2472-4057-930F-28E27B7C872D}"/>
               </a:ext>
             </a:extLst>
           </p:cNvPr>
@@ -3204,7 +3204,7 @@
           <p:cNvPr id="43" name="">
             <a:extLst xmlns:a="http://schemas.openxmlformats.org/drawingml/2006/main">
               <a:ext uri="{FF2B5EF4-FFF2-40B4-BE49-F238E27FC236}">
-                <a16:creationId xmlns:a16="http://schemas.microsoft.com/office/drawing/2014/main" id="{6BEAEDF9-8AD0-47F2-8465-D5A2AE9E0BF6}"/>
+                <a16:creationId xmlns:a16="http://schemas.microsoft.com/office/drawing/2014/main" id="{503E7008-B381-44E0-8361-88A6C6DB5A5F}"/>
               </a:ext>
             </a:extLst>
           </p:cNvPr>
@@ -3237,7 +3237,7 @@
           <p:cNvPr id="44" name="">
             <a:extLst xmlns:a="http://schemas.openxmlformats.org/drawingml/2006/main">
               <a:ext uri="{FF2B5EF4-FFF2-40B4-BE49-F238E27FC236}">
-                <a16:creationId xmlns:a16="http://schemas.microsoft.com/office/drawing/2014/main" id="{AFDDD11B-7C74-4AC6-A926-19E0F1212435}"/>
+                <a16:creationId xmlns:a16="http://schemas.microsoft.com/office/drawing/2014/main" id="{5E9FF76B-2902-4D75-9FEF-36E1BBBDEFF7}"/>
               </a:ext>
             </a:extLst>
           </p:cNvPr>
@@ -3301,7 +3301,7 @@
           <p:cNvPr id="45" name="">
             <a:extLst xmlns:a="http://schemas.openxmlformats.org/drawingml/2006/main">
               <a:ext uri="{FF2B5EF4-FFF2-40B4-BE49-F238E27FC236}">
-                <a16:creationId xmlns:a16="http://schemas.microsoft.com/office/drawing/2014/main" id="{B2AA5283-65DF-4F56-A04B-1F7693CFA542}"/>
+                <a16:creationId xmlns:a16="http://schemas.microsoft.com/office/drawing/2014/main" id="{17D5E5B7-B7BB-4D73-973E-813D3FC7D4B4}"/>
               </a:ext>
             </a:extLst>
           </p:cNvPr>
@@ -3336,7 +3336,7 @@
           <p:cNvPr id="46" name="">
             <a:extLst xmlns:a="http://schemas.openxmlformats.org/drawingml/2006/main">
               <a:ext uri="{FF2B5EF4-FFF2-40B4-BE49-F238E27FC236}">
-                <a16:creationId xmlns:a16="http://schemas.microsoft.com/office/drawing/2014/main" id="{CEE751CB-3F50-4218-928A-04D37C74E96E}"/>
+                <a16:creationId xmlns:a16="http://schemas.microsoft.com/office/drawing/2014/main" id="{EE0E512F-6891-4FA5-BD01-4267507346BD}"/>
               </a:ext>
             </a:extLst>
           </p:cNvPr>
@@ -3398,7 +3398,7 @@
     </p:spTree>
     <p:extLst>
       <p:ext uri="{BB962C8B-B14F-4D97-AF65-F5344CB8AC3E}">
-        <p14:creationId xmlns:p14="http://schemas.microsoft.com/office/powerpoint/2010/main" val="545927259"/>
+        <p14:creationId xmlns:p14="http://schemas.microsoft.com/office/powerpoint/2010/main" val="1399287782"/>
       </p:ext>
     </p:extLst>
   </p:cSld>
@@ -3422,7 +3422,7 @@
           <p:cNvPr id="1" name="">
             <a:extLst xmlns:a="http://schemas.openxmlformats.org/drawingml/2006/main">
               <a:ext uri="{FF2B5EF4-FFF2-40B4-BE49-F238E27FC236}">
-                <a16:creationId xmlns:a16="http://schemas.microsoft.com/office/drawing/2014/main" id="{70081C22-A312-47DA-B46D-97D3A766F622}"/>
+                <a16:creationId xmlns:a16="http://schemas.microsoft.com/office/drawing/2014/main" id="{FAD8F615-0C4A-460B-8A57-A26951DA9CB3}"/>
               </a:ext>
             </a:extLst>
           </p:cNvPr>
@@ -3457,7 +3457,7 @@
           <p:cNvPr id="2" name="">
             <a:extLst xmlns:a="http://schemas.openxmlformats.org/drawingml/2006/main">
               <a:ext uri="{FF2B5EF4-FFF2-40B4-BE49-F238E27FC236}">
-                <a16:creationId xmlns:a16="http://schemas.microsoft.com/office/drawing/2014/main" id="{A5939B6D-6DBC-49D5-AB34-AE94C961445A}"/>
+                <a16:creationId xmlns:a16="http://schemas.microsoft.com/office/drawing/2014/main" id="{2C038ED4-EE6D-4996-BEF7-0DE4C8975E78}"/>
               </a:ext>
             </a:extLst>
           </p:cNvPr>
@@ -3492,7 +3492,7 @@
           <p:cNvPr id="3" name="">
             <a:extLst xmlns:a="http://schemas.openxmlformats.org/drawingml/2006/main">
               <a:ext uri="{FF2B5EF4-FFF2-40B4-BE49-F238E27FC236}">
-                <a16:creationId xmlns:a16="http://schemas.microsoft.com/office/drawing/2014/main" id="{70A4F0D4-1622-46CD-97B5-ACADCAB3B1D4}"/>
+                <a16:creationId xmlns:a16="http://schemas.microsoft.com/office/drawing/2014/main" id="{F884E87E-CA95-4999-BADB-FB20B32D45FE}"/>
               </a:ext>
             </a:extLst>
           </p:cNvPr>
@@ -3556,7 +3556,7 @@
           <p:cNvPr id="4" name="">
             <a:extLst xmlns:a="http://schemas.openxmlformats.org/drawingml/2006/main">
               <a:ext uri="{FF2B5EF4-FFF2-40B4-BE49-F238E27FC236}">
-                <a16:creationId xmlns:a16="http://schemas.microsoft.com/office/drawing/2014/main" id="{F614AE7A-9B71-4B05-9E25-8BD65D70B30D}"/>
+                <a16:creationId xmlns:a16="http://schemas.microsoft.com/office/drawing/2014/main" id="{26C2C866-55AD-4712-85C4-7C7C284BF047}"/>
               </a:ext>
             </a:extLst>
           </p:cNvPr>
@@ -3620,7 +3620,7 @@
           <p:cNvPr id="5" name="">
             <a:extLst xmlns:a="http://schemas.openxmlformats.org/drawingml/2006/main">
               <a:ext uri="{FF2B5EF4-FFF2-40B4-BE49-F238E27FC236}">
-                <a16:creationId xmlns:a16="http://schemas.microsoft.com/office/drawing/2014/main" id="{3A98E8A4-7E62-44B4-AF8B-BFE24B1664DA}"/>
+                <a16:creationId xmlns:a16="http://schemas.microsoft.com/office/drawing/2014/main" id="{4975FA99-62D7-4CC5-9F94-366720E68772}"/>
               </a:ext>
             </a:extLst>
           </p:cNvPr>
@@ -3684,7 +3684,7 @@
           <p:cNvPr id="6" name="">
             <a:extLst xmlns:a="http://schemas.openxmlformats.org/drawingml/2006/main">
               <a:ext uri="{FF2B5EF4-FFF2-40B4-BE49-F238E27FC236}">
-                <a16:creationId xmlns:a16="http://schemas.microsoft.com/office/drawing/2014/main" id="{097ACC60-D918-4E77-8657-3B13BAE673BC}"/>
+                <a16:creationId xmlns:a16="http://schemas.microsoft.com/office/drawing/2014/main" id="{36F4DA08-8752-425F-ABEC-196E50E35BE8}"/>
               </a:ext>
             </a:extLst>
           </p:cNvPr>
@@ -3748,7 +3748,7 @@
           <p:cNvPr id="7" name="">
             <a:extLst xmlns:a="http://schemas.openxmlformats.org/drawingml/2006/main">
               <a:ext uri="{FF2B5EF4-FFF2-40B4-BE49-F238E27FC236}">
-                <a16:creationId xmlns:a16="http://schemas.microsoft.com/office/drawing/2014/main" id="{C9A6F56A-595D-4F8D-BC55-E346A9F7D409}"/>
+                <a16:creationId xmlns:a16="http://schemas.microsoft.com/office/drawing/2014/main" id="{CE22AF05-E631-4CBD-A6BF-1B57ACF72239}"/>
               </a:ext>
             </a:extLst>
           </p:cNvPr>
@@ -3812,7 +3812,7 @@
           <p:cNvPr id="8" name="">
             <a:extLst xmlns:a="http://schemas.openxmlformats.org/drawingml/2006/main">
               <a:ext uri="{FF2B5EF4-FFF2-40B4-BE49-F238E27FC236}">
-                <a16:creationId xmlns:a16="http://schemas.microsoft.com/office/drawing/2014/main" id="{E0B9A68D-6F0F-4E2C-9495-57F0B2E1C086}"/>
+                <a16:creationId xmlns:a16="http://schemas.microsoft.com/office/drawing/2014/main" id="{39618ED2-62ED-4A55-BD6C-5654E5411E3E}"/>
               </a:ext>
             </a:extLst>
           </p:cNvPr>
@@ -3845,7 +3845,7 @@
           <p:cNvPr id="9" name="">
             <a:extLst xmlns:a="http://schemas.openxmlformats.org/drawingml/2006/main">
               <a:ext uri="{FF2B5EF4-FFF2-40B4-BE49-F238E27FC236}">
-                <a16:creationId xmlns:a16="http://schemas.microsoft.com/office/drawing/2014/main" id="{551BD499-02F3-4559-A967-521C2E48F1F3}"/>
+                <a16:creationId xmlns:a16="http://schemas.microsoft.com/office/drawing/2014/main" id="{0C593BE2-9CE5-446A-BAA8-3D42FB260398}"/>
               </a:ext>
             </a:extLst>
           </p:cNvPr>
@@ -3899,7 +3899,7 @@
                 <a:ea typeface="Aptos"/>
                 <a:cs typeface="Aptos"/>
               </a:rPr>
-              <a:t>a_n(Δ) = nΔ</a:t>
+              <a:t>aₙ(Δ) = nΔ</a:t>
             </a:r>
           </a:p>
         </p:txBody>
@@ -3909,7 +3909,7 @@
           <p:cNvPr id="10" name="">
             <a:extLst xmlns:a="http://schemas.openxmlformats.org/drawingml/2006/main">
               <a:ext uri="{FF2B5EF4-FFF2-40B4-BE49-F238E27FC236}">
-                <a16:creationId xmlns:a16="http://schemas.microsoft.com/office/drawing/2014/main" id="{46EE09EA-B412-4E2B-8830-A6B5B348B2BE}"/>
+                <a16:creationId xmlns:a16="http://schemas.microsoft.com/office/drawing/2014/main" id="{6A5972F0-0850-41A1-BAD6-90F973F5A3F9}"/>
               </a:ext>
             </a:extLst>
           </p:cNvPr>
@@ -3944,7 +3944,7 @@
           <p:cNvPr id="11" name="">
             <a:extLst xmlns:a="http://schemas.openxmlformats.org/drawingml/2006/main">
               <a:ext uri="{FF2B5EF4-FFF2-40B4-BE49-F238E27FC236}">
-                <a16:creationId xmlns:a16="http://schemas.microsoft.com/office/drawing/2014/main" id="{59BC16A1-1ACD-4BB7-841E-3B7A4855BF70}"/>
+                <a16:creationId xmlns:a16="http://schemas.microsoft.com/office/drawing/2014/main" id="{3370560B-B148-4C7C-8813-96BA645BA1C1}"/>
               </a:ext>
             </a:extLst>
           </p:cNvPr>
@@ -3979,7 +3979,7 @@
           <p:cNvPr id="12" name="">
             <a:extLst xmlns:a="http://schemas.openxmlformats.org/drawingml/2006/main">
               <a:ext uri="{FF2B5EF4-FFF2-40B4-BE49-F238E27FC236}">
-                <a16:creationId xmlns:a16="http://schemas.microsoft.com/office/drawing/2014/main" id="{3444C2D1-7476-4B80-8FA3-10F4DCEE8EB8}"/>
+                <a16:creationId xmlns:a16="http://schemas.microsoft.com/office/drawing/2014/main" id="{AA144969-C92F-4053-AB7D-DF4C2211C4B5}"/>
               </a:ext>
             </a:extLst>
           </p:cNvPr>
@@ -4014,7 +4014,7 @@
           <p:cNvPr id="13" name="">
             <a:extLst xmlns:a="http://schemas.openxmlformats.org/drawingml/2006/main">
               <a:ext uri="{FF2B5EF4-FFF2-40B4-BE49-F238E27FC236}">
-                <a16:creationId xmlns:a16="http://schemas.microsoft.com/office/drawing/2014/main" id="{02501763-EA7A-4086-B0DC-E03955302FBC}"/>
+                <a16:creationId xmlns:a16="http://schemas.microsoft.com/office/drawing/2014/main" id="{457C8732-062B-4716-A510-D38DA2CB2AA3}"/>
               </a:ext>
             </a:extLst>
           </p:cNvPr>
@@ -4049,7 +4049,7 @@
           <p:cNvPr id="14" name="">
             <a:extLst xmlns:a="http://schemas.openxmlformats.org/drawingml/2006/main">
               <a:ext uri="{FF2B5EF4-FFF2-40B4-BE49-F238E27FC236}">
-                <a16:creationId xmlns:a16="http://schemas.microsoft.com/office/drawing/2014/main" id="{FA9A51D2-11EB-474E-B088-05F88BB39A11}"/>
+                <a16:creationId xmlns:a16="http://schemas.microsoft.com/office/drawing/2014/main" id="{D99C313D-0FF1-4D4E-A5CA-DA19AC666BB1}"/>
               </a:ext>
             </a:extLst>
           </p:cNvPr>
@@ -4084,7 +4084,7 @@
           <p:cNvPr id="15" name="">
             <a:extLst xmlns:a="http://schemas.openxmlformats.org/drawingml/2006/main">
               <a:ext uri="{FF2B5EF4-FFF2-40B4-BE49-F238E27FC236}">
-                <a16:creationId xmlns:a16="http://schemas.microsoft.com/office/drawing/2014/main" id="{C193E3E6-BB60-4CC2-8C5C-3E8DC9223974}"/>
+                <a16:creationId xmlns:a16="http://schemas.microsoft.com/office/drawing/2014/main" id="{00378B2B-28A2-472F-A403-465201F43127}"/>
               </a:ext>
             </a:extLst>
           </p:cNvPr>
@@ -4117,7 +4117,7 @@
           <p:cNvPr id="16" name="">
             <a:extLst xmlns:a="http://schemas.openxmlformats.org/drawingml/2006/main">
               <a:ext uri="{FF2B5EF4-FFF2-40B4-BE49-F238E27FC236}">
-                <a16:creationId xmlns:a16="http://schemas.microsoft.com/office/drawing/2014/main" id="{2D655E80-2576-4895-A6BD-96BF2BEB9B6A}"/>
+                <a16:creationId xmlns:a16="http://schemas.microsoft.com/office/drawing/2014/main" id="{4CF88F52-F478-41A7-AA9E-AADF9A6486DB}"/>
               </a:ext>
             </a:extLst>
           </p:cNvPr>
@@ -4181,7 +4181,7 @@
           <p:cNvPr id="17" name="">
             <a:extLst xmlns:a="http://schemas.openxmlformats.org/drawingml/2006/main">
               <a:ext uri="{FF2B5EF4-FFF2-40B4-BE49-F238E27FC236}">
-                <a16:creationId xmlns:a16="http://schemas.microsoft.com/office/drawing/2014/main" id="{7DB2AEB9-CF17-40F1-89D3-997280EDC3BF}"/>
+                <a16:creationId xmlns:a16="http://schemas.microsoft.com/office/drawing/2014/main" id="{44C80520-8660-4D82-ADC0-1999908862A2}"/>
               </a:ext>
             </a:extLst>
           </p:cNvPr>
@@ -4214,7 +4214,7 @@
           <p:cNvPr id="18" name="">
             <a:extLst xmlns:a="http://schemas.openxmlformats.org/drawingml/2006/main">
               <a:ext uri="{FF2B5EF4-FFF2-40B4-BE49-F238E27FC236}">
-                <a16:creationId xmlns:a16="http://schemas.microsoft.com/office/drawing/2014/main" id="{49CAECE4-C6DA-4613-8B3D-03ECD9269655}"/>
+                <a16:creationId xmlns:a16="http://schemas.microsoft.com/office/drawing/2014/main" id="{378C646D-5948-4A37-9060-ECD3B4993B40}"/>
               </a:ext>
             </a:extLst>
           </p:cNvPr>
@@ -4278,7 +4278,7 @@
           <p:cNvPr id="19" name="">
             <a:extLst xmlns:a="http://schemas.openxmlformats.org/drawingml/2006/main">
               <a:ext uri="{FF2B5EF4-FFF2-40B4-BE49-F238E27FC236}">
-                <a16:creationId xmlns:a16="http://schemas.microsoft.com/office/drawing/2014/main" id="{4C02A6C0-FF44-4409-90E2-B8B0968C5AFF}"/>
+                <a16:creationId xmlns:a16="http://schemas.microsoft.com/office/drawing/2014/main" id="{8F0B43E9-7A73-406A-9305-CC686A687217}"/>
               </a:ext>
             </a:extLst>
           </p:cNvPr>
@@ -4342,7 +4342,7 @@
           <p:cNvPr id="20" name="">
             <a:extLst xmlns:a="http://schemas.openxmlformats.org/drawingml/2006/main">
               <a:ext uri="{FF2B5EF4-FFF2-40B4-BE49-F238E27FC236}">
-                <a16:creationId xmlns:a16="http://schemas.microsoft.com/office/drawing/2014/main" id="{57E41024-5670-48A8-BF56-52FB3D237068}"/>
+                <a16:creationId xmlns:a16="http://schemas.microsoft.com/office/drawing/2014/main" id="{7989B46B-718D-4249-B841-CF3D94118392}"/>
               </a:ext>
             </a:extLst>
           </p:cNvPr>
@@ -4406,7 +4406,7 @@
           <p:cNvPr id="21" name="">
             <a:extLst xmlns:a="http://schemas.openxmlformats.org/drawingml/2006/main">
               <a:ext uri="{FF2B5EF4-FFF2-40B4-BE49-F238E27FC236}">
-                <a16:creationId xmlns:a16="http://schemas.microsoft.com/office/drawing/2014/main" id="{987750C7-B4AA-4A63-B96A-83E5F7FC859D}"/>
+                <a16:creationId xmlns:a16="http://schemas.microsoft.com/office/drawing/2014/main" id="{D7AB0A31-F57F-4EC7-BC3B-A8D7FB0E332C}"/>
               </a:ext>
             </a:extLst>
           </p:cNvPr>
@@ -4439,7 +4439,7 @@
           <p:cNvPr id="22" name="">
             <a:extLst xmlns:a="http://schemas.openxmlformats.org/drawingml/2006/main">
               <a:ext uri="{FF2B5EF4-FFF2-40B4-BE49-F238E27FC236}">
-                <a16:creationId xmlns:a16="http://schemas.microsoft.com/office/drawing/2014/main" id="{0CF6DC0D-D60E-4DFE-B263-A763A8D6209F}"/>
+                <a16:creationId xmlns:a16="http://schemas.microsoft.com/office/drawing/2014/main" id="{343177A8-CDC9-436D-8179-637969DD54A6}"/>
               </a:ext>
             </a:extLst>
           </p:cNvPr>
@@ -4503,7 +4503,7 @@
           <p:cNvPr id="23" name="">
             <a:extLst xmlns:a="http://schemas.openxmlformats.org/drawingml/2006/main">
               <a:ext uri="{FF2B5EF4-FFF2-40B4-BE49-F238E27FC236}">
-                <a16:creationId xmlns:a16="http://schemas.microsoft.com/office/drawing/2014/main" id="{C8CBD6DC-4D5B-4C20-B9D5-B41E585687B4}"/>
+                <a16:creationId xmlns:a16="http://schemas.microsoft.com/office/drawing/2014/main" id="{CB24BFD4-05F4-4C7E-8957-DFB72523DDA9}"/>
               </a:ext>
             </a:extLst>
           </p:cNvPr>
@@ -4536,7 +4536,7 @@
           <p:cNvPr id="24" name="">
             <a:extLst xmlns:a="http://schemas.openxmlformats.org/drawingml/2006/main">
               <a:ext uri="{FF2B5EF4-FFF2-40B4-BE49-F238E27FC236}">
-                <a16:creationId xmlns:a16="http://schemas.microsoft.com/office/drawing/2014/main" id="{56D65476-7789-4FD1-ACC2-0295BAEF4B6A}"/>
+                <a16:creationId xmlns:a16="http://schemas.microsoft.com/office/drawing/2014/main" id="{DA234BAC-66B1-4D01-BDC5-B9718CC7070B}"/>
               </a:ext>
             </a:extLst>
           </p:cNvPr>
@@ -4600,7 +4600,7 @@
           <p:cNvPr id="25" name="">
             <a:extLst xmlns:a="http://schemas.openxmlformats.org/drawingml/2006/main">
               <a:ext uri="{FF2B5EF4-FFF2-40B4-BE49-F238E27FC236}">
-                <a16:creationId xmlns:a16="http://schemas.microsoft.com/office/drawing/2014/main" id="{E5B1A754-2BD3-49F0-B432-9CF881D2D588}"/>
+                <a16:creationId xmlns:a16="http://schemas.microsoft.com/office/drawing/2014/main" id="{7FE3FCB4-8BB9-4215-8E8B-EFB2820A7C15}"/>
               </a:ext>
             </a:extLst>
           </p:cNvPr>
@@ -4633,7 +4633,7 @@
           <p:cNvPr id="26" name="">
             <a:extLst xmlns:a="http://schemas.openxmlformats.org/drawingml/2006/main">
               <a:ext uri="{FF2B5EF4-FFF2-40B4-BE49-F238E27FC236}">
-                <a16:creationId xmlns:a16="http://schemas.microsoft.com/office/drawing/2014/main" id="{25B584D6-F853-41EB-9A2E-37C09501DDF0}"/>
+                <a16:creationId xmlns:a16="http://schemas.microsoft.com/office/drawing/2014/main" id="{C73B25CF-50A8-4667-B388-757E958A1797}"/>
               </a:ext>
             </a:extLst>
           </p:cNvPr>
@@ -4687,7 +4687,7 @@
                 <a:ea typeface="Hiragino Sans"/>
                 <a:cs typeface="Hiragino Sans"/>
               </a:rPr>
-              <a:t>a_n = 清浄復旧ホライズン</a:t>
+              <a:t>aₙ = 清浄復旧ホライズン</a:t>
             </a:r>
           </a:p>
         </p:txBody>
@@ -4697,7 +4697,7 @@
           <p:cNvPr id="27" name="">
             <a:extLst xmlns:a="http://schemas.openxmlformats.org/drawingml/2006/main">
               <a:ext uri="{FF2B5EF4-FFF2-40B4-BE49-F238E27FC236}">
-                <a16:creationId xmlns:a16="http://schemas.microsoft.com/office/drawing/2014/main" id="{3C9B32EB-D9B4-4B30-8A27-8F9BA5C11A89}"/>
+                <a16:creationId xmlns:a16="http://schemas.microsoft.com/office/drawing/2014/main" id="{5C2EFECC-D2FD-4FD9-A6EF-7E94E87935F3}"/>
               </a:ext>
             </a:extLst>
           </p:cNvPr>
@@ -4730,7 +4730,7 @@
           <p:cNvPr id="28" name="">
             <a:extLst xmlns:a="http://schemas.openxmlformats.org/drawingml/2006/main">
               <a:ext uri="{FF2B5EF4-FFF2-40B4-BE49-F238E27FC236}">
-                <a16:creationId xmlns:a16="http://schemas.microsoft.com/office/drawing/2014/main" id="{5E35D7CB-FBCB-49B9-BC50-E614DA6AA96A}"/>
+                <a16:creationId xmlns:a16="http://schemas.microsoft.com/office/drawing/2014/main" id="{8EC66B4D-89F4-459A-8258-BFCA93C8C837}"/>
               </a:ext>
             </a:extLst>
           </p:cNvPr>
@@ -4784,7 +4784,7 @@
                 <a:ea typeface="Hiragino Sans"/>
                 <a:cs typeface="Hiragino Sans"/>
               </a:rPr>
-              <a:t>評価領域: nΔ &gt; t_m</a:t>
+              <a:t>評価領域: nΔ &gt; tₘ</a:t>
             </a:r>
           </a:p>
         </p:txBody>
@@ -4794,7 +4794,7 @@
           <p:cNvPr id="29" name="">
             <a:extLst xmlns:a="http://schemas.openxmlformats.org/drawingml/2006/main">
               <a:ext uri="{FF2B5EF4-FFF2-40B4-BE49-F238E27FC236}">
-                <a16:creationId xmlns:a16="http://schemas.microsoft.com/office/drawing/2014/main" id="{13B23D51-487E-4A9D-BB86-B36CD63AE777}"/>
+                <a16:creationId xmlns:a16="http://schemas.microsoft.com/office/drawing/2014/main" id="{61BDC64E-7B69-4EFB-A7B6-9E6F76C794A3}"/>
               </a:ext>
             </a:extLst>
           </p:cNvPr>
@@ -4829,7 +4829,7 @@
           <p:cNvPr id="30" name="">
             <a:extLst xmlns:a="http://schemas.openxmlformats.org/drawingml/2006/main">
               <a:ext uri="{FF2B5EF4-FFF2-40B4-BE49-F238E27FC236}">
-                <a16:creationId xmlns:a16="http://schemas.microsoft.com/office/drawing/2014/main" id="{9A88E8F8-8B37-43A9-8EA8-FC53DBC7C595}"/>
+                <a16:creationId xmlns:a16="http://schemas.microsoft.com/office/drawing/2014/main" id="{E15DE1DF-3D7B-4168-B070-9831797F9708}"/>
               </a:ext>
             </a:extLst>
           </p:cNvPr>
@@ -4891,7 +4891,7 @@
     </p:spTree>
     <p:extLst>
       <p:ext uri="{BB962C8B-B14F-4D97-AF65-F5344CB8AC3E}">
-        <p14:creationId xmlns:p14="http://schemas.microsoft.com/office/powerpoint/2010/main" val="724187046"/>
+        <p14:creationId xmlns:p14="http://schemas.microsoft.com/office/powerpoint/2010/main" val="1164252294"/>
       </p:ext>
     </p:extLst>
   </p:cSld>
@@ -4915,7 +4915,7 @@
           <p:cNvPr id="1" name="">
             <a:extLst xmlns:a="http://schemas.openxmlformats.org/drawingml/2006/main">
               <a:ext uri="{FF2B5EF4-FFF2-40B4-BE49-F238E27FC236}">
-                <a16:creationId xmlns:a16="http://schemas.microsoft.com/office/drawing/2014/main" id="{2C17BF67-E3EC-4A6A-8E9E-6E5979317A8A}"/>
+                <a16:creationId xmlns:a16="http://schemas.microsoft.com/office/drawing/2014/main" id="{3C4F26B2-B63B-44DB-9B4A-66721A0EE2D2}"/>
               </a:ext>
             </a:extLst>
           </p:cNvPr>
@@ -4950,7 +4950,7 @@
           <p:cNvPr id="2" name="">
             <a:extLst xmlns:a="http://schemas.openxmlformats.org/drawingml/2006/main">
               <a:ext uri="{FF2B5EF4-FFF2-40B4-BE49-F238E27FC236}">
-                <a16:creationId xmlns:a16="http://schemas.microsoft.com/office/drawing/2014/main" id="{1B09F514-F50A-4306-B404-B67BD4D7A5B7}"/>
+                <a16:creationId xmlns:a16="http://schemas.microsoft.com/office/drawing/2014/main" id="{22849B93-7CAF-4A91-AD5A-0F9971D9602D}"/>
               </a:ext>
             </a:extLst>
           </p:cNvPr>
@@ -4985,7 +4985,7 @@
           <p:cNvPr id="3" name="">
             <a:extLst xmlns:a="http://schemas.openxmlformats.org/drawingml/2006/main">
               <a:ext uri="{FF2B5EF4-FFF2-40B4-BE49-F238E27FC236}">
-                <a16:creationId xmlns:a16="http://schemas.microsoft.com/office/drawing/2014/main" id="{91965F24-5A31-40DA-9C0E-83B67012A631}"/>
+                <a16:creationId xmlns:a16="http://schemas.microsoft.com/office/drawing/2014/main" id="{0D2206F8-E365-4029-A002-7B7A941B6B6B}"/>
               </a:ext>
             </a:extLst>
           </p:cNvPr>
@@ -5049,7 +5049,7 @@
           <p:cNvPr id="4" name="">
             <a:extLst xmlns:a="http://schemas.openxmlformats.org/drawingml/2006/main">
               <a:ext uri="{FF2B5EF4-FFF2-40B4-BE49-F238E27FC236}">
-                <a16:creationId xmlns:a16="http://schemas.microsoft.com/office/drawing/2014/main" id="{1DD0B787-E5D0-473A-8ED9-61706A125665}"/>
+                <a16:creationId xmlns:a16="http://schemas.microsoft.com/office/drawing/2014/main" id="{48B4E38E-E3C5-48F3-9CB7-DB94EBF6E469}"/>
               </a:ext>
             </a:extLst>
           </p:cNvPr>
@@ -5113,7 +5113,7 @@
           <p:cNvPr id="5" name="">
             <a:extLst xmlns:a="http://schemas.openxmlformats.org/drawingml/2006/main">
               <a:ext uri="{FF2B5EF4-FFF2-40B4-BE49-F238E27FC236}">
-                <a16:creationId xmlns:a16="http://schemas.microsoft.com/office/drawing/2014/main" id="{8EB5F09B-F92E-4079-85AE-0BB2DE778C9A}"/>
+                <a16:creationId xmlns:a16="http://schemas.microsoft.com/office/drawing/2014/main" id="{6FCAAC3F-0A2B-483F-95F4-298C2E40A816}"/>
               </a:ext>
             </a:extLst>
           </p:cNvPr>
@@ -5177,7 +5177,7 @@
           <p:cNvPr id="6" name="">
             <a:extLst xmlns:a="http://schemas.openxmlformats.org/drawingml/2006/main">
               <a:ext uri="{FF2B5EF4-FFF2-40B4-BE49-F238E27FC236}">
-                <a16:creationId xmlns:a16="http://schemas.microsoft.com/office/drawing/2014/main" id="{21534393-B252-42B9-A691-DC059AA97C6E}"/>
+                <a16:creationId xmlns:a16="http://schemas.microsoft.com/office/drawing/2014/main" id="{ADB5A8A1-F9BA-42AE-8D50-F60A9BC601EA}"/>
               </a:ext>
             </a:extLst>
           </p:cNvPr>
@@ -5241,7 +5241,7 @@
           <p:cNvPr id="7" name="">
             <a:extLst xmlns:a="http://schemas.openxmlformats.org/drawingml/2006/main">
               <a:ext uri="{FF2B5EF4-FFF2-40B4-BE49-F238E27FC236}">
-                <a16:creationId xmlns:a16="http://schemas.microsoft.com/office/drawing/2014/main" id="{B0C6342F-FF46-43E9-A68E-C961BA937305}"/>
+                <a16:creationId xmlns:a16="http://schemas.microsoft.com/office/drawing/2014/main" id="{84F6135A-176D-42F5-945B-E36926AAA45C}"/>
               </a:ext>
             </a:extLst>
           </p:cNvPr>
@@ -5274,7 +5274,7 @@
           <p:cNvPr id="8" name="">
             <a:extLst xmlns:a="http://schemas.openxmlformats.org/drawingml/2006/main">
               <a:ext uri="{FF2B5EF4-FFF2-40B4-BE49-F238E27FC236}">
-                <a16:creationId xmlns:a16="http://schemas.microsoft.com/office/drawing/2014/main" id="{960F6950-D3A2-40E9-90A5-1BBDF30C0C56}"/>
+                <a16:creationId xmlns:a16="http://schemas.microsoft.com/office/drawing/2014/main" id="{DA33C3B7-CF6E-4A33-A9AE-E9EBCCE1AC72}"/>
               </a:ext>
             </a:extLst>
           </p:cNvPr>
@@ -5338,7 +5338,7 @@
           <p:cNvPr id="9" name="">
             <a:extLst xmlns:a="http://schemas.openxmlformats.org/drawingml/2006/main">
               <a:ext uri="{FF2B5EF4-FFF2-40B4-BE49-F238E27FC236}">
-                <a16:creationId xmlns:a16="http://schemas.microsoft.com/office/drawing/2014/main" id="{7E4B4C52-3E72-47A1-ACC7-5F1E68E79D93}"/>
+                <a16:creationId xmlns:a16="http://schemas.microsoft.com/office/drawing/2014/main" id="{13DDB4EF-C36D-4FCC-AA9E-3174AED479D1}"/>
               </a:ext>
             </a:extLst>
           </p:cNvPr>
@@ -5373,7 +5373,7 @@
           <p:cNvPr id="10" name="">
             <a:extLst xmlns:a="http://schemas.openxmlformats.org/drawingml/2006/main">
               <a:ext uri="{FF2B5EF4-FFF2-40B4-BE49-F238E27FC236}">
-                <a16:creationId xmlns:a16="http://schemas.microsoft.com/office/drawing/2014/main" id="{ACCDDD8C-3340-4E4D-97A6-E5BE9D6F2C10}"/>
+                <a16:creationId xmlns:a16="http://schemas.microsoft.com/office/drawing/2014/main" id="{A82A68D4-E29C-4513-A2C0-EDC9586C9708}"/>
               </a:ext>
             </a:extLst>
           </p:cNvPr>
@@ -5437,7 +5437,7 @@
           <p:cNvPr id="11" name="">
             <a:extLst xmlns:a="http://schemas.openxmlformats.org/drawingml/2006/main">
               <a:ext uri="{FF2B5EF4-FFF2-40B4-BE49-F238E27FC236}">
-                <a16:creationId xmlns:a16="http://schemas.microsoft.com/office/drawing/2014/main" id="{4FB459A6-450C-44AF-B77C-1D0AFC827253}"/>
+                <a16:creationId xmlns:a16="http://schemas.microsoft.com/office/drawing/2014/main" id="{4D007870-A2AA-4659-A0BB-3E1192DD6796}"/>
               </a:ext>
             </a:extLst>
           </p:cNvPr>
@@ -5501,7 +5501,7 @@
           <p:cNvPr id="12" name="">
             <a:extLst xmlns:a="http://schemas.openxmlformats.org/drawingml/2006/main">
               <a:ext uri="{FF2B5EF4-FFF2-40B4-BE49-F238E27FC236}">
-                <a16:creationId xmlns:a16="http://schemas.microsoft.com/office/drawing/2014/main" id="{8EA0A9B6-143A-4DDB-B8E0-DFCF21CA9EC3}"/>
+                <a16:creationId xmlns:a16="http://schemas.microsoft.com/office/drawing/2014/main" id="{814A20B2-C31F-4D92-ABDC-CF6E50B73DA6}"/>
               </a:ext>
             </a:extLst>
           </p:cNvPr>
@@ -5536,7 +5536,7 @@
           <p:cNvPr id="13" name="">
             <a:extLst xmlns:a="http://schemas.openxmlformats.org/drawingml/2006/main">
               <a:ext uri="{FF2B5EF4-FFF2-40B4-BE49-F238E27FC236}">
-                <a16:creationId xmlns:a16="http://schemas.microsoft.com/office/drawing/2014/main" id="{15C010CD-FC9C-467C-8E2A-FFACCD7B8757}"/>
+                <a16:creationId xmlns:a16="http://schemas.microsoft.com/office/drawing/2014/main" id="{E6387DBC-F581-4FD7-A5CF-B379F46733AC}"/>
               </a:ext>
             </a:extLst>
           </p:cNvPr>
@@ -5571,7 +5571,7 @@
           <p:cNvPr id="14" name="">
             <a:extLst xmlns:a="http://schemas.openxmlformats.org/drawingml/2006/main">
               <a:ext uri="{FF2B5EF4-FFF2-40B4-BE49-F238E27FC236}">
-                <a16:creationId xmlns:a16="http://schemas.microsoft.com/office/drawing/2014/main" id="{08AD6D26-F9D2-47CB-889C-04B3C47D17E0}"/>
+                <a16:creationId xmlns:a16="http://schemas.microsoft.com/office/drawing/2014/main" id="{3DEB3713-EB15-4D02-9153-39F1B4F628AA}"/>
               </a:ext>
             </a:extLst>
           </p:cNvPr>
@@ -5606,7 +5606,7 @@
           <p:cNvPr id="15" name="">
             <a:extLst xmlns:a="http://schemas.openxmlformats.org/drawingml/2006/main">
               <a:ext uri="{FF2B5EF4-FFF2-40B4-BE49-F238E27FC236}">
-                <a16:creationId xmlns:a16="http://schemas.microsoft.com/office/drawing/2014/main" id="{28FDA2FA-7A34-4705-89D8-56B2C230C3F9}"/>
+                <a16:creationId xmlns:a16="http://schemas.microsoft.com/office/drawing/2014/main" id="{4FA0D51D-945A-4082-9C69-DE58D6499AD3}"/>
               </a:ext>
             </a:extLst>
           </p:cNvPr>
@@ -5641,7 +5641,7 @@
           <p:cNvPr id="16" name="">
             <a:extLst xmlns:a="http://schemas.openxmlformats.org/drawingml/2006/main">
               <a:ext uri="{FF2B5EF4-FFF2-40B4-BE49-F238E27FC236}">
-                <a16:creationId xmlns:a16="http://schemas.microsoft.com/office/drawing/2014/main" id="{BF0AE9AD-18AB-4198-8AEA-BFB434D5463D}"/>
+                <a16:creationId xmlns:a16="http://schemas.microsoft.com/office/drawing/2014/main" id="{AC8EC1ED-3AC6-4946-9FB2-26E6FDEDCD3A}"/>
               </a:ext>
             </a:extLst>
           </p:cNvPr>
@@ -5676,7 +5676,7 @@
           <p:cNvPr id="17" name="">
             <a:extLst xmlns:a="http://schemas.openxmlformats.org/drawingml/2006/main">
               <a:ext uri="{FF2B5EF4-FFF2-40B4-BE49-F238E27FC236}">
-                <a16:creationId xmlns:a16="http://schemas.microsoft.com/office/drawing/2014/main" id="{6798F4B8-3C62-484A-8538-F9E29CD173EC}"/>
+                <a16:creationId xmlns:a16="http://schemas.microsoft.com/office/drawing/2014/main" id="{EDCA2427-117A-4936-BF0E-198B2618296E}"/>
               </a:ext>
             </a:extLst>
           </p:cNvPr>
@@ -5711,7 +5711,7 @@
           <p:cNvPr id="18" name="">
             <a:extLst xmlns:a="http://schemas.openxmlformats.org/drawingml/2006/main">
               <a:ext uri="{FF2B5EF4-FFF2-40B4-BE49-F238E27FC236}">
-                <a16:creationId xmlns:a16="http://schemas.microsoft.com/office/drawing/2014/main" id="{D544FFEB-96CE-4AF3-813A-521544154425}"/>
+                <a16:creationId xmlns:a16="http://schemas.microsoft.com/office/drawing/2014/main" id="{455855DA-FE51-4E13-82D3-523591663A77}"/>
               </a:ext>
             </a:extLst>
           </p:cNvPr>
@@ -5744,7 +5744,7 @@
           <p:cNvPr id="19" name="">
             <a:extLst xmlns:a="http://schemas.openxmlformats.org/drawingml/2006/main">
               <a:ext uri="{FF2B5EF4-FFF2-40B4-BE49-F238E27FC236}">
-                <a16:creationId xmlns:a16="http://schemas.microsoft.com/office/drawing/2014/main" id="{AC545D6C-8006-43F2-B6AB-669596DD92BB}"/>
+                <a16:creationId xmlns:a16="http://schemas.microsoft.com/office/drawing/2014/main" id="{580A0978-C23E-40F0-A733-40472992ABC3}"/>
               </a:ext>
             </a:extLst>
           </p:cNvPr>
@@ -5808,7 +5808,7 @@
           <p:cNvPr id="20" name="">
             <a:extLst xmlns:a="http://schemas.openxmlformats.org/drawingml/2006/main">
               <a:ext uri="{FF2B5EF4-FFF2-40B4-BE49-F238E27FC236}">
-                <a16:creationId xmlns:a16="http://schemas.microsoft.com/office/drawing/2014/main" id="{883B4E09-EDD1-455A-9976-DF71E46DC2EB}"/>
+                <a16:creationId xmlns:a16="http://schemas.microsoft.com/office/drawing/2014/main" id="{AA31E898-CE18-4CE2-9361-A098B8589FD1}"/>
               </a:ext>
             </a:extLst>
           </p:cNvPr>
@@ -5895,7 +5895,7 @@
           <p:cNvPr id="21" name="">
             <a:extLst xmlns:a="http://schemas.openxmlformats.org/drawingml/2006/main">
               <a:ext uri="{FF2B5EF4-FFF2-40B4-BE49-F238E27FC236}">
-                <a16:creationId xmlns:a16="http://schemas.microsoft.com/office/drawing/2014/main" id="{0E6B34BC-C4B0-4950-943B-E52992D0545B}"/>
+                <a16:creationId xmlns:a16="http://schemas.microsoft.com/office/drawing/2014/main" id="{7B8A59F6-1C71-4284-9994-36DC001075C7}"/>
               </a:ext>
             </a:extLst>
           </p:cNvPr>
@@ -5928,7 +5928,7 @@
           <p:cNvPr id="22" name="">
             <a:extLst xmlns:a="http://schemas.openxmlformats.org/drawingml/2006/main">
               <a:ext uri="{FF2B5EF4-FFF2-40B4-BE49-F238E27FC236}">
-                <a16:creationId xmlns:a16="http://schemas.microsoft.com/office/drawing/2014/main" id="{7F62D9D4-B802-4EDB-B4FC-5CA3BF11E561}"/>
+                <a16:creationId xmlns:a16="http://schemas.microsoft.com/office/drawing/2014/main" id="{7AEB560D-19EC-4A53-B808-D0A2C892B69D}"/>
               </a:ext>
             </a:extLst>
           </p:cNvPr>
@@ -5992,7 +5992,7 @@
           <p:cNvPr id="23" name="">
             <a:extLst xmlns:a="http://schemas.openxmlformats.org/drawingml/2006/main">
               <a:ext uri="{FF2B5EF4-FFF2-40B4-BE49-F238E27FC236}">
-                <a16:creationId xmlns:a16="http://schemas.microsoft.com/office/drawing/2014/main" id="{E6789623-44B9-4ACA-B0F4-C1A966FAB228}"/>
+                <a16:creationId xmlns:a16="http://schemas.microsoft.com/office/drawing/2014/main" id="{6BF4388A-CB5C-4AC7-A74F-55415AE5F491}"/>
               </a:ext>
             </a:extLst>
           </p:cNvPr>
@@ -6027,7 +6027,7 @@
           <p:cNvPr id="24" name="">
             <a:extLst xmlns:a="http://schemas.openxmlformats.org/drawingml/2006/main">
               <a:ext uri="{FF2B5EF4-FFF2-40B4-BE49-F238E27FC236}">
-                <a16:creationId xmlns:a16="http://schemas.microsoft.com/office/drawing/2014/main" id="{245CF8A2-B4AD-4A6C-8C13-3EFD38A84143}"/>
+                <a16:creationId xmlns:a16="http://schemas.microsoft.com/office/drawing/2014/main" id="{E176350A-D01E-48FF-9275-56A7364DA48B}"/>
               </a:ext>
             </a:extLst>
           </p:cNvPr>
@@ -6091,7 +6091,7 @@
           <p:cNvPr id="25" name="">
             <a:extLst xmlns:a="http://schemas.openxmlformats.org/drawingml/2006/main">
               <a:ext uri="{FF2B5EF4-FFF2-40B4-BE49-F238E27FC236}">
-                <a16:creationId xmlns:a16="http://schemas.microsoft.com/office/drawing/2014/main" id="{D39E61C6-9A62-4FE2-89AD-81D43CB786E4}"/>
+                <a16:creationId xmlns:a16="http://schemas.microsoft.com/office/drawing/2014/main" id="{8D459F06-563B-46A6-89FF-C4694B5E12A0}"/>
               </a:ext>
             </a:extLst>
           </p:cNvPr>
@@ -6126,7 +6126,7 @@
           <p:cNvPr id="26" name="">
             <a:extLst xmlns:a="http://schemas.openxmlformats.org/drawingml/2006/main">
               <a:ext uri="{FF2B5EF4-FFF2-40B4-BE49-F238E27FC236}">
-                <a16:creationId xmlns:a16="http://schemas.microsoft.com/office/drawing/2014/main" id="{E858B1F2-0755-4628-BEE7-A0B50E149CF2}"/>
+                <a16:creationId xmlns:a16="http://schemas.microsoft.com/office/drawing/2014/main" id="{11D34B0B-B5B8-4A6C-B9DD-B6CA6B17BC0F}"/>
               </a:ext>
             </a:extLst>
           </p:cNvPr>
@@ -6161,7 +6161,7 @@
           <p:cNvPr id="27" name="">
             <a:extLst xmlns:a="http://schemas.openxmlformats.org/drawingml/2006/main">
               <a:ext uri="{FF2B5EF4-FFF2-40B4-BE49-F238E27FC236}">
-                <a16:creationId xmlns:a16="http://schemas.microsoft.com/office/drawing/2014/main" id="{209D4C00-D364-4923-8BA3-DC0F11BED547}"/>
+                <a16:creationId xmlns:a16="http://schemas.microsoft.com/office/drawing/2014/main" id="{8FA847BE-6FB0-4E8D-9587-9BFDA32300CF}"/>
               </a:ext>
             </a:extLst>
           </p:cNvPr>
@@ -6196,7 +6196,7 @@
           <p:cNvPr id="28" name="">
             <a:extLst xmlns:a="http://schemas.openxmlformats.org/drawingml/2006/main">
               <a:ext uri="{FF2B5EF4-FFF2-40B4-BE49-F238E27FC236}">
-                <a16:creationId xmlns:a16="http://schemas.microsoft.com/office/drawing/2014/main" id="{F561BE0E-FC71-4ECB-B54C-E44E7099A7A5}"/>
+                <a16:creationId xmlns:a16="http://schemas.microsoft.com/office/drawing/2014/main" id="{30C596A2-DC1A-4C0C-BB3E-4DFAE8BEB727}"/>
               </a:ext>
             </a:extLst>
           </p:cNvPr>
@@ -6231,7 +6231,7 @@
           <p:cNvPr id="29" name="">
             <a:extLst xmlns:a="http://schemas.openxmlformats.org/drawingml/2006/main">
               <a:ext uri="{FF2B5EF4-FFF2-40B4-BE49-F238E27FC236}">
-                <a16:creationId xmlns:a16="http://schemas.microsoft.com/office/drawing/2014/main" id="{0667588F-B953-446E-97D6-A2277738C760}"/>
+                <a16:creationId xmlns:a16="http://schemas.microsoft.com/office/drawing/2014/main" id="{91458108-0E5A-41B8-94DD-EC95FB6CECB6}"/>
               </a:ext>
             </a:extLst>
           </p:cNvPr>
@@ -6266,7 +6266,7 @@
           <p:cNvPr id="30" name="">
             <a:extLst xmlns:a="http://schemas.openxmlformats.org/drawingml/2006/main">
               <a:ext uri="{FF2B5EF4-FFF2-40B4-BE49-F238E27FC236}">
-                <a16:creationId xmlns:a16="http://schemas.microsoft.com/office/drawing/2014/main" id="{E4673B11-0765-4D6E-856B-51499E917509}"/>
+                <a16:creationId xmlns:a16="http://schemas.microsoft.com/office/drawing/2014/main" id="{54052F8F-D2C1-4D76-AB0E-849289D4783C}"/>
               </a:ext>
             </a:extLst>
           </p:cNvPr>
@@ -6301,7 +6301,7 @@
           <p:cNvPr id="31" name="">
             <a:extLst xmlns:a="http://schemas.openxmlformats.org/drawingml/2006/main">
               <a:ext uri="{FF2B5EF4-FFF2-40B4-BE49-F238E27FC236}">
-                <a16:creationId xmlns:a16="http://schemas.microsoft.com/office/drawing/2014/main" id="{4009D7AD-513C-4AAD-92C9-CCE18241113E}"/>
+                <a16:creationId xmlns:a16="http://schemas.microsoft.com/office/drawing/2014/main" id="{3061117D-D37A-42F0-932E-5F95DC2C76BA}"/>
               </a:ext>
             </a:extLst>
           </p:cNvPr>
@@ -6336,7 +6336,7 @@
           <p:cNvPr id="32" name="">
             <a:extLst xmlns:a="http://schemas.openxmlformats.org/drawingml/2006/main">
               <a:ext uri="{FF2B5EF4-FFF2-40B4-BE49-F238E27FC236}">
-                <a16:creationId xmlns:a16="http://schemas.microsoft.com/office/drawing/2014/main" id="{18DB9DE1-6374-4A9F-B533-AEEBB206AF3A}"/>
+                <a16:creationId xmlns:a16="http://schemas.microsoft.com/office/drawing/2014/main" id="{CC3A4CBC-F83B-4685-8CB2-6CA299474D71}"/>
               </a:ext>
             </a:extLst>
           </p:cNvPr>
@@ -6371,7 +6371,7 @@
           <p:cNvPr id="33" name="">
             <a:extLst xmlns:a="http://schemas.openxmlformats.org/drawingml/2006/main">
               <a:ext uri="{FF2B5EF4-FFF2-40B4-BE49-F238E27FC236}">
-                <a16:creationId xmlns:a16="http://schemas.microsoft.com/office/drawing/2014/main" id="{ACC1093E-B575-4DA8-868B-6F0A720FAFCF}"/>
+                <a16:creationId xmlns:a16="http://schemas.microsoft.com/office/drawing/2014/main" id="{EFB76F32-ED78-4CF2-B24E-15C6676ABC94}"/>
               </a:ext>
             </a:extLst>
           </p:cNvPr>
@@ -6406,7 +6406,7 @@
           <p:cNvPr id="34" name="">
             <a:extLst xmlns:a="http://schemas.openxmlformats.org/drawingml/2006/main">
               <a:ext uri="{FF2B5EF4-FFF2-40B4-BE49-F238E27FC236}">
-                <a16:creationId xmlns:a16="http://schemas.microsoft.com/office/drawing/2014/main" id="{956EED11-245A-4588-9308-AD2C3771CA0C}"/>
+                <a16:creationId xmlns:a16="http://schemas.microsoft.com/office/drawing/2014/main" id="{068EE2E7-E392-416B-929C-34AE53861604}"/>
               </a:ext>
             </a:extLst>
           </p:cNvPr>
@@ -6439,7 +6439,7 @@
           <p:cNvPr id="35" name="">
             <a:extLst xmlns:a="http://schemas.openxmlformats.org/drawingml/2006/main">
               <a:ext uri="{FF2B5EF4-FFF2-40B4-BE49-F238E27FC236}">
-                <a16:creationId xmlns:a16="http://schemas.microsoft.com/office/drawing/2014/main" id="{8B87302D-1717-4FA5-A444-D25C72DFE2CC}"/>
+                <a16:creationId xmlns:a16="http://schemas.microsoft.com/office/drawing/2014/main" id="{7EDCA87A-124B-4FEC-BA81-552721BB13CE}"/>
               </a:ext>
             </a:extLst>
           </p:cNvPr>
@@ -6503,7 +6503,7 @@
           <p:cNvPr id="36" name="">
             <a:extLst xmlns:a="http://schemas.openxmlformats.org/drawingml/2006/main">
               <a:ext uri="{FF2B5EF4-FFF2-40B4-BE49-F238E27FC236}">
-                <a16:creationId xmlns:a16="http://schemas.microsoft.com/office/drawing/2014/main" id="{E7DA6937-7B2D-4412-82BE-3C0B04A4B886}"/>
+                <a16:creationId xmlns:a16="http://schemas.microsoft.com/office/drawing/2014/main" id="{9DF2DE45-65CC-448E-BA24-6BE965E58023}"/>
               </a:ext>
             </a:extLst>
           </p:cNvPr>
@@ -6590,7 +6590,7 @@
           <p:cNvPr id="37" name="">
             <a:extLst xmlns:a="http://schemas.openxmlformats.org/drawingml/2006/main">
               <a:ext uri="{FF2B5EF4-FFF2-40B4-BE49-F238E27FC236}">
-                <a16:creationId xmlns:a16="http://schemas.microsoft.com/office/drawing/2014/main" id="{4EBF0271-0D2F-4954-9C56-40EBC305A579}"/>
+                <a16:creationId xmlns:a16="http://schemas.microsoft.com/office/drawing/2014/main" id="{D8BB58B6-E750-4D07-8C68-8BA8BD42DADA}"/>
               </a:ext>
             </a:extLst>
           </p:cNvPr>
@@ -6644,7 +6644,7 @@
                 <a:ea typeface="Hiragino Sans"/>
                 <a:cs typeface="Hiragino Sans"/>
               </a:rPr>
-              <a:t>平均が同じに見えても、少数の長期潜伏が保持窓を超える</a:t>
+              <a:t>典型例が短く見えても、少数の長期潜伏が保持窓を超える</a:t>
             </a:r>
           </a:p>
         </p:txBody>
@@ -6654,7 +6654,7 @@
           <p:cNvPr id="38" name="">
             <a:extLst xmlns:a="http://schemas.openxmlformats.org/drawingml/2006/main">
               <a:ext uri="{FF2B5EF4-FFF2-40B4-BE49-F238E27FC236}">
-                <a16:creationId xmlns:a16="http://schemas.microsoft.com/office/drawing/2014/main" id="{4910DD1D-FD9D-4FD6-9266-634786C4AEEE}"/>
+                <a16:creationId xmlns:a16="http://schemas.microsoft.com/office/drawing/2014/main" id="{5BEC6E52-0624-4E43-9B02-55E7A06F7B25}"/>
               </a:ext>
             </a:extLst>
           </p:cNvPr>
@@ -6689,7 +6689,7 @@
           <p:cNvPr id="39" name="">
             <a:extLst xmlns:a="http://schemas.openxmlformats.org/drawingml/2006/main">
               <a:ext uri="{FF2B5EF4-FFF2-40B4-BE49-F238E27FC236}">
-                <a16:creationId xmlns:a16="http://schemas.microsoft.com/office/drawing/2014/main" id="{F5B76013-7743-44C2-82E3-B9A51A804756}"/>
+                <a16:creationId xmlns:a16="http://schemas.microsoft.com/office/drawing/2014/main" id="{E5F21599-CF29-4EFF-8FEB-7C599BB8AB5F}"/>
               </a:ext>
             </a:extLst>
           </p:cNvPr>
@@ -6751,7 +6751,7 @@
     </p:spTree>
     <p:extLst>
       <p:ext uri="{BB962C8B-B14F-4D97-AF65-F5344CB8AC3E}">
-        <p14:creationId xmlns:p14="http://schemas.microsoft.com/office/powerpoint/2010/main" val="747501902"/>
+        <p14:creationId xmlns:p14="http://schemas.microsoft.com/office/powerpoint/2010/main" val="1773364478"/>
       </p:ext>
     </p:extLst>
   </p:cSld>
@@ -6775,7 +6775,7 @@
           <p:cNvPr id="1" name="">
             <a:extLst xmlns:a="http://schemas.openxmlformats.org/drawingml/2006/main">
               <a:ext uri="{FF2B5EF4-FFF2-40B4-BE49-F238E27FC236}">
-                <a16:creationId xmlns:a16="http://schemas.microsoft.com/office/drawing/2014/main" id="{43BF1624-D557-4CF8-9D0C-8B6483D92706}"/>
+                <a16:creationId xmlns:a16="http://schemas.microsoft.com/office/drawing/2014/main" id="{CCB00377-80B9-4E48-B1B8-8C22F55180FA}"/>
               </a:ext>
             </a:extLst>
           </p:cNvPr>
@@ -6810,7 +6810,7 @@
           <p:cNvPr id="2" name="">
             <a:extLst xmlns:a="http://schemas.openxmlformats.org/drawingml/2006/main">
               <a:ext uri="{FF2B5EF4-FFF2-40B4-BE49-F238E27FC236}">
-                <a16:creationId xmlns:a16="http://schemas.microsoft.com/office/drawing/2014/main" id="{1769F3C7-7B97-4B97-A95D-2BF4282A3E24}"/>
+                <a16:creationId xmlns:a16="http://schemas.microsoft.com/office/drawing/2014/main" id="{3FA38B96-A8E9-4416-89A9-318807712E37}"/>
               </a:ext>
             </a:extLst>
           </p:cNvPr>
@@ -6845,7 +6845,7 @@
           <p:cNvPr id="3" name="">
             <a:extLst xmlns:a="http://schemas.openxmlformats.org/drawingml/2006/main">
               <a:ext uri="{FF2B5EF4-FFF2-40B4-BE49-F238E27FC236}">
-                <a16:creationId xmlns:a16="http://schemas.microsoft.com/office/drawing/2014/main" id="{68CB5B6C-E97B-42A8-BBF0-FC049875D7A2}"/>
+                <a16:creationId xmlns:a16="http://schemas.microsoft.com/office/drawing/2014/main" id="{A22AD0A9-F3F1-4013-BCA4-9BF95E86C710}"/>
               </a:ext>
             </a:extLst>
           </p:cNvPr>
@@ -6909,7 +6909,7 @@
           <p:cNvPr id="4" name="">
             <a:extLst xmlns:a="http://schemas.openxmlformats.org/drawingml/2006/main">
               <a:ext uri="{FF2B5EF4-FFF2-40B4-BE49-F238E27FC236}">
-                <a16:creationId xmlns:a16="http://schemas.microsoft.com/office/drawing/2014/main" id="{95BD6FF2-1948-41DC-927A-C70C9D2E1F7F}"/>
+                <a16:creationId xmlns:a16="http://schemas.microsoft.com/office/drawing/2014/main" id="{CDADEC0B-F2F0-4B3F-B60B-FA2C2DD59EFF}"/>
               </a:ext>
             </a:extLst>
           </p:cNvPr>
@@ -6973,7 +6973,7 @@
           <p:cNvPr id="5" name="">
             <a:extLst xmlns:a="http://schemas.openxmlformats.org/drawingml/2006/main">
               <a:ext uri="{FF2B5EF4-FFF2-40B4-BE49-F238E27FC236}">
-                <a16:creationId xmlns:a16="http://schemas.microsoft.com/office/drawing/2014/main" id="{F13FE4F6-36C1-4F05-83F9-950BD72CF8FE}"/>
+                <a16:creationId xmlns:a16="http://schemas.microsoft.com/office/drawing/2014/main" id="{5691A5C8-D9B3-450F-8498-BAB019C1DA59}"/>
               </a:ext>
             </a:extLst>
           </p:cNvPr>
@@ -7027,7 +7027,7 @@
                 <a:ea typeface="Hiragino Sans"/>
                 <a:cs typeface="Hiragino Sans"/>
               </a:rPr>
-              <a:t>まず決めるのは、何日前まで安全に戻れるべきか</a:t>
+              <a:t>まず決めるのは、何日前まで清浄に戻れるべきか</a:t>
             </a:r>
           </a:p>
         </p:txBody>
@@ -7037,7 +7037,7 @@
           <p:cNvPr id="6" name="">
             <a:extLst xmlns:a="http://schemas.openxmlformats.org/drawingml/2006/main">
               <a:ext uri="{FF2B5EF4-FFF2-40B4-BE49-F238E27FC236}">
-                <a16:creationId xmlns:a16="http://schemas.microsoft.com/office/drawing/2014/main" id="{85CA3367-29FC-4ECF-992C-562332850811}"/>
+                <a16:creationId xmlns:a16="http://schemas.microsoft.com/office/drawing/2014/main" id="{6BDEE40A-16B5-4EE7-89F4-ACAF0AA59C50}"/>
               </a:ext>
             </a:extLst>
           </p:cNvPr>
@@ -7101,7 +7101,7 @@
           <p:cNvPr id="7" name="">
             <a:extLst xmlns:a="http://schemas.openxmlformats.org/drawingml/2006/main">
               <a:ext uri="{FF2B5EF4-FFF2-40B4-BE49-F238E27FC236}">
-                <a16:creationId xmlns:a16="http://schemas.microsoft.com/office/drawing/2014/main" id="{67E68543-0671-46D4-9FA4-F8319127B5B9}"/>
+                <a16:creationId xmlns:a16="http://schemas.microsoft.com/office/drawing/2014/main" id="{DB973498-A7A5-454A-A3F4-97BA21BAF3AC}"/>
               </a:ext>
             </a:extLst>
           </p:cNvPr>
@@ -7134,7 +7134,7 @@
           <p:cNvPr id="8" name="">
             <a:extLst xmlns:a="http://schemas.openxmlformats.org/drawingml/2006/main">
               <a:ext uri="{FF2B5EF4-FFF2-40B4-BE49-F238E27FC236}">
-                <a16:creationId xmlns:a16="http://schemas.microsoft.com/office/drawing/2014/main" id="{DBE34DC2-9836-4F3A-B5EE-7FA04BEBBAAC}"/>
+                <a16:creationId xmlns:a16="http://schemas.microsoft.com/office/drawing/2014/main" id="{71B316AF-E7EE-423C-9040-2D2FD9AF6BDB}"/>
               </a:ext>
             </a:extLst>
           </p:cNvPr>
@@ -7198,7 +7198,7 @@
           <p:cNvPr id="9" name="">
             <a:extLst xmlns:a="http://schemas.openxmlformats.org/drawingml/2006/main">
               <a:ext uri="{FF2B5EF4-FFF2-40B4-BE49-F238E27FC236}">
-                <a16:creationId xmlns:a16="http://schemas.microsoft.com/office/drawing/2014/main" id="{3E916685-6140-4264-9D14-05FD15D34E55}"/>
+                <a16:creationId xmlns:a16="http://schemas.microsoft.com/office/drawing/2014/main" id="{8995824B-4066-4B6E-A0E0-F6079846A52B}"/>
               </a:ext>
             </a:extLst>
           </p:cNvPr>
@@ -7262,7 +7262,7 @@
           <p:cNvPr id="10" name="">
             <a:extLst xmlns:a="http://schemas.openxmlformats.org/drawingml/2006/main">
               <a:ext uri="{FF2B5EF4-FFF2-40B4-BE49-F238E27FC236}">
-                <a16:creationId xmlns:a16="http://schemas.microsoft.com/office/drawing/2014/main" id="{129AFFC7-F19F-44CA-9772-1363A5532D52}"/>
+                <a16:creationId xmlns:a16="http://schemas.microsoft.com/office/drawing/2014/main" id="{2A7BEB54-200F-4B2D-AAE2-C16EF5C7464D}"/>
               </a:ext>
             </a:extLst>
           </p:cNvPr>
@@ -7326,7 +7326,7 @@
           <p:cNvPr id="11" name="">
             <a:extLst xmlns:a="http://schemas.openxmlformats.org/drawingml/2006/main">
               <a:ext uri="{FF2B5EF4-FFF2-40B4-BE49-F238E27FC236}">
-                <a16:creationId xmlns:a16="http://schemas.microsoft.com/office/drawing/2014/main" id="{E08A2280-62C1-46A3-9B48-7D38CD9316DD}"/>
+                <a16:creationId xmlns:a16="http://schemas.microsoft.com/office/drawing/2014/main" id="{26774185-0C43-493A-8D92-8A75C89CE2D3}"/>
               </a:ext>
             </a:extLst>
           </p:cNvPr>
@@ -7359,7 +7359,7 @@
           <p:cNvPr id="12" name="">
             <a:extLst xmlns:a="http://schemas.openxmlformats.org/drawingml/2006/main">
               <a:ext uri="{FF2B5EF4-FFF2-40B4-BE49-F238E27FC236}">
-                <a16:creationId xmlns:a16="http://schemas.microsoft.com/office/drawing/2014/main" id="{D8E7410B-DF9C-4332-99F3-B52F85B04886}"/>
+                <a16:creationId xmlns:a16="http://schemas.microsoft.com/office/drawing/2014/main" id="{4B83E618-0505-4158-A95F-ADDB8605BE86}"/>
               </a:ext>
             </a:extLst>
           </p:cNvPr>
@@ -7423,7 +7423,7 @@
           <p:cNvPr id="13" name="">
             <a:extLst xmlns:a="http://schemas.openxmlformats.org/drawingml/2006/main">
               <a:ext uri="{FF2B5EF4-FFF2-40B4-BE49-F238E27FC236}">
-                <a16:creationId xmlns:a16="http://schemas.microsoft.com/office/drawing/2014/main" id="{92D571DB-2CA6-46C8-8AAF-5DEACDAF3C01}"/>
+                <a16:creationId xmlns:a16="http://schemas.microsoft.com/office/drawing/2014/main" id="{01EB471B-7D98-4837-BD9D-1676BFF431F1}"/>
               </a:ext>
             </a:extLst>
           </p:cNvPr>
@@ -7456,7 +7456,7 @@
           <p:cNvPr id="14" name="">
             <a:extLst xmlns:a="http://schemas.openxmlformats.org/drawingml/2006/main">
               <a:ext uri="{FF2B5EF4-FFF2-40B4-BE49-F238E27FC236}">
-                <a16:creationId xmlns:a16="http://schemas.microsoft.com/office/drawing/2014/main" id="{750CCD2A-0BCC-416E-9666-2C5BA6649100}"/>
+                <a16:creationId xmlns:a16="http://schemas.microsoft.com/office/drawing/2014/main" id="{79C79667-061C-4D0D-97B5-BA36D085E2E6}"/>
               </a:ext>
             </a:extLst>
           </p:cNvPr>
@@ -7520,7 +7520,7 @@
           <p:cNvPr id="15" name="">
             <a:extLst xmlns:a="http://schemas.openxmlformats.org/drawingml/2006/main">
               <a:ext uri="{FF2B5EF4-FFF2-40B4-BE49-F238E27FC236}">
-                <a16:creationId xmlns:a16="http://schemas.microsoft.com/office/drawing/2014/main" id="{B738FA88-278C-4821-8CD7-6CB456D6BB92}"/>
+                <a16:creationId xmlns:a16="http://schemas.microsoft.com/office/drawing/2014/main" id="{ED574B86-7ACE-465B-9AD7-02876D808F5C}"/>
               </a:ext>
             </a:extLst>
           </p:cNvPr>
@@ -7553,7 +7553,7 @@
           <p:cNvPr id="16" name="">
             <a:extLst xmlns:a="http://schemas.openxmlformats.org/drawingml/2006/main">
               <a:ext uri="{FF2B5EF4-FFF2-40B4-BE49-F238E27FC236}">
-                <a16:creationId xmlns:a16="http://schemas.microsoft.com/office/drawing/2014/main" id="{D7FB006E-2065-4A65-8F9B-5D8B34A6B932}"/>
+                <a16:creationId xmlns:a16="http://schemas.microsoft.com/office/drawing/2014/main" id="{E92F38DD-EA04-43A4-BBF5-794AE0D97525}"/>
               </a:ext>
             </a:extLst>
           </p:cNvPr>
@@ -7617,7 +7617,7 @@
           <p:cNvPr id="17" name="">
             <a:extLst xmlns:a="http://schemas.openxmlformats.org/drawingml/2006/main">
               <a:ext uri="{FF2B5EF4-FFF2-40B4-BE49-F238E27FC236}">
-                <a16:creationId xmlns:a16="http://schemas.microsoft.com/office/drawing/2014/main" id="{E84AA3EB-A218-474C-9058-7DF701CF431A}"/>
+                <a16:creationId xmlns:a16="http://schemas.microsoft.com/office/drawing/2014/main" id="{18B59D26-CFBD-4EC2-994E-67ADC4A198FB}"/>
               </a:ext>
             </a:extLst>
           </p:cNvPr>
@@ -7650,7 +7650,7 @@
           <p:cNvPr id="18" name="">
             <a:extLst xmlns:a="http://schemas.openxmlformats.org/drawingml/2006/main">
               <a:ext uri="{FF2B5EF4-FFF2-40B4-BE49-F238E27FC236}">
-                <a16:creationId xmlns:a16="http://schemas.microsoft.com/office/drawing/2014/main" id="{6AB2B9A5-B644-4003-B040-924EC6630EFC}"/>
+                <a16:creationId xmlns:a16="http://schemas.microsoft.com/office/drawing/2014/main" id="{E45E4182-1B1B-4CF2-8555-F36B7A9E4479}"/>
               </a:ext>
             </a:extLst>
           </p:cNvPr>
@@ -7714,18 +7714,18 @@
           <p:cNvPr id="19" name="">
             <a:extLst xmlns:a="http://schemas.openxmlformats.org/drawingml/2006/main">
               <a:ext uri="{FF2B5EF4-FFF2-40B4-BE49-F238E27FC236}">
-                <a16:creationId xmlns:a16="http://schemas.microsoft.com/office/drawing/2014/main" id="{6069CF03-00D1-4837-A7B3-380EC49C1DF4}"/>
-              </a:ext>
-            </a:extLst>
-          </p:cNvPr>
-          <p:cNvSpPr>
-            <a:spLocks xmlns:a="http://schemas.openxmlformats.org/drawingml/2006/main" noGrp="1"/>
-          </p:cNvSpPr>
-          <p:nvPr/>
-        </p:nvSpPr>
-        <p:spPr>
-          <a:xfrm xmlns:a="http://schemas.openxmlformats.org/drawingml/2006/main">
-            <a:off x="7562850" y="3333750"/>
+                <a16:creationId xmlns:a16="http://schemas.microsoft.com/office/drawing/2014/main" id="{D83B32C8-1ECA-4DA4-B506-2D29587E19F3}"/>
+              </a:ext>
+            </a:extLst>
+          </p:cNvPr>
+          <p:cNvSpPr>
+            <a:spLocks xmlns:a="http://schemas.openxmlformats.org/drawingml/2006/main" noGrp="1"/>
+          </p:cNvSpPr>
+          <p:nvPr/>
+        </p:nvSpPr>
+        <p:spPr>
+          <a:xfrm xmlns:a="http://schemas.openxmlformats.org/drawingml/2006/main">
+            <a:off x="7562850" y="3352800"/>
             <a:ext cx="85725" cy="85725"/>
           </a:xfrm>
           <a:prstGeom xmlns:a="http://schemas.openxmlformats.org/drawingml/2006/main" prst="ellipse">
@@ -7749,18 +7749,18 @@
           <p:cNvPr id="20" name="">
             <a:extLst xmlns:a="http://schemas.openxmlformats.org/drawingml/2006/main">
               <a:ext uri="{FF2B5EF4-FFF2-40B4-BE49-F238E27FC236}">
-                <a16:creationId xmlns:a16="http://schemas.microsoft.com/office/drawing/2014/main" id="{8D5D697C-8105-400C-BE45-C9621889636A}"/>
-              </a:ext>
-            </a:extLst>
-          </p:cNvPr>
-          <p:cNvSpPr>
-            <a:spLocks xmlns:a="http://schemas.openxmlformats.org/drawingml/2006/main" noGrp="1"/>
-          </p:cNvSpPr>
-          <p:nvPr/>
-        </p:nvSpPr>
-        <p:spPr>
-          <a:xfrm xmlns:a="http://schemas.openxmlformats.org/drawingml/2006/main">
-            <a:off x="7772400" y="3257550"/>
+                <a16:creationId xmlns:a16="http://schemas.microsoft.com/office/drawing/2014/main" id="{10144200-1BA5-4054-92AC-EAF7BD632FB5}"/>
+              </a:ext>
+            </a:extLst>
+          </p:cNvPr>
+          <p:cNvSpPr>
+            <a:spLocks xmlns:a="http://schemas.openxmlformats.org/drawingml/2006/main" noGrp="1"/>
+          </p:cNvSpPr>
+          <p:nvPr/>
+        </p:nvSpPr>
+        <p:spPr>
+          <a:xfrm xmlns:a="http://schemas.openxmlformats.org/drawingml/2006/main">
+            <a:off x="7772400" y="3276600"/>
             <a:ext cx="2781300" cy="552450"/>
           </a:xfrm>
           <a:prstGeom xmlns:a="http://schemas.openxmlformats.org/drawingml/2006/main" prst="rect">
@@ -7803,7 +7803,7 @@
                 <a:ea typeface="Hiragino Sans"/>
                 <a:cs typeface="Hiragino Sans"/>
               </a:rPr>
-              <a:t>全損と通常復旧の損失差が大きいほど、古い清浄点を残す</a:t>
+              <a:t>損失差が大きいほど、古い清浄点を残す</a:t>
             </a:r>
           </a:p>
         </p:txBody>
@@ -7813,18 +7813,18 @@
           <p:cNvPr id="21" name="">
             <a:extLst xmlns:a="http://schemas.openxmlformats.org/drawingml/2006/main">
               <a:ext uri="{FF2B5EF4-FFF2-40B4-BE49-F238E27FC236}">
-                <a16:creationId xmlns:a16="http://schemas.microsoft.com/office/drawing/2014/main" id="{7AF1412A-585F-4FA8-AE0F-6F5BFD23AC0B}"/>
-              </a:ext>
-            </a:extLst>
-          </p:cNvPr>
-          <p:cNvSpPr>
-            <a:spLocks xmlns:a="http://schemas.openxmlformats.org/drawingml/2006/main" noGrp="1"/>
-          </p:cNvSpPr>
-          <p:nvPr/>
-        </p:nvSpPr>
-        <p:spPr>
-          <a:xfrm xmlns:a="http://schemas.openxmlformats.org/drawingml/2006/main">
-            <a:off x="7562850" y="4057650"/>
+                <a16:creationId xmlns:a16="http://schemas.microsoft.com/office/drawing/2014/main" id="{F383031E-184B-4503-8E66-1F1FB5B23C13}"/>
+              </a:ext>
+            </a:extLst>
+          </p:cNvPr>
+          <p:cNvSpPr>
+            <a:spLocks xmlns:a="http://schemas.openxmlformats.org/drawingml/2006/main" noGrp="1"/>
+          </p:cNvSpPr>
+          <p:nvPr/>
+        </p:nvSpPr>
+        <p:spPr>
+          <a:xfrm xmlns:a="http://schemas.openxmlformats.org/drawingml/2006/main">
+            <a:off x="7562850" y="4038600"/>
             <a:ext cx="85725" cy="85725"/>
           </a:xfrm>
           <a:prstGeom xmlns:a="http://schemas.openxmlformats.org/drawingml/2006/main" prst="ellipse">
@@ -7848,18 +7848,18 @@
           <p:cNvPr id="22" name="">
             <a:extLst xmlns:a="http://schemas.openxmlformats.org/drawingml/2006/main">
               <a:ext uri="{FF2B5EF4-FFF2-40B4-BE49-F238E27FC236}">
-                <a16:creationId xmlns:a16="http://schemas.microsoft.com/office/drawing/2014/main" id="{ADCEF33C-62C0-489E-A3F4-A05E66A615B8}"/>
-              </a:ext>
-            </a:extLst>
-          </p:cNvPr>
-          <p:cNvSpPr>
-            <a:spLocks xmlns:a="http://schemas.openxmlformats.org/drawingml/2006/main" noGrp="1"/>
-          </p:cNvSpPr>
-          <p:nvPr/>
-        </p:nvSpPr>
-        <p:spPr>
-          <a:xfrm xmlns:a="http://schemas.openxmlformats.org/drawingml/2006/main">
-            <a:off x="7772400" y="3981450"/>
+                <a16:creationId xmlns:a16="http://schemas.microsoft.com/office/drawing/2014/main" id="{191F4728-F299-4DCB-8CF7-18CB9FD9E5A6}"/>
+              </a:ext>
+            </a:extLst>
+          </p:cNvPr>
+          <p:cNvSpPr>
+            <a:spLocks xmlns:a="http://schemas.openxmlformats.org/drawingml/2006/main" noGrp="1"/>
+          </p:cNvSpPr>
+          <p:nvPr/>
+        </p:nvSpPr>
+        <p:spPr>
+          <a:xfrm xmlns:a="http://schemas.openxmlformats.org/drawingml/2006/main">
+            <a:off x="7772400" y="3962400"/>
             <a:ext cx="2781300" cy="552450"/>
           </a:xfrm>
           <a:prstGeom xmlns:a="http://schemas.openxmlformats.org/drawingml/2006/main" prst="rect">
@@ -7902,7 +7902,7 @@
                 <a:ea typeface="Hiragino Sans"/>
                 <a:cs typeface="Hiragino Sans"/>
               </a:rPr>
-              <a:t>τ_R と d₀ は、復旧できても残る損失</a:t>
+              <a:t>τ_R と d₀ は、復旧後も残る損失</a:t>
             </a:r>
           </a:p>
         </p:txBody>
@@ -7912,18 +7912,18 @@
           <p:cNvPr id="23" name="">
             <a:extLst xmlns:a="http://schemas.openxmlformats.org/drawingml/2006/main">
               <a:ext uri="{FF2B5EF4-FFF2-40B4-BE49-F238E27FC236}">
-                <a16:creationId xmlns:a16="http://schemas.microsoft.com/office/drawing/2014/main" id="{56F42DE1-EA17-4E6E-841C-8A1911141018}"/>
-              </a:ext>
-            </a:extLst>
-          </p:cNvPr>
-          <p:cNvSpPr>
-            <a:spLocks xmlns:a="http://schemas.openxmlformats.org/drawingml/2006/main" noGrp="1"/>
-          </p:cNvSpPr>
-          <p:nvPr/>
-        </p:nvSpPr>
-        <p:spPr>
-          <a:xfrm xmlns:a="http://schemas.openxmlformats.org/drawingml/2006/main">
-            <a:off x="7562850" y="4705350"/>
+                <a16:creationId xmlns:a16="http://schemas.microsoft.com/office/drawing/2014/main" id="{412D4697-E13C-43DD-9410-3B37B8785B57}"/>
+              </a:ext>
+            </a:extLst>
+          </p:cNvPr>
+          <p:cNvSpPr>
+            <a:spLocks xmlns:a="http://schemas.openxmlformats.org/drawingml/2006/main" noGrp="1"/>
+          </p:cNvSpPr>
+          <p:nvPr/>
+        </p:nvSpPr>
+        <p:spPr>
+          <a:xfrm xmlns:a="http://schemas.openxmlformats.org/drawingml/2006/main">
+            <a:off x="7562850" y="4667250"/>
             <a:ext cx="85725" cy="85725"/>
           </a:xfrm>
           <a:prstGeom xmlns:a="http://schemas.openxmlformats.org/drawingml/2006/main" prst="ellipse">
@@ -7947,18 +7947,18 @@
           <p:cNvPr id="24" name="">
             <a:extLst xmlns:a="http://schemas.openxmlformats.org/drawingml/2006/main">
               <a:ext uri="{FF2B5EF4-FFF2-40B4-BE49-F238E27FC236}">
-                <a16:creationId xmlns:a16="http://schemas.microsoft.com/office/drawing/2014/main" id="{8462CB51-602D-4689-8E72-1B10240A52D9}"/>
-              </a:ext>
-            </a:extLst>
-          </p:cNvPr>
-          <p:cNvSpPr>
-            <a:spLocks xmlns:a="http://schemas.openxmlformats.org/drawingml/2006/main" noGrp="1"/>
-          </p:cNvSpPr>
-          <p:nvPr/>
-        </p:nvSpPr>
-        <p:spPr>
-          <a:xfrm xmlns:a="http://schemas.openxmlformats.org/drawingml/2006/main">
-            <a:off x="7772400" y="4629150"/>
+                <a16:creationId xmlns:a16="http://schemas.microsoft.com/office/drawing/2014/main" id="{EAC33E15-447D-484A-BB2E-540B0E5C17A5}"/>
+              </a:ext>
+            </a:extLst>
+          </p:cNvPr>
+          <p:cNvSpPr>
+            <a:spLocks xmlns:a="http://schemas.openxmlformats.org/drawingml/2006/main" noGrp="1"/>
+          </p:cNvSpPr>
+          <p:nvPr/>
+        </p:nvSpPr>
+        <p:spPr>
+          <a:xfrm xmlns:a="http://schemas.openxmlformats.org/drawingml/2006/main">
+            <a:off x="7772400" y="4591050"/>
             <a:ext cx="2781300" cy="552450"/>
           </a:xfrm>
           <a:prstGeom xmlns:a="http://schemas.openxmlformats.org/drawingml/2006/main" prst="rect">
@@ -8011,7 +8011,7 @@
           <p:cNvPr id="25" name="">
             <a:extLst xmlns:a="http://schemas.openxmlformats.org/drawingml/2006/main">
               <a:ext uri="{FF2B5EF4-FFF2-40B4-BE49-F238E27FC236}">
-                <a16:creationId xmlns:a16="http://schemas.microsoft.com/office/drawing/2014/main" id="{7802AB60-1C67-4FBF-BA7F-2833577A22C8}"/>
+                <a16:creationId xmlns:a16="http://schemas.microsoft.com/office/drawing/2014/main" id="{9271E4D9-A292-4C49-80F6-59B44F47EC7C}"/>
               </a:ext>
             </a:extLst>
           </p:cNvPr>
@@ -8046,7 +8046,7 @@
           <p:cNvPr id="26" name="">
             <a:extLst xmlns:a="http://schemas.openxmlformats.org/drawingml/2006/main">
               <a:ext uri="{FF2B5EF4-FFF2-40B4-BE49-F238E27FC236}">
-                <a16:creationId xmlns:a16="http://schemas.microsoft.com/office/drawing/2014/main" id="{DB3142F8-BA00-48E0-9DB7-25313114E328}"/>
+                <a16:creationId xmlns:a16="http://schemas.microsoft.com/office/drawing/2014/main" id="{EC3AC651-97E7-4ABD-A385-2621640D18EE}"/>
               </a:ext>
             </a:extLst>
           </p:cNvPr>
@@ -8110,7 +8110,7 @@
           <p:cNvPr id="27" name="">
             <a:extLst xmlns:a="http://schemas.openxmlformats.org/drawingml/2006/main">
               <a:ext uri="{FF2B5EF4-FFF2-40B4-BE49-F238E27FC236}">
-                <a16:creationId xmlns:a16="http://schemas.microsoft.com/office/drawing/2014/main" id="{6A6AE20C-3071-408E-A726-00F7E795DAD8}"/>
+                <a16:creationId xmlns:a16="http://schemas.microsoft.com/office/drawing/2014/main" id="{A19226F5-DA6C-4912-90ED-A4A46FC0A687}"/>
               </a:ext>
             </a:extLst>
           </p:cNvPr>
@@ -8145,7 +8145,7 @@
           <p:cNvPr id="28" name="">
             <a:extLst xmlns:a="http://schemas.openxmlformats.org/drawingml/2006/main">
               <a:ext uri="{FF2B5EF4-FFF2-40B4-BE49-F238E27FC236}">
-                <a16:creationId xmlns:a16="http://schemas.microsoft.com/office/drawing/2014/main" id="{4F2B7221-FB6F-4D2C-A31A-8DDE172925D9}"/>
+                <a16:creationId xmlns:a16="http://schemas.microsoft.com/office/drawing/2014/main" id="{F39CB40F-AE64-4E65-A4BE-6F7A0B16043B}"/>
               </a:ext>
             </a:extLst>
           </p:cNvPr>
@@ -8207,7 +8207,7 @@
     </p:spTree>
     <p:extLst>
       <p:ext uri="{BB962C8B-B14F-4D97-AF65-F5344CB8AC3E}">
-        <p14:creationId xmlns:p14="http://schemas.microsoft.com/office/powerpoint/2010/main" val="2113407475"/>
+        <p14:creationId xmlns:p14="http://schemas.microsoft.com/office/powerpoint/2010/main" val="417110375"/>
       </p:ext>
     </p:extLst>
   </p:cSld>
@@ -8231,7 +8231,7 @@
           <p:cNvPr id="1" name="">
             <a:extLst xmlns:a="http://schemas.openxmlformats.org/drawingml/2006/main">
               <a:ext uri="{FF2B5EF4-FFF2-40B4-BE49-F238E27FC236}">
-                <a16:creationId xmlns:a16="http://schemas.microsoft.com/office/drawing/2014/main" id="{DB6E4760-75D5-46BB-ACB2-99F0665A03D4}"/>
+                <a16:creationId xmlns:a16="http://schemas.microsoft.com/office/drawing/2014/main" id="{50D83A32-37B4-48B8-A3C8-F1E87E024F32}"/>
               </a:ext>
             </a:extLst>
           </p:cNvPr>
@@ -8266,7 +8266,7 @@
           <p:cNvPr id="2" name="">
             <a:extLst xmlns:a="http://schemas.openxmlformats.org/drawingml/2006/main">
               <a:ext uri="{FF2B5EF4-FFF2-40B4-BE49-F238E27FC236}">
-                <a16:creationId xmlns:a16="http://schemas.microsoft.com/office/drawing/2014/main" id="{748808DE-BCC2-4AF8-9F08-CC45561D2C9B}"/>
+                <a16:creationId xmlns:a16="http://schemas.microsoft.com/office/drawing/2014/main" id="{E16E7417-C4E5-4461-A2D0-EC565803529F}"/>
               </a:ext>
             </a:extLst>
           </p:cNvPr>
@@ -8301,7 +8301,7 @@
           <p:cNvPr id="3" name="">
             <a:extLst xmlns:a="http://schemas.openxmlformats.org/drawingml/2006/main">
               <a:ext uri="{FF2B5EF4-FFF2-40B4-BE49-F238E27FC236}">
-                <a16:creationId xmlns:a16="http://schemas.microsoft.com/office/drawing/2014/main" id="{A63FD632-5B25-43B5-A539-AEA86AEFB1D2}"/>
+                <a16:creationId xmlns:a16="http://schemas.microsoft.com/office/drawing/2014/main" id="{7D57AE44-FEE9-4EFB-99A7-4AA2AE4214A3}"/>
               </a:ext>
             </a:extLst>
           </p:cNvPr>
@@ -8365,7 +8365,7 @@
           <p:cNvPr id="4" name="">
             <a:extLst xmlns:a="http://schemas.openxmlformats.org/drawingml/2006/main">
               <a:ext uri="{FF2B5EF4-FFF2-40B4-BE49-F238E27FC236}">
-                <a16:creationId xmlns:a16="http://schemas.microsoft.com/office/drawing/2014/main" id="{AEC63420-8125-402C-99AC-68DF8808FDD4}"/>
+                <a16:creationId xmlns:a16="http://schemas.microsoft.com/office/drawing/2014/main" id="{0C533A60-C11C-4ED0-868A-25C0D0FC08A0}"/>
               </a:ext>
             </a:extLst>
           </p:cNvPr>
@@ -8429,7 +8429,7 @@
           <p:cNvPr id="5" name="">
             <a:extLst xmlns:a="http://schemas.openxmlformats.org/drawingml/2006/main">
               <a:ext uri="{FF2B5EF4-FFF2-40B4-BE49-F238E27FC236}">
-                <a16:creationId xmlns:a16="http://schemas.microsoft.com/office/drawing/2014/main" id="{379B20C8-4403-4D1D-AF2C-6D9023E537C5}"/>
+                <a16:creationId xmlns:a16="http://schemas.microsoft.com/office/drawing/2014/main" id="{D3868195-E6A4-45E0-932B-906F8F8ACF99}"/>
               </a:ext>
             </a:extLst>
           </p:cNvPr>
@@ -8493,7 +8493,7 @@
           <p:cNvPr id="6" name="">
             <a:extLst xmlns:a="http://schemas.openxmlformats.org/drawingml/2006/main">
               <a:ext uri="{FF2B5EF4-FFF2-40B4-BE49-F238E27FC236}">
-                <a16:creationId xmlns:a16="http://schemas.microsoft.com/office/drawing/2014/main" id="{776C58A6-856D-4F43-86F6-828ECF537A81}"/>
+                <a16:creationId xmlns:a16="http://schemas.microsoft.com/office/drawing/2014/main" id="{12D64E0B-506A-4442-96A3-F40F3C399CC0}"/>
               </a:ext>
             </a:extLst>
           </p:cNvPr>
@@ -8557,7 +8557,7 @@
           <p:cNvPr id="7" name="">
             <a:extLst xmlns:a="http://schemas.openxmlformats.org/drawingml/2006/main">
               <a:ext uri="{FF2B5EF4-FFF2-40B4-BE49-F238E27FC236}">
-                <a16:creationId xmlns:a16="http://schemas.microsoft.com/office/drawing/2014/main" id="{D0AA84AC-CC63-4765-BD9D-4994D83809FF}"/>
+                <a16:creationId xmlns:a16="http://schemas.microsoft.com/office/drawing/2014/main" id="{499B3B4B-917F-4B9F-BAC7-E7660F59DDA1}"/>
               </a:ext>
             </a:extLst>
           </p:cNvPr>
@@ -8590,7 +8590,7 @@
           <p:cNvPr id="8" name="">
             <a:extLst xmlns:a="http://schemas.openxmlformats.org/drawingml/2006/main">
               <a:ext uri="{FF2B5EF4-FFF2-40B4-BE49-F238E27FC236}">
-                <a16:creationId xmlns:a16="http://schemas.microsoft.com/office/drawing/2014/main" id="{EE4621A9-DB97-43D0-A0CB-C186B0B0A269}"/>
+                <a16:creationId xmlns:a16="http://schemas.microsoft.com/office/drawing/2014/main" id="{F9EFDCEE-5A7A-45DE-AA0F-55C96E4E158E}"/>
               </a:ext>
             </a:extLst>
           </p:cNvPr>
@@ -8625,7 +8625,7 @@
           <p:cNvPr id="9" name="">
             <a:extLst xmlns:a="http://schemas.openxmlformats.org/drawingml/2006/main">
               <a:ext uri="{FF2B5EF4-FFF2-40B4-BE49-F238E27FC236}">
-                <a16:creationId xmlns:a16="http://schemas.microsoft.com/office/drawing/2014/main" id="{CFB3EDB4-61E5-4B8E-A20B-D50C20FEF9C1}"/>
+                <a16:creationId xmlns:a16="http://schemas.microsoft.com/office/drawing/2014/main" id="{25F9DEF3-95AC-4AF0-8630-4E7B9FAF329A}"/>
               </a:ext>
             </a:extLst>
           </p:cNvPr>
@@ -8689,7 +8689,7 @@
           <p:cNvPr id="10" name="">
             <a:extLst xmlns:a="http://schemas.openxmlformats.org/drawingml/2006/main">
               <a:ext uri="{FF2B5EF4-FFF2-40B4-BE49-F238E27FC236}">
-                <a16:creationId xmlns:a16="http://schemas.microsoft.com/office/drawing/2014/main" id="{5808D82F-E2D6-4872-BAE1-377A1C5C6FE7}"/>
+                <a16:creationId xmlns:a16="http://schemas.microsoft.com/office/drawing/2014/main" id="{BB7B4D27-45D3-41C5-B442-D7630BF9EF24}"/>
               </a:ext>
             </a:extLst>
           </p:cNvPr>
@@ -8753,7 +8753,7 @@
           <p:cNvPr id="11" name="">
             <a:extLst xmlns:a="http://schemas.openxmlformats.org/drawingml/2006/main">
               <a:ext uri="{FF2B5EF4-FFF2-40B4-BE49-F238E27FC236}">
-                <a16:creationId xmlns:a16="http://schemas.microsoft.com/office/drawing/2014/main" id="{73AB3D0C-8633-491F-8D1A-7A4F664D0036}"/>
+                <a16:creationId xmlns:a16="http://schemas.microsoft.com/office/drawing/2014/main" id="{09A4BA22-59DC-437A-B371-F00964E446B3}"/>
               </a:ext>
             </a:extLst>
           </p:cNvPr>
@@ -8817,7 +8817,7 @@
           <p:cNvPr id="12" name="">
             <a:extLst xmlns:a="http://schemas.openxmlformats.org/drawingml/2006/main">
               <a:ext uri="{FF2B5EF4-FFF2-40B4-BE49-F238E27FC236}">
-                <a16:creationId xmlns:a16="http://schemas.microsoft.com/office/drawing/2014/main" id="{A6658EE3-7172-4ECE-BD65-2584253C797D}"/>
+                <a16:creationId xmlns:a16="http://schemas.microsoft.com/office/drawing/2014/main" id="{4A2B30CF-9DEB-4835-AD35-6C9239BD12A0}"/>
               </a:ext>
             </a:extLst>
           </p:cNvPr>
@@ -8881,7 +8881,7 @@
           <p:cNvPr id="13" name="">
             <a:extLst xmlns:a="http://schemas.openxmlformats.org/drawingml/2006/main">
               <a:ext uri="{FF2B5EF4-FFF2-40B4-BE49-F238E27FC236}">
-                <a16:creationId xmlns:a16="http://schemas.microsoft.com/office/drawing/2014/main" id="{459992B6-2889-49A4-83A9-B6DD3E0D4413}"/>
+                <a16:creationId xmlns:a16="http://schemas.microsoft.com/office/drawing/2014/main" id="{4803FAB5-0749-457A-9B76-542FCDDC2DDD}"/>
               </a:ext>
             </a:extLst>
           </p:cNvPr>
@@ -8914,7 +8914,7 @@
           <p:cNvPr id="14" name="">
             <a:extLst xmlns:a="http://schemas.openxmlformats.org/drawingml/2006/main">
               <a:ext uri="{FF2B5EF4-FFF2-40B4-BE49-F238E27FC236}">
-                <a16:creationId xmlns:a16="http://schemas.microsoft.com/office/drawing/2014/main" id="{535F6223-F458-40D1-BFB9-052E78A3B134}"/>
+                <a16:creationId xmlns:a16="http://schemas.microsoft.com/office/drawing/2014/main" id="{53C82D9C-C8B6-4EBA-BCF2-9C4B5A0C0794}"/>
               </a:ext>
             </a:extLst>
           </p:cNvPr>
@@ -8949,7 +8949,7 @@
           <p:cNvPr id="15" name="">
             <a:extLst xmlns:a="http://schemas.openxmlformats.org/drawingml/2006/main">
               <a:ext uri="{FF2B5EF4-FFF2-40B4-BE49-F238E27FC236}">
-                <a16:creationId xmlns:a16="http://schemas.microsoft.com/office/drawing/2014/main" id="{C45164A1-52BB-4CAD-9742-97935C71E56E}"/>
+                <a16:creationId xmlns:a16="http://schemas.microsoft.com/office/drawing/2014/main" id="{FC9F8D25-134E-4B7E-8897-959E9FC21319}"/>
               </a:ext>
             </a:extLst>
           </p:cNvPr>
@@ -9013,7 +9013,7 @@
           <p:cNvPr id="16" name="">
             <a:extLst xmlns:a="http://schemas.openxmlformats.org/drawingml/2006/main">
               <a:ext uri="{FF2B5EF4-FFF2-40B4-BE49-F238E27FC236}">
-                <a16:creationId xmlns:a16="http://schemas.microsoft.com/office/drawing/2014/main" id="{FC57A320-20EE-41B9-B13E-111300FE370B}"/>
+                <a16:creationId xmlns:a16="http://schemas.microsoft.com/office/drawing/2014/main" id="{BEC12ECD-FEB5-48C9-9B39-CD0AE9831EF6}"/>
               </a:ext>
             </a:extLst>
           </p:cNvPr>
@@ -9077,7 +9077,7 @@
           <p:cNvPr id="17" name="">
             <a:extLst xmlns:a="http://schemas.openxmlformats.org/drawingml/2006/main">
               <a:ext uri="{FF2B5EF4-FFF2-40B4-BE49-F238E27FC236}">
-                <a16:creationId xmlns:a16="http://schemas.microsoft.com/office/drawing/2014/main" id="{91A87515-301B-44E4-9222-7C81104B490E}"/>
+                <a16:creationId xmlns:a16="http://schemas.microsoft.com/office/drawing/2014/main" id="{5577721A-8279-4598-8D19-295A12D3F896}"/>
               </a:ext>
             </a:extLst>
           </p:cNvPr>
@@ -9141,7 +9141,7 @@
           <p:cNvPr id="18" name="">
             <a:extLst xmlns:a="http://schemas.openxmlformats.org/drawingml/2006/main">
               <a:ext uri="{FF2B5EF4-FFF2-40B4-BE49-F238E27FC236}">
-                <a16:creationId xmlns:a16="http://schemas.microsoft.com/office/drawing/2014/main" id="{73B2ABE0-3453-4728-940B-BB2074AA4E21}"/>
+                <a16:creationId xmlns:a16="http://schemas.microsoft.com/office/drawing/2014/main" id="{E5281CA9-9D0C-4C5C-8189-7C22E05588AA}"/>
               </a:ext>
             </a:extLst>
           </p:cNvPr>
@@ -9205,7 +9205,7 @@
           <p:cNvPr id="19" name="">
             <a:extLst xmlns:a="http://schemas.openxmlformats.org/drawingml/2006/main">
               <a:ext uri="{FF2B5EF4-FFF2-40B4-BE49-F238E27FC236}">
-                <a16:creationId xmlns:a16="http://schemas.microsoft.com/office/drawing/2014/main" id="{30547829-AA1B-4B65-B860-596CEC2DBEE4}"/>
+                <a16:creationId xmlns:a16="http://schemas.microsoft.com/office/drawing/2014/main" id="{A6480E18-AA3F-49F0-981B-789E74A1F64B}"/>
               </a:ext>
             </a:extLst>
           </p:cNvPr>
@@ -9238,7 +9238,7 @@
           <p:cNvPr id="20" name="">
             <a:extLst xmlns:a="http://schemas.openxmlformats.org/drawingml/2006/main">
               <a:ext uri="{FF2B5EF4-FFF2-40B4-BE49-F238E27FC236}">
-                <a16:creationId xmlns:a16="http://schemas.microsoft.com/office/drawing/2014/main" id="{5F877CA6-CDFC-4F41-BC71-B6A5709DB552}"/>
+                <a16:creationId xmlns:a16="http://schemas.microsoft.com/office/drawing/2014/main" id="{744D298F-14A3-43CA-890B-7361EF587972}"/>
               </a:ext>
             </a:extLst>
           </p:cNvPr>
@@ -9273,7 +9273,7 @@
           <p:cNvPr id="21" name="">
             <a:extLst xmlns:a="http://schemas.openxmlformats.org/drawingml/2006/main">
               <a:ext uri="{FF2B5EF4-FFF2-40B4-BE49-F238E27FC236}">
-                <a16:creationId xmlns:a16="http://schemas.microsoft.com/office/drawing/2014/main" id="{776F0835-1020-435B-AA7A-FB58262E40C9}"/>
+                <a16:creationId xmlns:a16="http://schemas.microsoft.com/office/drawing/2014/main" id="{004BA40F-0C4F-4D6E-8BD3-69650C4E9601}"/>
               </a:ext>
             </a:extLst>
           </p:cNvPr>
@@ -9337,7 +9337,7 @@
           <p:cNvPr id="22" name="">
             <a:extLst xmlns:a="http://schemas.openxmlformats.org/drawingml/2006/main">
               <a:ext uri="{FF2B5EF4-FFF2-40B4-BE49-F238E27FC236}">
-                <a16:creationId xmlns:a16="http://schemas.microsoft.com/office/drawing/2014/main" id="{FE347540-D35F-4916-8DE8-5B9CF3FF49E4}"/>
+                <a16:creationId xmlns:a16="http://schemas.microsoft.com/office/drawing/2014/main" id="{79D44E98-FB11-4B03-83B8-530DB3A6ED61}"/>
               </a:ext>
             </a:extLst>
           </p:cNvPr>
@@ -9401,7 +9401,7 @@
           <p:cNvPr id="23" name="">
             <a:extLst xmlns:a="http://schemas.openxmlformats.org/drawingml/2006/main">
               <a:ext uri="{FF2B5EF4-FFF2-40B4-BE49-F238E27FC236}">
-                <a16:creationId xmlns:a16="http://schemas.microsoft.com/office/drawing/2014/main" id="{424773F1-2CD4-4C9D-9BAE-379ACD5C2886}"/>
+                <a16:creationId xmlns:a16="http://schemas.microsoft.com/office/drawing/2014/main" id="{2A70EF07-F7EE-4CE5-AC02-5ADCC068AB4C}"/>
               </a:ext>
             </a:extLst>
           </p:cNvPr>
@@ -9455,7 +9455,7 @@
                 <a:ea typeface="Hiragino Sans"/>
                 <a:cs typeface="Hiragino Sans"/>
               </a:rPr>
-              <a:t>検知遅れ・潜伏分布が a* を超えないかを見る</a:t>
+              <a:t>検知時点の感染後経過時間が a* を超えないかを見る</a:t>
             </a:r>
           </a:p>
         </p:txBody>
@@ -9465,7 +9465,7 @@
           <p:cNvPr id="24" name="">
             <a:extLst xmlns:a="http://schemas.openxmlformats.org/drawingml/2006/main">
               <a:ext uri="{FF2B5EF4-FFF2-40B4-BE49-F238E27FC236}">
-                <a16:creationId xmlns:a16="http://schemas.microsoft.com/office/drawing/2014/main" id="{81F0180E-D0B3-453B-837D-64FD7BED0B0E}"/>
+                <a16:creationId xmlns:a16="http://schemas.microsoft.com/office/drawing/2014/main" id="{7AF5E713-8FB0-4AF5-B490-635EAE5ACA36}"/>
               </a:ext>
             </a:extLst>
           </p:cNvPr>
@@ -9529,7 +9529,7 @@
           <p:cNvPr id="25" name="">
             <a:extLst xmlns:a="http://schemas.openxmlformats.org/drawingml/2006/main">
               <a:ext uri="{FF2B5EF4-FFF2-40B4-BE49-F238E27FC236}">
-                <a16:creationId xmlns:a16="http://schemas.microsoft.com/office/drawing/2014/main" id="{C145EAA5-513A-46C5-BA55-41C7A236C827}"/>
+                <a16:creationId xmlns:a16="http://schemas.microsoft.com/office/drawing/2014/main" id="{C7D799B3-F2F4-4C92-A927-2F6853FE4F48}"/>
               </a:ext>
             </a:extLst>
           </p:cNvPr>
@@ -9562,7 +9562,7 @@
           <p:cNvPr id="26" name="">
             <a:extLst xmlns:a="http://schemas.openxmlformats.org/drawingml/2006/main">
               <a:ext uri="{FF2B5EF4-FFF2-40B4-BE49-F238E27FC236}">
-                <a16:creationId xmlns:a16="http://schemas.microsoft.com/office/drawing/2014/main" id="{86BA4A98-BA6D-42C2-AE15-B556E229F62E}"/>
+                <a16:creationId xmlns:a16="http://schemas.microsoft.com/office/drawing/2014/main" id="{6E538AB4-3AC1-48F1-993A-2C7007C94EB0}"/>
               </a:ext>
             </a:extLst>
           </p:cNvPr>
@@ -9597,7 +9597,7 @@
           <p:cNvPr id="27" name="">
             <a:extLst xmlns:a="http://schemas.openxmlformats.org/drawingml/2006/main">
               <a:ext uri="{FF2B5EF4-FFF2-40B4-BE49-F238E27FC236}">
-                <a16:creationId xmlns:a16="http://schemas.microsoft.com/office/drawing/2014/main" id="{C0F2568C-7EF7-499D-AFE6-27F745496F39}"/>
+                <a16:creationId xmlns:a16="http://schemas.microsoft.com/office/drawing/2014/main" id="{99D14F37-DEE9-47BE-AB7D-1FF6A565CDEA}"/>
               </a:ext>
             </a:extLst>
           </p:cNvPr>
@@ -9661,7 +9661,7 @@
           <p:cNvPr id="28" name="">
             <a:extLst xmlns:a="http://schemas.openxmlformats.org/drawingml/2006/main">
               <a:ext uri="{FF2B5EF4-FFF2-40B4-BE49-F238E27FC236}">
-                <a16:creationId xmlns:a16="http://schemas.microsoft.com/office/drawing/2014/main" id="{A871D0EF-9A96-42D4-B4DE-88D7A0C3AE21}"/>
+                <a16:creationId xmlns:a16="http://schemas.microsoft.com/office/drawing/2014/main" id="{F35A93E4-F55D-45B7-9262-628FCDA05D50}"/>
               </a:ext>
             </a:extLst>
           </p:cNvPr>
@@ -9725,7 +9725,7 @@
           <p:cNvPr id="29" name="">
             <a:extLst xmlns:a="http://schemas.openxmlformats.org/drawingml/2006/main">
               <a:ext uri="{FF2B5EF4-FFF2-40B4-BE49-F238E27FC236}">
-                <a16:creationId xmlns:a16="http://schemas.microsoft.com/office/drawing/2014/main" id="{BE186E50-4946-4A3E-9B22-0AC10E63BFB6}"/>
+                <a16:creationId xmlns:a16="http://schemas.microsoft.com/office/drawing/2014/main" id="{034111D3-CC10-4ECD-8561-7F0E7C816CF0}"/>
               </a:ext>
             </a:extLst>
           </p:cNvPr>
@@ -9789,7 +9789,7 @@
           <p:cNvPr id="30" name="">
             <a:extLst xmlns:a="http://schemas.openxmlformats.org/drawingml/2006/main">
               <a:ext uri="{FF2B5EF4-FFF2-40B4-BE49-F238E27FC236}">
-                <a16:creationId xmlns:a16="http://schemas.microsoft.com/office/drawing/2014/main" id="{11DC000B-0EC4-4401-877E-B938F1361A44}"/>
+                <a16:creationId xmlns:a16="http://schemas.microsoft.com/office/drawing/2014/main" id="{EB3BA01E-E000-4DD7-A81E-9E52A6E31692}"/>
               </a:ext>
             </a:extLst>
           </p:cNvPr>
@@ -9822,7 +9822,7 @@
           <p:cNvPr id="31" name="">
             <a:extLst xmlns:a="http://schemas.openxmlformats.org/drawingml/2006/main">
               <a:ext uri="{FF2B5EF4-FFF2-40B4-BE49-F238E27FC236}">
-                <a16:creationId xmlns:a16="http://schemas.microsoft.com/office/drawing/2014/main" id="{3C9A9BD2-25EB-46BD-8F6F-9CE983AD9A57}"/>
+                <a16:creationId xmlns:a16="http://schemas.microsoft.com/office/drawing/2014/main" id="{4374FF03-1893-4A07-9478-2D44D47ED05E}"/>
               </a:ext>
             </a:extLst>
           </p:cNvPr>
@@ -9886,7 +9886,7 @@
           <p:cNvPr id="32" name="">
             <a:extLst xmlns:a="http://schemas.openxmlformats.org/drawingml/2006/main">
               <a:ext uri="{FF2B5EF4-FFF2-40B4-BE49-F238E27FC236}">
-                <a16:creationId xmlns:a16="http://schemas.microsoft.com/office/drawing/2014/main" id="{05E2BCA1-101B-47E0-8079-2ACE54B33291}"/>
+                <a16:creationId xmlns:a16="http://schemas.microsoft.com/office/drawing/2014/main" id="{EF551A5D-B3D6-4190-825E-94F92161EF46}"/>
               </a:ext>
             </a:extLst>
           </p:cNvPr>
@@ -9919,7 +9919,7 @@
           <p:cNvPr id="33" name="">
             <a:extLst xmlns:a="http://schemas.openxmlformats.org/drawingml/2006/main">
               <a:ext uri="{FF2B5EF4-FFF2-40B4-BE49-F238E27FC236}">
-                <a16:creationId xmlns:a16="http://schemas.microsoft.com/office/drawing/2014/main" id="{40E12F23-F9C4-4C4D-96FA-C005E6053030}"/>
+                <a16:creationId xmlns:a16="http://schemas.microsoft.com/office/drawing/2014/main" id="{F3FCBA4D-5CC4-4429-9299-11205BB06EFB}"/>
               </a:ext>
             </a:extLst>
           </p:cNvPr>
@@ -9983,7 +9983,7 @@
           <p:cNvPr id="34" name="">
             <a:extLst xmlns:a="http://schemas.openxmlformats.org/drawingml/2006/main">
               <a:ext uri="{FF2B5EF4-FFF2-40B4-BE49-F238E27FC236}">
-                <a16:creationId xmlns:a16="http://schemas.microsoft.com/office/drawing/2014/main" id="{54A836B2-82C4-4A69-B3C0-817B201513D0}"/>
+                <a16:creationId xmlns:a16="http://schemas.microsoft.com/office/drawing/2014/main" id="{E0F81EB6-1FE6-4F3B-888A-4B6DFA326CE3}"/>
               </a:ext>
             </a:extLst>
           </p:cNvPr>
@@ -10016,7 +10016,7 @@
           <p:cNvPr id="35" name="">
             <a:extLst xmlns:a="http://schemas.openxmlformats.org/drawingml/2006/main">
               <a:ext uri="{FF2B5EF4-FFF2-40B4-BE49-F238E27FC236}">
-                <a16:creationId xmlns:a16="http://schemas.microsoft.com/office/drawing/2014/main" id="{F3608AC9-FEA0-4E93-B3C4-9F19328A8E45}"/>
+                <a16:creationId xmlns:a16="http://schemas.microsoft.com/office/drawing/2014/main" id="{95D620C1-792F-414B-BE8A-6C7C0C1F2224}"/>
               </a:ext>
             </a:extLst>
           </p:cNvPr>
@@ -10080,7 +10080,7 @@
           <p:cNvPr id="36" name="">
             <a:extLst xmlns:a="http://schemas.openxmlformats.org/drawingml/2006/main">
               <a:ext uri="{FF2B5EF4-FFF2-40B4-BE49-F238E27FC236}">
-                <a16:creationId xmlns:a16="http://schemas.microsoft.com/office/drawing/2014/main" id="{DF62B556-CC83-45BD-8233-E7621D61D43A}"/>
+                <a16:creationId xmlns:a16="http://schemas.microsoft.com/office/drawing/2014/main" id="{9B8C8352-5B37-48C2-A38C-4B7FBCE0DEFB}"/>
               </a:ext>
             </a:extLst>
           </p:cNvPr>
@@ -10144,7 +10144,7 @@
           <p:cNvPr id="37" name="">
             <a:extLst xmlns:a="http://schemas.openxmlformats.org/drawingml/2006/main">
               <a:ext uri="{FF2B5EF4-FFF2-40B4-BE49-F238E27FC236}">
-                <a16:creationId xmlns:a16="http://schemas.microsoft.com/office/drawing/2014/main" id="{F97433E7-1814-4D03-BCE5-A111CACCE7F8}"/>
+                <a16:creationId xmlns:a16="http://schemas.microsoft.com/office/drawing/2014/main" id="{2D0C04E2-2CCA-45A6-B765-F739C063B564}"/>
               </a:ext>
             </a:extLst>
           </p:cNvPr>
@@ -10179,7 +10179,7 @@
           <p:cNvPr id="38" name="">
             <a:extLst xmlns:a="http://schemas.openxmlformats.org/drawingml/2006/main">
               <a:ext uri="{FF2B5EF4-FFF2-40B4-BE49-F238E27FC236}">
-                <a16:creationId xmlns:a16="http://schemas.microsoft.com/office/drawing/2014/main" id="{A0C6823C-D8EF-4453-A8E7-BA92557ACBDD}"/>
+                <a16:creationId xmlns:a16="http://schemas.microsoft.com/office/drawing/2014/main" id="{2C0E16EB-0526-48DC-95D9-33D46531405E}"/>
               </a:ext>
             </a:extLst>
           </p:cNvPr>
@@ -10241,7 +10241,7 @@
     </p:spTree>
     <p:extLst>
       <p:ext uri="{BB962C8B-B14F-4D97-AF65-F5344CB8AC3E}">
-        <p14:creationId xmlns:p14="http://schemas.microsoft.com/office/powerpoint/2010/main" val="2042610000"/>
+        <p14:creationId xmlns:p14="http://schemas.microsoft.com/office/powerpoint/2010/main" val="1462916172"/>
       </p:ext>
     </p:extLst>
   </p:cSld>

</xml_diff>

<commit_message>
Address zero-base presentation review round 3
</commit_message>
<xml_diff>
--- a/paper/presentations/heavy_tail_backup_intro/heavy_tail_backup_intro.pptx
+++ b/paper/presentations/heavy_tail_backup_intro/heavy_tail_backup_intro.pptx
@@ -2,17 +2,17 @@
 <file path=ppt/presentation.xml><?xml version="1.0" encoding="utf-8"?>
 <p:presentation xmlns:p="http://schemas.openxmlformats.org/presentationml/2006/main">
   <p:sldMasterIdLst>
-    <p:sldMasterId xmlns:r="http://schemas.openxmlformats.org/officeDocument/2006/relationships" id="2147483648" r:id="Rc970b19ae99f49e9"/>
+    <p:sldMasterId xmlns:r="http://schemas.openxmlformats.org/officeDocument/2006/relationships" id="2147483648" r:id="R70638090351b4c45"/>
   </p:sldMasterIdLst>
   <p:notesMasterIdLst>
-    <p:notesMasterId xmlns:r="http://schemas.openxmlformats.org/officeDocument/2006/relationships" r:id="Ra242a591518d4297"/>
+    <p:notesMasterId xmlns:r="http://schemas.openxmlformats.org/officeDocument/2006/relationships" r:id="R41e4758736cf4cb0"/>
   </p:notesMasterIdLst>
   <p:sldIdLst>
-    <p:sldId xmlns:r="http://schemas.openxmlformats.org/officeDocument/2006/relationships" id="256" r:id="R96467514c1ba4975"/>
-    <p:sldId xmlns:r="http://schemas.openxmlformats.org/officeDocument/2006/relationships" id="257" r:id="R4c2795f212bf4c8a"/>
-    <p:sldId xmlns:r="http://schemas.openxmlformats.org/officeDocument/2006/relationships" id="258" r:id="Rcf5f6be4f85544e1"/>
-    <p:sldId xmlns:r="http://schemas.openxmlformats.org/officeDocument/2006/relationships" id="259" r:id="Rb58692dd01f14a53"/>
-    <p:sldId xmlns:r="http://schemas.openxmlformats.org/officeDocument/2006/relationships" id="260" r:id="R77bcee06887e437d"/>
+    <p:sldId xmlns:r="http://schemas.openxmlformats.org/officeDocument/2006/relationships" id="256" r:id="Rb067fbc0d10941fb"/>
+    <p:sldId xmlns:r="http://schemas.openxmlformats.org/officeDocument/2006/relationships" id="257" r:id="R73488b53727543bb"/>
+    <p:sldId xmlns:r="http://schemas.openxmlformats.org/officeDocument/2006/relationships" id="258" r:id="Rcc48a474a15d4e7c"/>
+    <p:sldId xmlns:r="http://schemas.openxmlformats.org/officeDocument/2006/relationships" id="259" r:id="R3ff64a93867641ca"/>
+    <p:sldId xmlns:r="http://schemas.openxmlformats.org/officeDocument/2006/relationships" id="260" r:id="R58026e6bf1aa4bd5"/>
   </p:sldIdLst>
   <p:sldSz cx="12192000" cy="6858000"/>
   <p:notesSz cx="6858000" cy="9144000"/>
@@ -823,7 +823,7 @@
   </p:cSld>
   <p:clrMap bg1="lt1" tx1="dk1" bg2="lt2" tx2="dk2" accent1="accent1" accent2="accent2" accent3="accent3" accent4="accent4" accent5="accent5" accent6="accent6" hlink="hlink" folHlink="folHlink"/>
   <p:sldLayoutIdLst>
-    <p:sldLayoutId xmlns:r="http://schemas.openxmlformats.org/officeDocument/2006/relationships" id="2147483649" r:id="R86ab11ed5ac14d72"/>
+    <p:sldLayoutId xmlns:r="http://schemas.openxmlformats.org/officeDocument/2006/relationships" id="2147483649" r:id="Rc496f0efc013465e"/>
   </p:sldLayoutIdLst>
   <p:txStyles>
     <p:titleStyle>
@@ -1122,7 +1122,7 @@
           <p:cNvPr id="1" name="">
             <a:extLst xmlns:a="http://schemas.openxmlformats.org/drawingml/2006/main">
               <a:ext uri="{FF2B5EF4-FFF2-40B4-BE49-F238E27FC236}">
-                <a16:creationId xmlns:a16="http://schemas.microsoft.com/office/drawing/2014/main" id="{2096FA08-6B73-48E4-AAF6-DC7938B11D45}"/>
+                <a16:creationId xmlns:a16="http://schemas.microsoft.com/office/drawing/2014/main" id="{DA12B065-0628-4B86-8A88-EBCF8C2C6A56}"/>
               </a:ext>
             </a:extLst>
           </p:cNvPr>
@@ -1157,7 +1157,7 @@
           <p:cNvPr id="2" name="">
             <a:extLst xmlns:a="http://schemas.openxmlformats.org/drawingml/2006/main">
               <a:ext uri="{FF2B5EF4-FFF2-40B4-BE49-F238E27FC236}">
-                <a16:creationId xmlns:a16="http://schemas.microsoft.com/office/drawing/2014/main" id="{DC6FB8B7-DF15-46D0-80E4-708DFC5E3415}"/>
+                <a16:creationId xmlns:a16="http://schemas.microsoft.com/office/drawing/2014/main" id="{7D2CA525-F434-4CE5-9EFC-87A42F495E34}"/>
               </a:ext>
             </a:extLst>
           </p:cNvPr>
@@ -1192,7 +1192,7 @@
           <p:cNvPr id="3" name="">
             <a:extLst xmlns:a="http://schemas.openxmlformats.org/drawingml/2006/main">
               <a:ext uri="{FF2B5EF4-FFF2-40B4-BE49-F238E27FC236}">
-                <a16:creationId xmlns:a16="http://schemas.microsoft.com/office/drawing/2014/main" id="{A933637D-3930-4562-8A6A-BB15529C4194}"/>
+                <a16:creationId xmlns:a16="http://schemas.microsoft.com/office/drawing/2014/main" id="{6684D4D0-ACEB-4CB0-992B-A798271055DD}"/>
               </a:ext>
             </a:extLst>
           </p:cNvPr>
@@ -1256,7 +1256,7 @@
           <p:cNvPr id="4" name="">
             <a:extLst xmlns:a="http://schemas.openxmlformats.org/drawingml/2006/main">
               <a:ext uri="{FF2B5EF4-FFF2-40B4-BE49-F238E27FC236}">
-                <a16:creationId xmlns:a16="http://schemas.microsoft.com/office/drawing/2014/main" id="{8F223D16-92C3-4A86-9EC8-8CDFF475E751}"/>
+                <a16:creationId xmlns:a16="http://schemas.microsoft.com/office/drawing/2014/main" id="{E21447A6-3AA5-41A7-8757-248ECE725CFB}"/>
               </a:ext>
             </a:extLst>
           </p:cNvPr>
@@ -1320,7 +1320,7 @@
           <p:cNvPr id="5" name="">
             <a:extLst xmlns:a="http://schemas.openxmlformats.org/drawingml/2006/main">
               <a:ext uri="{FF2B5EF4-FFF2-40B4-BE49-F238E27FC236}">
-                <a16:creationId xmlns:a16="http://schemas.microsoft.com/office/drawing/2014/main" id="{F8029EA3-C8EC-4351-89FB-0BBFB2860FA7}"/>
+                <a16:creationId xmlns:a16="http://schemas.microsoft.com/office/drawing/2014/main" id="{C2868091-98C3-4484-9FC4-B101B7E28FD1}"/>
               </a:ext>
             </a:extLst>
           </p:cNvPr>
@@ -1384,7 +1384,7 @@
           <p:cNvPr id="6" name="">
             <a:extLst xmlns:a="http://schemas.openxmlformats.org/drawingml/2006/main">
               <a:ext uri="{FF2B5EF4-FFF2-40B4-BE49-F238E27FC236}">
-                <a16:creationId xmlns:a16="http://schemas.microsoft.com/office/drawing/2014/main" id="{ECF03F08-548D-4783-93D4-BF78CEF0BE68}"/>
+                <a16:creationId xmlns:a16="http://schemas.microsoft.com/office/drawing/2014/main" id="{BFDE10FC-B812-4015-B682-D1B1A25FF359}"/>
               </a:ext>
             </a:extLst>
           </p:cNvPr>
@@ -1448,7 +1448,7 @@
           <p:cNvPr id="7" name="">
             <a:extLst xmlns:a="http://schemas.openxmlformats.org/drawingml/2006/main">
               <a:ext uri="{FF2B5EF4-FFF2-40B4-BE49-F238E27FC236}">
-                <a16:creationId xmlns:a16="http://schemas.microsoft.com/office/drawing/2014/main" id="{274D7BE7-2049-4AAA-8B5E-5C887D3791F1}"/>
+                <a16:creationId xmlns:a16="http://schemas.microsoft.com/office/drawing/2014/main" id="{2B0D978A-B88E-461B-BE82-B6C8933A7A3B}"/>
               </a:ext>
             </a:extLst>
           </p:cNvPr>
@@ -1481,7 +1481,7 @@
           <p:cNvPr id="8" name="">
             <a:extLst xmlns:a="http://schemas.openxmlformats.org/drawingml/2006/main">
               <a:ext uri="{FF2B5EF4-FFF2-40B4-BE49-F238E27FC236}">
-                <a16:creationId xmlns:a16="http://schemas.microsoft.com/office/drawing/2014/main" id="{995E59C3-396C-445E-8EDB-389C77DC0DDF}"/>
+                <a16:creationId xmlns:a16="http://schemas.microsoft.com/office/drawing/2014/main" id="{B850631A-CC8B-4B6E-BA44-DCD41FC97D48}"/>
               </a:ext>
             </a:extLst>
           </p:cNvPr>
@@ -1545,7 +1545,7 @@
           <p:cNvPr id="9" name="">
             <a:extLst xmlns:a="http://schemas.openxmlformats.org/drawingml/2006/main">
               <a:ext uri="{FF2B5EF4-FFF2-40B4-BE49-F238E27FC236}">
-                <a16:creationId xmlns:a16="http://schemas.microsoft.com/office/drawing/2014/main" id="{29497AF7-393D-4196-83FF-9429847E33C8}"/>
+                <a16:creationId xmlns:a16="http://schemas.microsoft.com/office/drawing/2014/main" id="{0719F932-44E4-4A93-B26E-4CCBB6F3D20A}"/>
               </a:ext>
             </a:extLst>
           </p:cNvPr>
@@ -1580,7 +1580,7 @@
           <p:cNvPr id="10" name="">
             <a:extLst xmlns:a="http://schemas.openxmlformats.org/drawingml/2006/main">
               <a:ext uri="{FF2B5EF4-FFF2-40B4-BE49-F238E27FC236}">
-                <a16:creationId xmlns:a16="http://schemas.microsoft.com/office/drawing/2014/main" id="{D25E7B43-5B77-41D2-96B6-F9581DE312CC}"/>
+                <a16:creationId xmlns:a16="http://schemas.microsoft.com/office/drawing/2014/main" id="{3119AC3C-5199-4C75-9618-0A593E4E65C5}"/>
               </a:ext>
             </a:extLst>
           </p:cNvPr>
@@ -1644,7 +1644,7 @@
           <p:cNvPr id="11" name="">
             <a:extLst xmlns:a="http://schemas.openxmlformats.org/drawingml/2006/main">
               <a:ext uri="{FF2B5EF4-FFF2-40B4-BE49-F238E27FC236}">
-                <a16:creationId xmlns:a16="http://schemas.microsoft.com/office/drawing/2014/main" id="{A782C2A4-7824-41B4-9F7D-116C18C5134D}"/>
+                <a16:creationId xmlns:a16="http://schemas.microsoft.com/office/drawing/2014/main" id="{2A3FBC0D-876A-4ED6-9351-8E748DEBF95C}"/>
               </a:ext>
             </a:extLst>
           </p:cNvPr>
@@ -1679,7 +1679,7 @@
           <p:cNvPr id="12" name="">
             <a:extLst xmlns:a="http://schemas.openxmlformats.org/drawingml/2006/main">
               <a:ext uri="{FF2B5EF4-FFF2-40B4-BE49-F238E27FC236}">
-                <a16:creationId xmlns:a16="http://schemas.microsoft.com/office/drawing/2014/main" id="{60D44B20-1315-409D-A0F8-0136F935A7B4}"/>
+                <a16:creationId xmlns:a16="http://schemas.microsoft.com/office/drawing/2014/main" id="{C2250A29-4385-475E-8C6E-204B46FF3638}"/>
               </a:ext>
             </a:extLst>
           </p:cNvPr>
@@ -1714,7 +1714,7 @@
           <p:cNvPr id="13" name="">
             <a:extLst xmlns:a="http://schemas.openxmlformats.org/drawingml/2006/main">
               <a:ext uri="{FF2B5EF4-FFF2-40B4-BE49-F238E27FC236}">
-                <a16:creationId xmlns:a16="http://schemas.microsoft.com/office/drawing/2014/main" id="{28D1D086-AFD7-466B-8B3E-CBA63DB5411E}"/>
+                <a16:creationId xmlns:a16="http://schemas.microsoft.com/office/drawing/2014/main" id="{E6923129-4E0B-4CE5-9DB1-68F8C70CDC3E}"/>
               </a:ext>
             </a:extLst>
           </p:cNvPr>
@@ -1778,7 +1778,7 @@
           <p:cNvPr id="14" name="">
             <a:extLst xmlns:a="http://schemas.openxmlformats.org/drawingml/2006/main">
               <a:ext uri="{FF2B5EF4-FFF2-40B4-BE49-F238E27FC236}">
-                <a16:creationId xmlns:a16="http://schemas.microsoft.com/office/drawing/2014/main" id="{EBEBD19C-E75F-4416-AB3B-7EEA1B171046}"/>
+                <a16:creationId xmlns:a16="http://schemas.microsoft.com/office/drawing/2014/main" id="{5215B7BA-670D-4678-BE40-178AF125EE8D}"/>
               </a:ext>
             </a:extLst>
           </p:cNvPr>
@@ -1811,7 +1811,7 @@
           <p:cNvPr id="15" name="">
             <a:extLst xmlns:a="http://schemas.openxmlformats.org/drawingml/2006/main">
               <a:ext uri="{FF2B5EF4-FFF2-40B4-BE49-F238E27FC236}">
-                <a16:creationId xmlns:a16="http://schemas.microsoft.com/office/drawing/2014/main" id="{C6521D3A-C08D-470A-A94D-3D5FA5B7C75D}"/>
+                <a16:creationId xmlns:a16="http://schemas.microsoft.com/office/drawing/2014/main" id="{8E8AB50E-6504-4CE7-BFB6-7E282214466C}"/>
               </a:ext>
             </a:extLst>
           </p:cNvPr>
@@ -1875,7 +1875,7 @@
           <p:cNvPr id="16" name="">
             <a:extLst xmlns:a="http://schemas.openxmlformats.org/drawingml/2006/main">
               <a:ext uri="{FF2B5EF4-FFF2-40B4-BE49-F238E27FC236}">
-                <a16:creationId xmlns:a16="http://schemas.microsoft.com/office/drawing/2014/main" id="{F2A702A0-3E4E-4859-9920-09AF2FFC96FC}"/>
+                <a16:creationId xmlns:a16="http://schemas.microsoft.com/office/drawing/2014/main" id="{B427C1F5-DCC8-4EE7-852B-B5B142C39C82}"/>
               </a:ext>
             </a:extLst>
           </p:cNvPr>
@@ -1910,7 +1910,7 @@
           <p:cNvPr id="17" name="">
             <a:extLst xmlns:a="http://schemas.openxmlformats.org/drawingml/2006/main">
               <a:ext uri="{FF2B5EF4-FFF2-40B4-BE49-F238E27FC236}">
-                <a16:creationId xmlns:a16="http://schemas.microsoft.com/office/drawing/2014/main" id="{AED8AA2F-66B4-4262-ADFD-6DB267C16E27}"/>
+                <a16:creationId xmlns:a16="http://schemas.microsoft.com/office/drawing/2014/main" id="{1B1F0B72-B87F-4DD6-BBCC-6FF18C131855}"/>
               </a:ext>
             </a:extLst>
           </p:cNvPr>
@@ -1974,7 +1974,7 @@
           <p:cNvPr id="18" name="">
             <a:extLst xmlns:a="http://schemas.openxmlformats.org/drawingml/2006/main">
               <a:ext uri="{FF2B5EF4-FFF2-40B4-BE49-F238E27FC236}">
-                <a16:creationId xmlns:a16="http://schemas.microsoft.com/office/drawing/2014/main" id="{24291CF7-E3BA-4CDA-9CE9-1BCA65B2B1D5}"/>
+                <a16:creationId xmlns:a16="http://schemas.microsoft.com/office/drawing/2014/main" id="{9825F4AC-4B5D-4904-86D4-DB904BD17912}"/>
               </a:ext>
             </a:extLst>
           </p:cNvPr>
@@ -2007,7 +2007,7 @@
           <p:cNvPr id="19" name="">
             <a:extLst xmlns:a="http://schemas.openxmlformats.org/drawingml/2006/main">
               <a:ext uri="{FF2B5EF4-FFF2-40B4-BE49-F238E27FC236}">
-                <a16:creationId xmlns:a16="http://schemas.microsoft.com/office/drawing/2014/main" id="{BFE764A4-2DCC-4D40-8FA7-B72667F58D11}"/>
+                <a16:creationId xmlns:a16="http://schemas.microsoft.com/office/drawing/2014/main" id="{B7A59868-EADE-4B9B-9D62-5465E099B432}"/>
               </a:ext>
             </a:extLst>
           </p:cNvPr>
@@ -2071,7 +2071,7 @@
           <p:cNvPr id="20" name="">
             <a:extLst xmlns:a="http://schemas.openxmlformats.org/drawingml/2006/main">
               <a:ext uri="{FF2B5EF4-FFF2-40B4-BE49-F238E27FC236}">
-                <a16:creationId xmlns:a16="http://schemas.microsoft.com/office/drawing/2014/main" id="{95823C77-5B2A-4C02-9076-34585C3FA7BD}"/>
+                <a16:creationId xmlns:a16="http://schemas.microsoft.com/office/drawing/2014/main" id="{365D8AE8-63B0-4D79-A4A6-6E2F6B215F2B}"/>
               </a:ext>
             </a:extLst>
           </p:cNvPr>
@@ -2106,7 +2106,7 @@
           <p:cNvPr id="21" name="">
             <a:extLst xmlns:a="http://schemas.openxmlformats.org/drawingml/2006/main">
               <a:ext uri="{FF2B5EF4-FFF2-40B4-BE49-F238E27FC236}">
-                <a16:creationId xmlns:a16="http://schemas.microsoft.com/office/drawing/2014/main" id="{EFF06C04-6578-4FDF-9D06-38AA5E024C77}"/>
+                <a16:creationId xmlns:a16="http://schemas.microsoft.com/office/drawing/2014/main" id="{FED7C2CC-D5B6-4CBD-98EA-941E5DEAA86E}"/>
               </a:ext>
             </a:extLst>
           </p:cNvPr>
@@ -2170,7 +2170,7 @@
           <p:cNvPr id="22" name="">
             <a:extLst xmlns:a="http://schemas.openxmlformats.org/drawingml/2006/main">
               <a:ext uri="{FF2B5EF4-FFF2-40B4-BE49-F238E27FC236}">
-                <a16:creationId xmlns:a16="http://schemas.microsoft.com/office/drawing/2014/main" id="{A9533EAF-5CB1-4C37-B7A4-58A9E28B6D43}"/>
+                <a16:creationId xmlns:a16="http://schemas.microsoft.com/office/drawing/2014/main" id="{4F3DB2AF-2D9A-44C9-ABD8-9DA2B55E3D3D}"/>
               </a:ext>
             </a:extLst>
           </p:cNvPr>
@@ -2203,7 +2203,7 @@
           <p:cNvPr id="23" name="">
             <a:extLst xmlns:a="http://schemas.openxmlformats.org/drawingml/2006/main">
               <a:ext uri="{FF2B5EF4-FFF2-40B4-BE49-F238E27FC236}">
-                <a16:creationId xmlns:a16="http://schemas.microsoft.com/office/drawing/2014/main" id="{74017A17-5480-45FD-8089-87E765D148A6}"/>
+                <a16:creationId xmlns:a16="http://schemas.microsoft.com/office/drawing/2014/main" id="{F7F1682B-A421-4746-880E-9E8CBD9D02CD}"/>
               </a:ext>
             </a:extLst>
           </p:cNvPr>
@@ -2267,7 +2267,7 @@
           <p:cNvPr id="24" name="">
             <a:extLst xmlns:a="http://schemas.openxmlformats.org/drawingml/2006/main">
               <a:ext uri="{FF2B5EF4-FFF2-40B4-BE49-F238E27FC236}">
-                <a16:creationId xmlns:a16="http://schemas.microsoft.com/office/drawing/2014/main" id="{E01F370E-1C68-4C09-874D-993A8F4B0DCC}"/>
+                <a16:creationId xmlns:a16="http://schemas.microsoft.com/office/drawing/2014/main" id="{63684948-6784-40CB-871D-1F3FA1EF19EF}"/>
               </a:ext>
             </a:extLst>
           </p:cNvPr>
@@ -2302,7 +2302,7 @@
           <p:cNvPr id="25" name="">
             <a:extLst xmlns:a="http://schemas.openxmlformats.org/drawingml/2006/main">
               <a:ext uri="{FF2B5EF4-FFF2-40B4-BE49-F238E27FC236}">
-                <a16:creationId xmlns:a16="http://schemas.microsoft.com/office/drawing/2014/main" id="{40C8591F-FC90-48A5-A3F9-D395265E0B59}"/>
+                <a16:creationId xmlns:a16="http://schemas.microsoft.com/office/drawing/2014/main" id="{47E2F81A-93EC-4881-B2AA-7B880DDF9DFF}"/>
               </a:ext>
             </a:extLst>
           </p:cNvPr>
@@ -2366,7 +2366,7 @@
           <p:cNvPr id="26" name="">
             <a:extLst xmlns:a="http://schemas.openxmlformats.org/drawingml/2006/main">
               <a:ext uri="{FF2B5EF4-FFF2-40B4-BE49-F238E27FC236}">
-                <a16:creationId xmlns:a16="http://schemas.microsoft.com/office/drawing/2014/main" id="{A3C86A26-EC53-49F3-BA48-9158B2520FE0}"/>
+                <a16:creationId xmlns:a16="http://schemas.microsoft.com/office/drawing/2014/main" id="{112C942A-FEFD-4AAB-B5D8-A37DA06AD16E}"/>
               </a:ext>
             </a:extLst>
           </p:cNvPr>
@@ -2399,7 +2399,7 @@
           <p:cNvPr id="27" name="">
             <a:extLst xmlns:a="http://schemas.openxmlformats.org/drawingml/2006/main">
               <a:ext uri="{FF2B5EF4-FFF2-40B4-BE49-F238E27FC236}">
-                <a16:creationId xmlns:a16="http://schemas.microsoft.com/office/drawing/2014/main" id="{9E6D2F0F-1290-456B-9946-FB6EF4DE2019}"/>
+                <a16:creationId xmlns:a16="http://schemas.microsoft.com/office/drawing/2014/main" id="{BA8FAB7A-42D3-4B85-85F5-95E938FE4EA6}"/>
               </a:ext>
             </a:extLst>
           </p:cNvPr>
@@ -2463,7 +2463,7 @@
           <p:cNvPr id="28" name="">
             <a:extLst xmlns:a="http://schemas.openxmlformats.org/drawingml/2006/main">
               <a:ext uri="{FF2B5EF4-FFF2-40B4-BE49-F238E27FC236}">
-                <a16:creationId xmlns:a16="http://schemas.microsoft.com/office/drawing/2014/main" id="{46FE3E9A-12A2-432B-AE5E-61E4CFAB5214}"/>
+                <a16:creationId xmlns:a16="http://schemas.microsoft.com/office/drawing/2014/main" id="{0DF2C67A-8AEC-4601-98AB-7D001BBAFA90}"/>
               </a:ext>
             </a:extLst>
           </p:cNvPr>
@@ -2498,7 +2498,7 @@
           <p:cNvPr id="29" name="">
             <a:extLst xmlns:a="http://schemas.openxmlformats.org/drawingml/2006/main">
               <a:ext uri="{FF2B5EF4-FFF2-40B4-BE49-F238E27FC236}">
-                <a16:creationId xmlns:a16="http://schemas.microsoft.com/office/drawing/2014/main" id="{9593E5B0-2046-4F2D-AE6D-1D8040515322}"/>
+                <a16:creationId xmlns:a16="http://schemas.microsoft.com/office/drawing/2014/main" id="{0A90AE71-FBC7-443D-AD2F-C5160F937AFE}"/>
               </a:ext>
             </a:extLst>
           </p:cNvPr>
@@ -2562,7 +2562,7 @@
           <p:cNvPr id="30" name="">
             <a:extLst xmlns:a="http://schemas.openxmlformats.org/drawingml/2006/main">
               <a:ext uri="{FF2B5EF4-FFF2-40B4-BE49-F238E27FC236}">
-                <a16:creationId xmlns:a16="http://schemas.microsoft.com/office/drawing/2014/main" id="{3E06AF58-65E5-4872-B5B0-6166673A1081}"/>
+                <a16:creationId xmlns:a16="http://schemas.microsoft.com/office/drawing/2014/main" id="{6CF3AD4F-60F5-4AE0-A0DF-509D0A29E33D}"/>
               </a:ext>
             </a:extLst>
           </p:cNvPr>
@@ -2595,7 +2595,7 @@
           <p:cNvPr id="31" name="">
             <a:extLst xmlns:a="http://schemas.openxmlformats.org/drawingml/2006/main">
               <a:ext uri="{FF2B5EF4-FFF2-40B4-BE49-F238E27FC236}">
-                <a16:creationId xmlns:a16="http://schemas.microsoft.com/office/drawing/2014/main" id="{C7FA6AC3-BF5B-4B8D-A8C7-7BCA965284E8}"/>
+                <a16:creationId xmlns:a16="http://schemas.microsoft.com/office/drawing/2014/main" id="{B71E66A5-BF72-425D-A5B1-EE142294822B}"/>
               </a:ext>
             </a:extLst>
           </p:cNvPr>
@@ -2659,7 +2659,7 @@
           <p:cNvPr id="32" name="">
             <a:extLst xmlns:a="http://schemas.openxmlformats.org/drawingml/2006/main">
               <a:ext uri="{FF2B5EF4-FFF2-40B4-BE49-F238E27FC236}">
-                <a16:creationId xmlns:a16="http://schemas.microsoft.com/office/drawing/2014/main" id="{E9D5FCE6-6441-433B-8C2E-A97098773E17}"/>
+                <a16:creationId xmlns:a16="http://schemas.microsoft.com/office/drawing/2014/main" id="{9AA5CCA3-C8C3-4108-832F-B0D656EF5409}"/>
               </a:ext>
             </a:extLst>
           </p:cNvPr>
@@ -2694,7 +2694,7 @@
           <p:cNvPr id="33" name="">
             <a:extLst xmlns:a="http://schemas.openxmlformats.org/drawingml/2006/main">
               <a:ext uri="{FF2B5EF4-FFF2-40B4-BE49-F238E27FC236}">
-                <a16:creationId xmlns:a16="http://schemas.microsoft.com/office/drawing/2014/main" id="{F049C692-25AE-4CD9-B325-3A97F1B0984E}"/>
+                <a16:creationId xmlns:a16="http://schemas.microsoft.com/office/drawing/2014/main" id="{E56B288D-85BF-4352-AE60-A9CD098DE201}"/>
               </a:ext>
             </a:extLst>
           </p:cNvPr>
@@ -2727,7 +2727,7 @@
           <p:cNvPr id="34" name="">
             <a:extLst xmlns:a="http://schemas.openxmlformats.org/drawingml/2006/main">
               <a:ext uri="{FF2B5EF4-FFF2-40B4-BE49-F238E27FC236}">
-                <a16:creationId xmlns:a16="http://schemas.microsoft.com/office/drawing/2014/main" id="{5A2A98B8-2C5C-4D7E-92F7-3F90A72EBF30}"/>
+                <a16:creationId xmlns:a16="http://schemas.microsoft.com/office/drawing/2014/main" id="{36F2E7D1-929D-4263-AA0A-11F32660CAE0}"/>
               </a:ext>
             </a:extLst>
           </p:cNvPr>
@@ -2791,7 +2791,7 @@
           <p:cNvPr id="35" name="">
             <a:extLst xmlns:a="http://schemas.openxmlformats.org/drawingml/2006/main">
               <a:ext uri="{FF2B5EF4-FFF2-40B4-BE49-F238E27FC236}">
-                <a16:creationId xmlns:a16="http://schemas.microsoft.com/office/drawing/2014/main" id="{156A5F5E-3980-4AFB-B13B-59EB2D229817}"/>
+                <a16:creationId xmlns:a16="http://schemas.microsoft.com/office/drawing/2014/main" id="{4F49DCF3-8B4C-464A-88B7-11E5855AFDD9}"/>
               </a:ext>
             </a:extLst>
           </p:cNvPr>
@@ -2826,7 +2826,7 @@
           <p:cNvPr id="36" name="">
             <a:extLst xmlns:a="http://schemas.openxmlformats.org/drawingml/2006/main">
               <a:ext uri="{FF2B5EF4-FFF2-40B4-BE49-F238E27FC236}">
-                <a16:creationId xmlns:a16="http://schemas.microsoft.com/office/drawing/2014/main" id="{6632B630-BBCF-45DF-AAEE-C78173A7A8E4}"/>
+                <a16:creationId xmlns:a16="http://schemas.microsoft.com/office/drawing/2014/main" id="{984EB2EE-718A-4712-93E7-987F4646E5E3}"/>
               </a:ext>
             </a:extLst>
           </p:cNvPr>
@@ -2859,7 +2859,7 @@
           <p:cNvPr id="37" name="">
             <a:extLst xmlns:a="http://schemas.openxmlformats.org/drawingml/2006/main">
               <a:ext uri="{FF2B5EF4-FFF2-40B4-BE49-F238E27FC236}">
-                <a16:creationId xmlns:a16="http://schemas.microsoft.com/office/drawing/2014/main" id="{B1A62F42-B743-441F-87C0-C1EAF25324D0}"/>
+                <a16:creationId xmlns:a16="http://schemas.microsoft.com/office/drawing/2014/main" id="{50FB5F57-1B4F-41E0-93A0-363C6FFE7E74}"/>
               </a:ext>
             </a:extLst>
           </p:cNvPr>
@@ -2923,7 +2923,7 @@
           <p:cNvPr id="38" name="">
             <a:extLst xmlns:a="http://schemas.openxmlformats.org/drawingml/2006/main">
               <a:ext uri="{FF2B5EF4-FFF2-40B4-BE49-F238E27FC236}">
-                <a16:creationId xmlns:a16="http://schemas.microsoft.com/office/drawing/2014/main" id="{5A6E4919-0A18-432F-AE00-1C4C51802D42}"/>
+                <a16:creationId xmlns:a16="http://schemas.microsoft.com/office/drawing/2014/main" id="{44B0FD9F-5B50-45E5-80F3-28EBBF0B2AD6}"/>
               </a:ext>
             </a:extLst>
           </p:cNvPr>
@@ -2956,7 +2956,7 @@
           <p:cNvPr id="39" name="">
             <a:extLst xmlns:a="http://schemas.openxmlformats.org/drawingml/2006/main">
               <a:ext uri="{FF2B5EF4-FFF2-40B4-BE49-F238E27FC236}">
-                <a16:creationId xmlns:a16="http://schemas.microsoft.com/office/drawing/2014/main" id="{80D32151-340C-43FC-9236-FBFC9D0004B8}"/>
+                <a16:creationId xmlns:a16="http://schemas.microsoft.com/office/drawing/2014/main" id="{47D22FFE-4038-4A8E-9428-31C9BC7F6469}"/>
               </a:ext>
             </a:extLst>
           </p:cNvPr>
@@ -3020,7 +3020,7 @@
           <p:cNvPr id="40" name="">
             <a:extLst xmlns:a="http://schemas.openxmlformats.org/drawingml/2006/main">
               <a:ext uri="{FF2B5EF4-FFF2-40B4-BE49-F238E27FC236}">
-                <a16:creationId xmlns:a16="http://schemas.microsoft.com/office/drawing/2014/main" id="{95990AD1-B21D-4E39-950E-A458D6F9C3E7}"/>
+                <a16:creationId xmlns:a16="http://schemas.microsoft.com/office/drawing/2014/main" id="{CA33EF88-8932-4BCE-A30B-CE665CAE661B}"/>
               </a:ext>
             </a:extLst>
           </p:cNvPr>
@@ -3053,7 +3053,7 @@
           <p:cNvPr id="41" name="">
             <a:extLst xmlns:a="http://schemas.openxmlformats.org/drawingml/2006/main">
               <a:ext uri="{FF2B5EF4-FFF2-40B4-BE49-F238E27FC236}">
-                <a16:creationId xmlns:a16="http://schemas.microsoft.com/office/drawing/2014/main" id="{23291CB0-4913-4B85-AFFD-7C33CE7EFCA4}"/>
+                <a16:creationId xmlns:a16="http://schemas.microsoft.com/office/drawing/2014/main" id="{04692C52-F43A-48C8-855E-4767172D8F2B}"/>
               </a:ext>
             </a:extLst>
           </p:cNvPr>
@@ -3117,7 +3117,7 @@
           <p:cNvPr id="42" name="">
             <a:extLst xmlns:a="http://schemas.openxmlformats.org/drawingml/2006/main">
               <a:ext uri="{FF2B5EF4-FFF2-40B4-BE49-F238E27FC236}">
-                <a16:creationId xmlns:a16="http://schemas.microsoft.com/office/drawing/2014/main" id="{7EBF0B8B-2472-4057-930F-28E27B7C872D}"/>
+                <a16:creationId xmlns:a16="http://schemas.microsoft.com/office/drawing/2014/main" id="{5979375B-CEED-4E72-9EE8-8F16E0926881}"/>
               </a:ext>
             </a:extLst>
           </p:cNvPr>
@@ -3204,7 +3204,7 @@
           <p:cNvPr id="43" name="">
             <a:extLst xmlns:a="http://schemas.openxmlformats.org/drawingml/2006/main">
               <a:ext uri="{FF2B5EF4-FFF2-40B4-BE49-F238E27FC236}">
-                <a16:creationId xmlns:a16="http://schemas.microsoft.com/office/drawing/2014/main" id="{503E7008-B381-44E0-8361-88A6C6DB5A5F}"/>
+                <a16:creationId xmlns:a16="http://schemas.microsoft.com/office/drawing/2014/main" id="{E2A4CB38-1816-4601-8230-BCE6DF1B9E15}"/>
               </a:ext>
             </a:extLst>
           </p:cNvPr>
@@ -3237,7 +3237,7 @@
           <p:cNvPr id="44" name="">
             <a:extLst xmlns:a="http://schemas.openxmlformats.org/drawingml/2006/main">
               <a:ext uri="{FF2B5EF4-FFF2-40B4-BE49-F238E27FC236}">
-                <a16:creationId xmlns:a16="http://schemas.microsoft.com/office/drawing/2014/main" id="{5E9FF76B-2902-4D75-9FEF-36E1BBBDEFF7}"/>
+                <a16:creationId xmlns:a16="http://schemas.microsoft.com/office/drawing/2014/main" id="{E91E4577-CF19-4346-9232-807911A00524}"/>
               </a:ext>
             </a:extLst>
           </p:cNvPr>
@@ -3301,7 +3301,7 @@
           <p:cNvPr id="45" name="">
             <a:extLst xmlns:a="http://schemas.openxmlformats.org/drawingml/2006/main">
               <a:ext uri="{FF2B5EF4-FFF2-40B4-BE49-F238E27FC236}">
-                <a16:creationId xmlns:a16="http://schemas.microsoft.com/office/drawing/2014/main" id="{17D5E5B7-B7BB-4D73-973E-813D3FC7D4B4}"/>
+                <a16:creationId xmlns:a16="http://schemas.microsoft.com/office/drawing/2014/main" id="{5B272262-FD68-47D5-BCF2-999AD203433C}"/>
               </a:ext>
             </a:extLst>
           </p:cNvPr>
@@ -3336,7 +3336,7 @@
           <p:cNvPr id="46" name="">
             <a:extLst xmlns:a="http://schemas.openxmlformats.org/drawingml/2006/main">
               <a:ext uri="{FF2B5EF4-FFF2-40B4-BE49-F238E27FC236}">
-                <a16:creationId xmlns:a16="http://schemas.microsoft.com/office/drawing/2014/main" id="{EE0E512F-6891-4FA5-BD01-4267507346BD}"/>
+                <a16:creationId xmlns:a16="http://schemas.microsoft.com/office/drawing/2014/main" id="{D90B12D5-6394-4E6E-900B-41F3074673F4}"/>
               </a:ext>
             </a:extLst>
           </p:cNvPr>
@@ -3372,7 +3372,7 @@
           <a:lstStyle xmlns:a="http://schemas.openxmlformats.org/drawingml/2006/main"/>
           <a:p xmlns:a="http://schemas.openxmlformats.org/drawingml/2006/main">
             <a:pPr algn="l">
-              <a:defRPr sz="788" b="0">
+              <a:defRPr sz="825" b="0">
                 <a:solidFill>
                   <a:srgbClr val="5F6B7A"/>
                 </a:solidFill>
@@ -3382,7 +3382,7 @@
               </a:defRPr>
             </a:pPr>
             <a:r>
-              <a:rPr sz="788" b="0">
+              <a:rPr sz="825" b="0">
                 <a:solidFill>
                   <a:srgbClr val="5F6B7A"/>
                 </a:solidFill>
@@ -3390,7 +3390,7 @@
                 <a:ea typeface="Aptos"/>
                 <a:cs typeface="Aptos"/>
               </a:rPr>
-              <a:t>Sources: 01_introduction.tex; 02_model_formulation.tex. Model boundary: post-intrusion backups may be contaminated.</a:t>
+              <a:t>Provenance note: 01_introduction.tex; 02_model_formulation.tex. Model boundary: post-intrusion backups may be contaminated.</a:t>
             </a:r>
           </a:p>
         </p:txBody>
@@ -3398,7 +3398,7 @@
     </p:spTree>
     <p:extLst>
       <p:ext uri="{BB962C8B-B14F-4D97-AF65-F5344CB8AC3E}">
-        <p14:creationId xmlns:p14="http://schemas.microsoft.com/office/powerpoint/2010/main" val="1399287782"/>
+        <p14:creationId xmlns:p14="http://schemas.microsoft.com/office/powerpoint/2010/main" val="1782383572"/>
       </p:ext>
     </p:extLst>
   </p:cSld>
@@ -3422,7 +3422,7 @@
           <p:cNvPr id="1" name="">
             <a:extLst xmlns:a="http://schemas.openxmlformats.org/drawingml/2006/main">
               <a:ext uri="{FF2B5EF4-FFF2-40B4-BE49-F238E27FC236}">
-                <a16:creationId xmlns:a16="http://schemas.microsoft.com/office/drawing/2014/main" id="{FAD8F615-0C4A-460B-8A57-A26951DA9CB3}"/>
+                <a16:creationId xmlns:a16="http://schemas.microsoft.com/office/drawing/2014/main" id="{B7AF3622-2036-4066-A257-CE9682ED0A58}"/>
               </a:ext>
             </a:extLst>
           </p:cNvPr>
@@ -3457,7 +3457,7 @@
           <p:cNvPr id="2" name="">
             <a:extLst xmlns:a="http://schemas.openxmlformats.org/drawingml/2006/main">
               <a:ext uri="{FF2B5EF4-FFF2-40B4-BE49-F238E27FC236}">
-                <a16:creationId xmlns:a16="http://schemas.microsoft.com/office/drawing/2014/main" id="{2C038ED4-EE6D-4996-BEF7-0DE4C8975E78}"/>
+                <a16:creationId xmlns:a16="http://schemas.microsoft.com/office/drawing/2014/main" id="{4377B445-AAE7-4A84-9DA1-5E49F4ABEAF1}"/>
               </a:ext>
             </a:extLst>
           </p:cNvPr>
@@ -3492,7 +3492,7 @@
           <p:cNvPr id="3" name="">
             <a:extLst xmlns:a="http://schemas.openxmlformats.org/drawingml/2006/main">
               <a:ext uri="{FF2B5EF4-FFF2-40B4-BE49-F238E27FC236}">
-                <a16:creationId xmlns:a16="http://schemas.microsoft.com/office/drawing/2014/main" id="{F884E87E-CA95-4999-BADB-FB20B32D45FE}"/>
+                <a16:creationId xmlns:a16="http://schemas.microsoft.com/office/drawing/2014/main" id="{B407575F-3AF3-4599-8663-CDE70892FFC0}"/>
               </a:ext>
             </a:extLst>
           </p:cNvPr>
@@ -3556,7 +3556,7 @@
           <p:cNvPr id="4" name="">
             <a:extLst xmlns:a="http://schemas.openxmlformats.org/drawingml/2006/main">
               <a:ext uri="{FF2B5EF4-FFF2-40B4-BE49-F238E27FC236}">
-                <a16:creationId xmlns:a16="http://schemas.microsoft.com/office/drawing/2014/main" id="{26C2C866-55AD-4712-85C4-7C7C284BF047}"/>
+                <a16:creationId xmlns:a16="http://schemas.microsoft.com/office/drawing/2014/main" id="{61433CF1-C176-4692-9BE8-ED7A4367C869}"/>
               </a:ext>
             </a:extLst>
           </p:cNvPr>
@@ -3620,7 +3620,7 @@
           <p:cNvPr id="5" name="">
             <a:extLst xmlns:a="http://schemas.openxmlformats.org/drawingml/2006/main">
               <a:ext uri="{FF2B5EF4-FFF2-40B4-BE49-F238E27FC236}">
-                <a16:creationId xmlns:a16="http://schemas.microsoft.com/office/drawing/2014/main" id="{4975FA99-62D7-4CC5-9F94-366720E68772}"/>
+                <a16:creationId xmlns:a16="http://schemas.microsoft.com/office/drawing/2014/main" id="{843DCEF5-9AC8-4E3A-A631-D18A897C0064}"/>
               </a:ext>
             </a:extLst>
           </p:cNvPr>
@@ -3684,7 +3684,7 @@
           <p:cNvPr id="6" name="">
             <a:extLst xmlns:a="http://schemas.openxmlformats.org/drawingml/2006/main">
               <a:ext uri="{FF2B5EF4-FFF2-40B4-BE49-F238E27FC236}">
-                <a16:creationId xmlns:a16="http://schemas.microsoft.com/office/drawing/2014/main" id="{36F4DA08-8752-425F-ABEC-196E50E35BE8}"/>
+                <a16:creationId xmlns:a16="http://schemas.microsoft.com/office/drawing/2014/main" id="{807E3D6D-3241-4907-9D99-E75D7475BBDA}"/>
               </a:ext>
             </a:extLst>
           </p:cNvPr>
@@ -3748,7 +3748,7 @@
           <p:cNvPr id="7" name="">
             <a:extLst xmlns:a="http://schemas.openxmlformats.org/drawingml/2006/main">
               <a:ext uri="{FF2B5EF4-FFF2-40B4-BE49-F238E27FC236}">
-                <a16:creationId xmlns:a16="http://schemas.microsoft.com/office/drawing/2014/main" id="{CE22AF05-E631-4CBD-A6BF-1B57ACF72239}"/>
+                <a16:creationId xmlns:a16="http://schemas.microsoft.com/office/drawing/2014/main" id="{A3FEB949-B7EE-4AEB-BBD4-686EB24D2FAA}"/>
               </a:ext>
             </a:extLst>
           </p:cNvPr>
@@ -3812,7 +3812,7 @@
           <p:cNvPr id="8" name="">
             <a:extLst xmlns:a="http://schemas.openxmlformats.org/drawingml/2006/main">
               <a:ext uri="{FF2B5EF4-FFF2-40B4-BE49-F238E27FC236}">
-                <a16:creationId xmlns:a16="http://schemas.microsoft.com/office/drawing/2014/main" id="{39618ED2-62ED-4A55-BD6C-5654E5411E3E}"/>
+                <a16:creationId xmlns:a16="http://schemas.microsoft.com/office/drawing/2014/main" id="{B48A86A0-0E56-45EC-96A7-0E60F9C3C3BE}"/>
               </a:ext>
             </a:extLst>
           </p:cNvPr>
@@ -3845,7 +3845,7 @@
           <p:cNvPr id="9" name="">
             <a:extLst xmlns:a="http://schemas.openxmlformats.org/drawingml/2006/main">
               <a:ext uri="{FF2B5EF4-FFF2-40B4-BE49-F238E27FC236}">
-                <a16:creationId xmlns:a16="http://schemas.microsoft.com/office/drawing/2014/main" id="{0C593BE2-9CE5-446A-BAA8-3D42FB260398}"/>
+                <a16:creationId xmlns:a16="http://schemas.microsoft.com/office/drawing/2014/main" id="{56278F37-D65E-47B9-8CAA-706FCB15ECB5}"/>
               </a:ext>
             </a:extLst>
           </p:cNvPr>
@@ -3909,7 +3909,7 @@
           <p:cNvPr id="10" name="">
             <a:extLst xmlns:a="http://schemas.openxmlformats.org/drawingml/2006/main">
               <a:ext uri="{FF2B5EF4-FFF2-40B4-BE49-F238E27FC236}">
-                <a16:creationId xmlns:a16="http://schemas.microsoft.com/office/drawing/2014/main" id="{6A5972F0-0850-41A1-BAD6-90F973F5A3F9}"/>
+                <a16:creationId xmlns:a16="http://schemas.microsoft.com/office/drawing/2014/main" id="{64932221-7C0A-4ECF-9C3B-BFEC56C74E03}"/>
               </a:ext>
             </a:extLst>
           </p:cNvPr>
@@ -3944,7 +3944,7 @@
           <p:cNvPr id="11" name="">
             <a:extLst xmlns:a="http://schemas.openxmlformats.org/drawingml/2006/main">
               <a:ext uri="{FF2B5EF4-FFF2-40B4-BE49-F238E27FC236}">
-                <a16:creationId xmlns:a16="http://schemas.microsoft.com/office/drawing/2014/main" id="{3370560B-B148-4C7C-8813-96BA645BA1C1}"/>
+                <a16:creationId xmlns:a16="http://schemas.microsoft.com/office/drawing/2014/main" id="{D706E048-8A12-4894-A5D6-2B10452B4767}"/>
               </a:ext>
             </a:extLst>
           </p:cNvPr>
@@ -3979,7 +3979,7 @@
           <p:cNvPr id="12" name="">
             <a:extLst xmlns:a="http://schemas.openxmlformats.org/drawingml/2006/main">
               <a:ext uri="{FF2B5EF4-FFF2-40B4-BE49-F238E27FC236}">
-                <a16:creationId xmlns:a16="http://schemas.microsoft.com/office/drawing/2014/main" id="{AA144969-C92F-4053-AB7D-DF4C2211C4B5}"/>
+                <a16:creationId xmlns:a16="http://schemas.microsoft.com/office/drawing/2014/main" id="{AD198072-9774-4AF5-90E7-8124506CA6C4}"/>
               </a:ext>
             </a:extLst>
           </p:cNvPr>
@@ -4014,7 +4014,7 @@
           <p:cNvPr id="13" name="">
             <a:extLst xmlns:a="http://schemas.openxmlformats.org/drawingml/2006/main">
               <a:ext uri="{FF2B5EF4-FFF2-40B4-BE49-F238E27FC236}">
-                <a16:creationId xmlns:a16="http://schemas.microsoft.com/office/drawing/2014/main" id="{457C8732-062B-4716-A510-D38DA2CB2AA3}"/>
+                <a16:creationId xmlns:a16="http://schemas.microsoft.com/office/drawing/2014/main" id="{A003BF73-3822-4A94-B636-00E596366D10}"/>
               </a:ext>
             </a:extLst>
           </p:cNvPr>
@@ -4049,7 +4049,7 @@
           <p:cNvPr id="14" name="">
             <a:extLst xmlns:a="http://schemas.openxmlformats.org/drawingml/2006/main">
               <a:ext uri="{FF2B5EF4-FFF2-40B4-BE49-F238E27FC236}">
-                <a16:creationId xmlns:a16="http://schemas.microsoft.com/office/drawing/2014/main" id="{D99C313D-0FF1-4D4E-A5CA-DA19AC666BB1}"/>
+                <a16:creationId xmlns:a16="http://schemas.microsoft.com/office/drawing/2014/main" id="{250D5391-A381-4A81-A838-DC7C7065D90C}"/>
               </a:ext>
             </a:extLst>
           </p:cNvPr>
@@ -4084,19 +4084,19 @@
           <p:cNvPr id="15" name="">
             <a:extLst xmlns:a="http://schemas.openxmlformats.org/drawingml/2006/main">
               <a:ext uri="{FF2B5EF4-FFF2-40B4-BE49-F238E27FC236}">
-                <a16:creationId xmlns:a16="http://schemas.microsoft.com/office/drawing/2014/main" id="{00378B2B-28A2-472F-A403-465201F43127}"/>
-              </a:ext>
-            </a:extLst>
-          </p:cNvPr>
-          <p:cNvSpPr>
-            <a:spLocks xmlns:a="http://schemas.openxmlformats.org/drawingml/2006/main" noGrp="1"/>
-          </p:cNvSpPr>
-          <p:nvPr/>
-        </p:nvSpPr>
-        <p:spPr>
-          <a:xfrm xmlns:a="http://schemas.openxmlformats.org/drawingml/2006/main">
-            <a:off x="990600" y="4648200"/>
-            <a:ext cx="1466850" cy="304800"/>
+                <a16:creationId xmlns:a16="http://schemas.microsoft.com/office/drawing/2014/main" id="{CEFDA1B8-C2F6-4219-9142-2CAF2F564837}"/>
+              </a:ext>
+            </a:extLst>
+          </p:cNvPr>
+          <p:cNvSpPr>
+            <a:spLocks xmlns:a="http://schemas.openxmlformats.org/drawingml/2006/main" noGrp="1"/>
+          </p:cNvSpPr>
+          <p:nvPr/>
+        </p:nvSpPr>
+        <p:spPr>
+          <a:xfrm xmlns:a="http://schemas.openxmlformats.org/drawingml/2006/main">
+            <a:off x="933450" y="4648200"/>
+            <a:ext cx="1581150" cy="304800"/>
           </a:xfrm>
           <a:prstGeom xmlns:a="http://schemas.openxmlformats.org/drawingml/2006/main" prst="rect">
             <a:avLst/>
@@ -4117,19 +4117,19 @@
           <p:cNvPr id="16" name="">
             <a:extLst xmlns:a="http://schemas.openxmlformats.org/drawingml/2006/main">
               <a:ext uri="{FF2B5EF4-FFF2-40B4-BE49-F238E27FC236}">
-                <a16:creationId xmlns:a16="http://schemas.microsoft.com/office/drawing/2014/main" id="{4CF88F52-F478-41A7-AA9E-AADF9A6486DB}"/>
-              </a:ext>
-            </a:extLst>
-          </p:cNvPr>
-          <p:cNvSpPr>
-            <a:spLocks xmlns:a="http://schemas.openxmlformats.org/drawingml/2006/main" noGrp="1"/>
-          </p:cNvSpPr>
-          <p:nvPr/>
-        </p:nvSpPr>
-        <p:spPr>
-          <a:xfrm xmlns:a="http://schemas.openxmlformats.org/drawingml/2006/main">
-            <a:off x="1066800" y="4714875"/>
-            <a:ext cx="1314450" cy="180975"/>
+                <a16:creationId xmlns:a16="http://schemas.microsoft.com/office/drawing/2014/main" id="{EFC6EC35-12DF-4D80-B339-1DFAA0EFCE8F}"/>
+              </a:ext>
+            </a:extLst>
+          </p:cNvPr>
+          <p:cNvSpPr>
+            <a:spLocks xmlns:a="http://schemas.openxmlformats.org/drawingml/2006/main" noGrp="1"/>
+          </p:cNvSpPr>
+          <p:nvPr/>
+        </p:nvSpPr>
+        <p:spPr>
+          <a:xfrm xmlns:a="http://schemas.openxmlformats.org/drawingml/2006/main">
+            <a:off x="1009650" y="4714875"/>
+            <a:ext cx="1428750" cy="180975"/>
           </a:xfrm>
           <a:prstGeom xmlns:a="http://schemas.openxmlformats.org/drawingml/2006/main" prst="rect">
             <a:avLst/>
@@ -4153,7 +4153,7 @@
           <a:lstStyle xmlns:a="http://schemas.openxmlformats.org/drawingml/2006/main"/>
           <a:p xmlns:a="http://schemas.openxmlformats.org/drawingml/2006/main">
             <a:pPr algn="ctr">
-              <a:defRPr sz="975" b="1">
+              <a:defRPr sz="1050" b="1">
                 <a:solidFill>
                   <a:srgbClr val="15803D"/>
                 </a:solidFill>
@@ -4163,7 +4163,7 @@
               </a:defRPr>
             </a:pPr>
             <a:r>
-              <a:rPr sz="975" b="1">
+              <a:rPr sz="1050" b="1">
                 <a:solidFill>
                   <a:srgbClr val="15803D"/>
                 </a:solidFill>
@@ -4181,19 +4181,19 @@
           <p:cNvPr id="17" name="">
             <a:extLst xmlns:a="http://schemas.openxmlformats.org/drawingml/2006/main">
               <a:ext uri="{FF2B5EF4-FFF2-40B4-BE49-F238E27FC236}">
-                <a16:creationId xmlns:a16="http://schemas.microsoft.com/office/drawing/2014/main" id="{44C80520-8660-4D82-ADC0-1999908862A2}"/>
-              </a:ext>
-            </a:extLst>
-          </p:cNvPr>
-          <p:cNvSpPr>
-            <a:spLocks xmlns:a="http://schemas.openxmlformats.org/drawingml/2006/main" noGrp="1"/>
-          </p:cNvSpPr>
-          <p:nvPr/>
-        </p:nvSpPr>
-        <p:spPr>
-          <a:xfrm xmlns:a="http://schemas.openxmlformats.org/drawingml/2006/main">
-            <a:off x="8248650" y="4648200"/>
-            <a:ext cx="990600" cy="304800"/>
+                <a16:creationId xmlns:a16="http://schemas.microsoft.com/office/drawing/2014/main" id="{9BA935F6-1F6D-424B-BE30-59C9540CFF09}"/>
+              </a:ext>
+            </a:extLst>
+          </p:cNvPr>
+          <p:cNvSpPr>
+            <a:spLocks xmlns:a="http://schemas.openxmlformats.org/drawingml/2006/main" noGrp="1"/>
+          </p:cNvSpPr>
+          <p:nvPr/>
+        </p:nvSpPr>
+        <p:spPr>
+          <a:xfrm xmlns:a="http://schemas.openxmlformats.org/drawingml/2006/main">
+            <a:off x="8191500" y="4648200"/>
+            <a:ext cx="1104900" cy="304800"/>
           </a:xfrm>
           <a:prstGeom xmlns:a="http://schemas.openxmlformats.org/drawingml/2006/main" prst="rect">
             <a:avLst/>
@@ -4214,19 +4214,19 @@
           <p:cNvPr id="18" name="">
             <a:extLst xmlns:a="http://schemas.openxmlformats.org/drawingml/2006/main">
               <a:ext uri="{FF2B5EF4-FFF2-40B4-BE49-F238E27FC236}">
-                <a16:creationId xmlns:a16="http://schemas.microsoft.com/office/drawing/2014/main" id="{378C646D-5948-4A37-9060-ECD3B4993B40}"/>
-              </a:ext>
-            </a:extLst>
-          </p:cNvPr>
-          <p:cNvSpPr>
-            <a:spLocks xmlns:a="http://schemas.openxmlformats.org/drawingml/2006/main" noGrp="1"/>
-          </p:cNvSpPr>
-          <p:nvPr/>
-        </p:nvSpPr>
-        <p:spPr>
-          <a:xfrm xmlns:a="http://schemas.openxmlformats.org/drawingml/2006/main">
-            <a:off x="8324850" y="4714875"/>
-            <a:ext cx="838200" cy="180975"/>
+                <a16:creationId xmlns:a16="http://schemas.microsoft.com/office/drawing/2014/main" id="{87D23091-870B-4EDB-9DCD-99F969646AC4}"/>
+              </a:ext>
+            </a:extLst>
+          </p:cNvPr>
+          <p:cNvSpPr>
+            <a:spLocks xmlns:a="http://schemas.openxmlformats.org/drawingml/2006/main" noGrp="1"/>
+          </p:cNvSpPr>
+          <p:nvPr/>
+        </p:nvSpPr>
+        <p:spPr>
+          <a:xfrm xmlns:a="http://schemas.openxmlformats.org/drawingml/2006/main">
+            <a:off x="8267700" y="4714875"/>
+            <a:ext cx="952500" cy="180975"/>
           </a:xfrm>
           <a:prstGeom xmlns:a="http://schemas.openxmlformats.org/drawingml/2006/main" prst="rect">
             <a:avLst/>
@@ -4250,7 +4250,7 @@
           <a:lstStyle xmlns:a="http://schemas.openxmlformats.org/drawingml/2006/main"/>
           <a:p xmlns:a="http://schemas.openxmlformats.org/drawingml/2006/main">
             <a:pPr algn="ctr">
-              <a:defRPr sz="975" b="1">
+              <a:defRPr sz="1050" b="1">
                 <a:solidFill>
                   <a:srgbClr val="B42318"/>
                 </a:solidFill>
@@ -4260,7 +4260,7 @@
               </a:defRPr>
             </a:pPr>
             <a:r>
-              <a:rPr sz="975" b="1">
+              <a:rPr sz="1050" b="1">
                 <a:solidFill>
                   <a:srgbClr val="B42318"/>
                 </a:solidFill>
@@ -4278,7 +4278,7 @@
           <p:cNvPr id="19" name="">
             <a:extLst xmlns:a="http://schemas.openxmlformats.org/drawingml/2006/main">
               <a:ext uri="{FF2B5EF4-FFF2-40B4-BE49-F238E27FC236}">
-                <a16:creationId xmlns:a16="http://schemas.microsoft.com/office/drawing/2014/main" id="{8F0B43E9-7A73-406A-9305-CC686A687217}"/>
+                <a16:creationId xmlns:a16="http://schemas.microsoft.com/office/drawing/2014/main" id="{FBB46660-24C9-42EB-AB6D-3D7ECC066371}"/>
               </a:ext>
             </a:extLst>
           </p:cNvPr>
@@ -4342,19 +4342,19 @@
           <p:cNvPr id="20" name="">
             <a:extLst xmlns:a="http://schemas.openxmlformats.org/drawingml/2006/main">
               <a:ext uri="{FF2B5EF4-FFF2-40B4-BE49-F238E27FC236}">
-                <a16:creationId xmlns:a16="http://schemas.microsoft.com/office/drawing/2014/main" id="{7989B46B-718D-4249-B841-CF3D94118392}"/>
-              </a:ext>
-            </a:extLst>
-          </p:cNvPr>
-          <p:cNvSpPr>
-            <a:spLocks xmlns:a="http://schemas.openxmlformats.org/drawingml/2006/main" noGrp="1"/>
-          </p:cNvSpPr>
-          <p:nvPr/>
-        </p:nvSpPr>
-        <p:spPr>
-          <a:xfrm xmlns:a="http://schemas.openxmlformats.org/drawingml/2006/main">
-            <a:off x="7239000" y="5219700"/>
-            <a:ext cx="3733800" cy="228600"/>
+                <a16:creationId xmlns:a16="http://schemas.microsoft.com/office/drawing/2014/main" id="{05C88135-83B0-45DB-813C-448E311E6F5B}"/>
+              </a:ext>
+            </a:extLst>
+          </p:cNvPr>
+          <p:cNvSpPr>
+            <a:spLocks xmlns:a="http://schemas.openxmlformats.org/drawingml/2006/main" noGrp="1"/>
+          </p:cNvSpPr>
+          <p:nvPr/>
+        </p:nvSpPr>
+        <p:spPr>
+          <a:xfrm xmlns:a="http://schemas.openxmlformats.org/drawingml/2006/main">
+            <a:off x="7429500" y="5200650"/>
+            <a:ext cx="3352800" cy="247650"/>
           </a:xfrm>
           <a:prstGeom xmlns:a="http://schemas.openxmlformats.org/drawingml/2006/main" prst="rect">
             <a:avLst/>
@@ -4378,7 +4378,7 @@
           <a:lstStyle xmlns:a="http://schemas.openxmlformats.org/drawingml/2006/main"/>
           <a:p xmlns:a="http://schemas.openxmlformats.org/drawingml/2006/main">
             <a:pPr algn="ctr">
-              <a:defRPr sz="1200" b="1">
+              <a:defRPr sz="1350" b="1">
                 <a:solidFill>
                   <a:srgbClr val="B42318"/>
                 </a:solidFill>
@@ -4388,7 +4388,7 @@
               </a:defRPr>
             </a:pPr>
             <a:r>
-              <a:rPr sz="1200" b="1">
+              <a:rPr sz="1350" b="1">
                 <a:solidFill>
                   <a:srgbClr val="B42318"/>
                 </a:solidFill>
@@ -4396,7 +4396,7 @@
                 <a:ea typeface="Hiragino Sans"/>
                 <a:cs typeface="Hiragino Sans"/>
               </a:rPr>
-              <a:t>この設計では清浄復旧に失敗（全損相当）</a:t>
+              <a:t>この設計では清浄復旧に失敗</a:t>
             </a:r>
           </a:p>
         </p:txBody>
@@ -4406,19 +4406,19 @@
           <p:cNvPr id="21" name="">
             <a:extLst xmlns:a="http://schemas.openxmlformats.org/drawingml/2006/main">
               <a:ext uri="{FF2B5EF4-FFF2-40B4-BE49-F238E27FC236}">
-                <a16:creationId xmlns:a16="http://schemas.microsoft.com/office/drawing/2014/main" id="{D7AB0A31-F57F-4EC7-BC3B-A8D7FB0E332C}"/>
-              </a:ext>
-            </a:extLst>
-          </p:cNvPr>
-          <p:cNvSpPr>
-            <a:spLocks xmlns:a="http://schemas.openxmlformats.org/drawingml/2006/main" noGrp="1"/>
-          </p:cNvSpPr>
-          <p:nvPr/>
-        </p:nvSpPr>
-        <p:spPr>
-          <a:xfrm xmlns:a="http://schemas.openxmlformats.org/drawingml/2006/main">
-            <a:off x="2152650" y="5429250"/>
-            <a:ext cx="1752600" cy="304800"/>
+                <a16:creationId xmlns:a16="http://schemas.microsoft.com/office/drawing/2014/main" id="{61AADDA2-DB12-4759-9F1C-47DD6F588618}"/>
+              </a:ext>
+            </a:extLst>
+          </p:cNvPr>
+          <p:cNvSpPr>
+            <a:spLocks xmlns:a="http://schemas.openxmlformats.org/drawingml/2006/main" noGrp="1"/>
+          </p:cNvSpPr>
+          <p:nvPr/>
+        </p:nvSpPr>
+        <p:spPr>
+          <a:xfrm xmlns:a="http://schemas.openxmlformats.org/drawingml/2006/main">
+            <a:off x="2038350" y="5429250"/>
+            <a:ext cx="1657350" cy="304800"/>
           </a:xfrm>
           <a:prstGeom xmlns:a="http://schemas.openxmlformats.org/drawingml/2006/main" prst="rect">
             <a:avLst/>
@@ -4439,19 +4439,19 @@
           <p:cNvPr id="22" name="">
             <a:extLst xmlns:a="http://schemas.openxmlformats.org/drawingml/2006/main">
               <a:ext uri="{FF2B5EF4-FFF2-40B4-BE49-F238E27FC236}">
-                <a16:creationId xmlns:a16="http://schemas.microsoft.com/office/drawing/2014/main" id="{343177A8-CDC9-436D-8179-637969DD54A6}"/>
-              </a:ext>
-            </a:extLst>
-          </p:cNvPr>
-          <p:cNvSpPr>
-            <a:spLocks xmlns:a="http://schemas.openxmlformats.org/drawingml/2006/main" noGrp="1"/>
-          </p:cNvSpPr>
-          <p:nvPr/>
-        </p:nvSpPr>
-        <p:spPr>
-          <a:xfrm xmlns:a="http://schemas.openxmlformats.org/drawingml/2006/main">
-            <a:off x="2228850" y="5495925"/>
-            <a:ext cx="1600200" cy="180975"/>
+                <a16:creationId xmlns:a16="http://schemas.microsoft.com/office/drawing/2014/main" id="{2F28F978-9807-4C9F-80D3-777D721B857D}"/>
+              </a:ext>
+            </a:extLst>
+          </p:cNvPr>
+          <p:cNvSpPr>
+            <a:spLocks xmlns:a="http://schemas.openxmlformats.org/drawingml/2006/main" noGrp="1"/>
+          </p:cNvSpPr>
+          <p:nvPr/>
+        </p:nvSpPr>
+        <p:spPr>
+          <a:xfrm xmlns:a="http://schemas.openxmlformats.org/drawingml/2006/main">
+            <a:off x="2114550" y="5495925"/>
+            <a:ext cx="1504950" cy="180975"/>
           </a:xfrm>
           <a:prstGeom xmlns:a="http://schemas.openxmlformats.org/drawingml/2006/main" prst="rect">
             <a:avLst/>
@@ -4475,7 +4475,7 @@
           <a:lstStyle xmlns:a="http://schemas.openxmlformats.org/drawingml/2006/main"/>
           <a:p xmlns:a="http://schemas.openxmlformats.org/drawingml/2006/main">
             <a:pPr algn="ctr">
-              <a:defRPr sz="975" b="1">
+              <a:defRPr sz="1050" b="1">
                 <a:solidFill>
                   <a:srgbClr val="1D4ED8"/>
                 </a:solidFill>
@@ -4485,7 +4485,7 @@
               </a:defRPr>
             </a:pPr>
             <a:r>
-              <a:rPr sz="975" b="1">
+              <a:rPr sz="1050" b="1">
                 <a:solidFill>
                   <a:srgbClr val="1D4ED8"/>
                 </a:solidFill>
@@ -4493,7 +4493,7 @@
                 <a:ea typeface="Hiragino Sans"/>
                 <a:cs typeface="Hiragino Sans"/>
               </a:rPr>
-              <a:t>n = 保持する世代数</a:t>
+              <a:t>n = 保持世代数</a:t>
             </a:r>
           </a:p>
         </p:txBody>
@@ -4503,19 +4503,19 @@
           <p:cNvPr id="23" name="">
             <a:extLst xmlns:a="http://schemas.openxmlformats.org/drawingml/2006/main">
               <a:ext uri="{FF2B5EF4-FFF2-40B4-BE49-F238E27FC236}">
-                <a16:creationId xmlns:a16="http://schemas.microsoft.com/office/drawing/2014/main" id="{CB24BFD4-05F4-4C7E-8957-DFB72523DDA9}"/>
-              </a:ext>
-            </a:extLst>
-          </p:cNvPr>
-          <p:cNvSpPr>
-            <a:spLocks xmlns:a="http://schemas.openxmlformats.org/drawingml/2006/main" noGrp="1"/>
-          </p:cNvSpPr>
-          <p:nvPr/>
-        </p:nvSpPr>
-        <p:spPr>
-          <a:xfrm xmlns:a="http://schemas.openxmlformats.org/drawingml/2006/main">
-            <a:off x="4210050" y="5429250"/>
-            <a:ext cx="1866900" cy="304800"/>
+                <a16:creationId xmlns:a16="http://schemas.microsoft.com/office/drawing/2014/main" id="{DAD686B5-93D2-4475-A490-AB5850FD4633}"/>
+              </a:ext>
+            </a:extLst>
+          </p:cNvPr>
+          <p:cNvSpPr>
+            <a:spLocks xmlns:a="http://schemas.openxmlformats.org/drawingml/2006/main" noGrp="1"/>
+          </p:cNvSpPr>
+          <p:nvPr/>
+        </p:nvSpPr>
+        <p:spPr>
+          <a:xfrm xmlns:a="http://schemas.openxmlformats.org/drawingml/2006/main">
+            <a:off x="4000500" y="5429250"/>
+            <a:ext cx="1371600" cy="304800"/>
           </a:xfrm>
           <a:prstGeom xmlns:a="http://schemas.openxmlformats.org/drawingml/2006/main" prst="rect">
             <a:avLst/>
@@ -4536,19 +4536,19 @@
           <p:cNvPr id="24" name="">
             <a:extLst xmlns:a="http://schemas.openxmlformats.org/drawingml/2006/main">
               <a:ext uri="{FF2B5EF4-FFF2-40B4-BE49-F238E27FC236}">
-                <a16:creationId xmlns:a16="http://schemas.microsoft.com/office/drawing/2014/main" id="{DA234BAC-66B1-4D01-BDC5-B9718CC7070B}"/>
-              </a:ext>
-            </a:extLst>
-          </p:cNvPr>
-          <p:cNvSpPr>
-            <a:spLocks xmlns:a="http://schemas.openxmlformats.org/drawingml/2006/main" noGrp="1"/>
-          </p:cNvSpPr>
-          <p:nvPr/>
-        </p:nvSpPr>
-        <p:spPr>
-          <a:xfrm xmlns:a="http://schemas.openxmlformats.org/drawingml/2006/main">
-            <a:off x="4286250" y="5495925"/>
-            <a:ext cx="1714500" cy="180975"/>
+                <a16:creationId xmlns:a16="http://schemas.microsoft.com/office/drawing/2014/main" id="{91C20E2D-06B1-4C69-9CBB-313FE61956A1}"/>
+              </a:ext>
+            </a:extLst>
+          </p:cNvPr>
+          <p:cNvSpPr>
+            <a:spLocks xmlns:a="http://schemas.openxmlformats.org/drawingml/2006/main" noGrp="1"/>
+          </p:cNvSpPr>
+          <p:nvPr/>
+        </p:nvSpPr>
+        <p:spPr>
+          <a:xfrm xmlns:a="http://schemas.openxmlformats.org/drawingml/2006/main">
+            <a:off x="4076700" y="5495925"/>
+            <a:ext cx="1219200" cy="180975"/>
           </a:xfrm>
           <a:prstGeom xmlns:a="http://schemas.openxmlformats.org/drawingml/2006/main" prst="rect">
             <a:avLst/>
@@ -4572,7 +4572,7 @@
           <a:lstStyle xmlns:a="http://schemas.openxmlformats.org/drawingml/2006/main"/>
           <a:p xmlns:a="http://schemas.openxmlformats.org/drawingml/2006/main">
             <a:pPr algn="ctr">
-              <a:defRPr sz="975" b="1">
+              <a:defRPr sz="1050" b="1">
                 <a:solidFill>
                   <a:srgbClr val="B45309"/>
                 </a:solidFill>
@@ -4582,7 +4582,7 @@
               </a:defRPr>
             </a:pPr>
             <a:r>
-              <a:rPr sz="975" b="1">
+              <a:rPr sz="1050" b="1">
                 <a:solidFill>
                   <a:srgbClr val="B45309"/>
                 </a:solidFill>
@@ -4590,7 +4590,7 @@
                 <a:ea typeface="Hiragino Sans"/>
                 <a:cs typeface="Hiragino Sans"/>
               </a:rPr>
-              <a:t>Δ = バックアップ間隔</a:t>
+              <a:t>Δ = 間隔</a:t>
             </a:r>
           </a:p>
         </p:txBody>
@@ -4600,19 +4600,19 @@
           <p:cNvPr id="25" name="">
             <a:extLst xmlns:a="http://schemas.openxmlformats.org/drawingml/2006/main">
               <a:ext uri="{FF2B5EF4-FFF2-40B4-BE49-F238E27FC236}">
-                <a16:creationId xmlns:a16="http://schemas.microsoft.com/office/drawing/2014/main" id="{7FE3FCB4-8BB9-4215-8E8B-EFB2820A7C15}"/>
-              </a:ext>
-            </a:extLst>
-          </p:cNvPr>
-          <p:cNvSpPr>
-            <a:spLocks xmlns:a="http://schemas.openxmlformats.org/drawingml/2006/main" noGrp="1"/>
-          </p:cNvSpPr>
-          <p:nvPr/>
-        </p:nvSpPr>
-        <p:spPr>
-          <a:xfrm xmlns:a="http://schemas.openxmlformats.org/drawingml/2006/main">
-            <a:off x="6381750" y="5429250"/>
-            <a:ext cx="2266950" cy="304800"/>
+                <a16:creationId xmlns:a16="http://schemas.microsoft.com/office/drawing/2014/main" id="{6B9FDCCC-A4A2-4E4F-A172-EBAB43518B12}"/>
+              </a:ext>
+            </a:extLst>
+          </p:cNvPr>
+          <p:cNvSpPr>
+            <a:spLocks xmlns:a="http://schemas.openxmlformats.org/drawingml/2006/main" noGrp="1"/>
+          </p:cNvSpPr>
+          <p:nvPr/>
+        </p:nvSpPr>
+        <p:spPr>
+          <a:xfrm xmlns:a="http://schemas.openxmlformats.org/drawingml/2006/main">
+            <a:off x="5676900" y="5429250"/>
+            <a:ext cx="2400300" cy="304800"/>
           </a:xfrm>
           <a:prstGeom xmlns:a="http://schemas.openxmlformats.org/drawingml/2006/main" prst="rect">
             <a:avLst/>
@@ -4633,19 +4633,19 @@
           <p:cNvPr id="26" name="">
             <a:extLst xmlns:a="http://schemas.openxmlformats.org/drawingml/2006/main">
               <a:ext uri="{FF2B5EF4-FFF2-40B4-BE49-F238E27FC236}">
-                <a16:creationId xmlns:a16="http://schemas.microsoft.com/office/drawing/2014/main" id="{C73B25CF-50A8-4667-B388-757E958A1797}"/>
-              </a:ext>
-            </a:extLst>
-          </p:cNvPr>
-          <p:cNvSpPr>
-            <a:spLocks xmlns:a="http://schemas.openxmlformats.org/drawingml/2006/main" noGrp="1"/>
-          </p:cNvSpPr>
-          <p:nvPr/>
-        </p:nvSpPr>
-        <p:spPr>
-          <a:xfrm xmlns:a="http://schemas.openxmlformats.org/drawingml/2006/main">
-            <a:off x="6457950" y="5495925"/>
-            <a:ext cx="2114550" cy="180975"/>
+                <a16:creationId xmlns:a16="http://schemas.microsoft.com/office/drawing/2014/main" id="{5BAFE2F5-EC09-4ABC-933B-F6B0EB87FD58}"/>
+              </a:ext>
+            </a:extLst>
+          </p:cNvPr>
+          <p:cNvSpPr>
+            <a:spLocks xmlns:a="http://schemas.openxmlformats.org/drawingml/2006/main" noGrp="1"/>
+          </p:cNvSpPr>
+          <p:nvPr/>
+        </p:nvSpPr>
+        <p:spPr>
+          <a:xfrm xmlns:a="http://schemas.openxmlformats.org/drawingml/2006/main">
+            <a:off x="5753100" y="5495925"/>
+            <a:ext cx="2247900" cy="180975"/>
           </a:xfrm>
           <a:prstGeom xmlns:a="http://schemas.openxmlformats.org/drawingml/2006/main" prst="rect">
             <a:avLst/>
@@ -4669,7 +4669,7 @@
           <a:lstStyle xmlns:a="http://schemas.openxmlformats.org/drawingml/2006/main"/>
           <a:p xmlns:a="http://schemas.openxmlformats.org/drawingml/2006/main">
             <a:pPr algn="ctr">
-              <a:defRPr sz="975" b="1">
+              <a:defRPr sz="1050" b="1">
                 <a:solidFill>
                   <a:srgbClr val="0F766E"/>
                 </a:solidFill>
@@ -4679,7 +4679,7 @@
               </a:defRPr>
             </a:pPr>
             <a:r>
-              <a:rPr sz="975" b="1">
+              <a:rPr sz="1050" b="1">
                 <a:solidFill>
                   <a:srgbClr val="0F766E"/>
                 </a:solidFill>
@@ -4697,19 +4697,19 @@
           <p:cNvPr id="27" name="">
             <a:extLst xmlns:a="http://schemas.openxmlformats.org/drawingml/2006/main">
               <a:ext uri="{FF2B5EF4-FFF2-40B4-BE49-F238E27FC236}">
-                <a16:creationId xmlns:a16="http://schemas.microsoft.com/office/drawing/2014/main" id="{5C2EFECC-D2FD-4FD9-A6EF-7E94E87935F3}"/>
-              </a:ext>
-            </a:extLst>
-          </p:cNvPr>
-          <p:cNvSpPr>
-            <a:spLocks xmlns:a="http://schemas.openxmlformats.org/drawingml/2006/main" noGrp="1"/>
-          </p:cNvSpPr>
-          <p:nvPr/>
-        </p:nvSpPr>
-        <p:spPr>
-          <a:xfrm xmlns:a="http://schemas.openxmlformats.org/drawingml/2006/main">
-            <a:off x="8953500" y="5429250"/>
-            <a:ext cx="1695450" cy="304800"/>
+                <a16:creationId xmlns:a16="http://schemas.microsoft.com/office/drawing/2014/main" id="{7141BFDA-71AC-4DD2-BE5C-8A74E9D618DF}"/>
+              </a:ext>
+            </a:extLst>
+          </p:cNvPr>
+          <p:cNvSpPr>
+            <a:spLocks xmlns:a="http://schemas.openxmlformats.org/drawingml/2006/main" noGrp="1"/>
+          </p:cNvSpPr>
+          <p:nvPr/>
+        </p:nvSpPr>
+        <p:spPr>
+          <a:xfrm xmlns:a="http://schemas.openxmlformats.org/drawingml/2006/main">
+            <a:off x="8382000" y="5429250"/>
+            <a:ext cx="1847850" cy="304800"/>
           </a:xfrm>
           <a:prstGeom xmlns:a="http://schemas.openxmlformats.org/drawingml/2006/main" prst="rect">
             <a:avLst/>
@@ -4730,19 +4730,19 @@
           <p:cNvPr id="28" name="">
             <a:extLst xmlns:a="http://schemas.openxmlformats.org/drawingml/2006/main">
               <a:ext uri="{FF2B5EF4-FFF2-40B4-BE49-F238E27FC236}">
-                <a16:creationId xmlns:a16="http://schemas.microsoft.com/office/drawing/2014/main" id="{8EC66B4D-89F4-459A-8258-BFCA93C8C837}"/>
-              </a:ext>
-            </a:extLst>
-          </p:cNvPr>
-          <p:cNvSpPr>
-            <a:spLocks xmlns:a="http://schemas.openxmlformats.org/drawingml/2006/main" noGrp="1"/>
-          </p:cNvSpPr>
-          <p:nvPr/>
-        </p:nvSpPr>
-        <p:spPr>
-          <a:xfrm xmlns:a="http://schemas.openxmlformats.org/drawingml/2006/main">
-            <a:off x="9029700" y="5495925"/>
-            <a:ext cx="1543050" cy="180975"/>
+                <a16:creationId xmlns:a16="http://schemas.microsoft.com/office/drawing/2014/main" id="{87AB3373-F44C-4347-B49A-4C4CAA9D1E16}"/>
+              </a:ext>
+            </a:extLst>
+          </p:cNvPr>
+          <p:cNvSpPr>
+            <a:spLocks xmlns:a="http://schemas.openxmlformats.org/drawingml/2006/main" noGrp="1"/>
+          </p:cNvSpPr>
+          <p:nvPr/>
+        </p:nvSpPr>
+        <p:spPr>
+          <a:xfrm xmlns:a="http://schemas.openxmlformats.org/drawingml/2006/main">
+            <a:off x="8458200" y="5495925"/>
+            <a:ext cx="1695450" cy="180975"/>
           </a:xfrm>
           <a:prstGeom xmlns:a="http://schemas.openxmlformats.org/drawingml/2006/main" prst="rect">
             <a:avLst/>
@@ -4766,7 +4766,7 @@
           <a:lstStyle xmlns:a="http://schemas.openxmlformats.org/drawingml/2006/main"/>
           <a:p xmlns:a="http://schemas.openxmlformats.org/drawingml/2006/main">
             <a:pPr algn="ctr">
-              <a:defRPr sz="975" b="1">
+              <a:defRPr sz="1050" b="1">
                 <a:solidFill>
                   <a:srgbClr val="5F6B7A"/>
                 </a:solidFill>
@@ -4776,7 +4776,7 @@
               </a:defRPr>
             </a:pPr>
             <a:r>
-              <a:rPr sz="975" b="1">
+              <a:rPr sz="1050" b="1">
                 <a:solidFill>
                   <a:srgbClr val="5F6B7A"/>
                 </a:solidFill>
@@ -4794,7 +4794,7 @@
           <p:cNvPr id="29" name="">
             <a:extLst xmlns:a="http://schemas.openxmlformats.org/drawingml/2006/main">
               <a:ext uri="{FF2B5EF4-FFF2-40B4-BE49-F238E27FC236}">
-                <a16:creationId xmlns:a16="http://schemas.microsoft.com/office/drawing/2014/main" id="{61BDC64E-7B69-4EFB-A7B6-9E6F76C794A3}"/>
+                <a16:creationId xmlns:a16="http://schemas.microsoft.com/office/drawing/2014/main" id="{EA841AC8-5F92-4611-9DA8-193BAE56D83F}"/>
               </a:ext>
             </a:extLst>
           </p:cNvPr>
@@ -4829,7 +4829,7 @@
           <p:cNvPr id="30" name="">
             <a:extLst xmlns:a="http://schemas.openxmlformats.org/drawingml/2006/main">
               <a:ext uri="{FF2B5EF4-FFF2-40B4-BE49-F238E27FC236}">
-                <a16:creationId xmlns:a16="http://schemas.microsoft.com/office/drawing/2014/main" id="{E15DE1DF-3D7B-4168-B070-9831797F9708}"/>
+                <a16:creationId xmlns:a16="http://schemas.microsoft.com/office/drawing/2014/main" id="{82A35CFD-3290-422D-95DF-285A8C5994AC}"/>
               </a:ext>
             </a:extLst>
           </p:cNvPr>
@@ -4865,7 +4865,7 @@
           <a:lstStyle xmlns:a="http://schemas.openxmlformats.org/drawingml/2006/main"/>
           <a:p xmlns:a="http://schemas.openxmlformats.org/drawingml/2006/main">
             <a:pPr algn="l">
-              <a:defRPr sz="788" b="0">
+              <a:defRPr sz="825" b="0">
                 <a:solidFill>
                   <a:srgbClr val="5F6B7A"/>
                 </a:solidFill>
@@ -4875,7 +4875,7 @@
               </a:defRPr>
             </a:pPr>
             <a:r>
-              <a:rPr sz="788" b="0">
+              <a:rPr sz="825" b="0">
                 <a:solidFill>
                   <a:srgbClr val="5F6B7A"/>
                 </a:solidFill>
@@ -4883,7 +4883,7 @@
                 <a:ea typeface="Aptos"/>
                 <a:cs typeface="Aptos"/>
               </a:rPr>
-              <a:t>Sources: 02_model_formulation.tex; 08_conclusion.tex. Recoverability is modeled through infection age and clean-backup horizon.</a:t>
+              <a:t>Provenance note: 02_model_formulation.tex; 08_conclusion.tex. Recoverability is modeled through infection age and clean-backup horizon.</a:t>
             </a:r>
           </a:p>
         </p:txBody>
@@ -4891,7 +4891,7 @@
     </p:spTree>
     <p:extLst>
       <p:ext uri="{BB962C8B-B14F-4D97-AF65-F5344CB8AC3E}">
-        <p14:creationId xmlns:p14="http://schemas.microsoft.com/office/powerpoint/2010/main" val="1164252294"/>
+        <p14:creationId xmlns:p14="http://schemas.microsoft.com/office/powerpoint/2010/main" val="909416849"/>
       </p:ext>
     </p:extLst>
   </p:cSld>
@@ -4915,7 +4915,7 @@
           <p:cNvPr id="1" name="">
             <a:extLst xmlns:a="http://schemas.openxmlformats.org/drawingml/2006/main">
               <a:ext uri="{FF2B5EF4-FFF2-40B4-BE49-F238E27FC236}">
-                <a16:creationId xmlns:a16="http://schemas.microsoft.com/office/drawing/2014/main" id="{3C4F26B2-B63B-44DB-9B4A-66721A0EE2D2}"/>
+                <a16:creationId xmlns:a16="http://schemas.microsoft.com/office/drawing/2014/main" id="{A1979F6B-4D61-4B02-800E-938A00DF04EE}"/>
               </a:ext>
             </a:extLst>
           </p:cNvPr>
@@ -4950,7 +4950,7 @@
           <p:cNvPr id="2" name="">
             <a:extLst xmlns:a="http://schemas.openxmlformats.org/drawingml/2006/main">
               <a:ext uri="{FF2B5EF4-FFF2-40B4-BE49-F238E27FC236}">
-                <a16:creationId xmlns:a16="http://schemas.microsoft.com/office/drawing/2014/main" id="{22849B93-7CAF-4A91-AD5A-0F9971D9602D}"/>
+                <a16:creationId xmlns:a16="http://schemas.microsoft.com/office/drawing/2014/main" id="{C63FF19B-658B-4C6C-BF46-1BEDF3D24610}"/>
               </a:ext>
             </a:extLst>
           </p:cNvPr>
@@ -4985,7 +4985,7 @@
           <p:cNvPr id="3" name="">
             <a:extLst xmlns:a="http://schemas.openxmlformats.org/drawingml/2006/main">
               <a:ext uri="{FF2B5EF4-FFF2-40B4-BE49-F238E27FC236}">
-                <a16:creationId xmlns:a16="http://schemas.microsoft.com/office/drawing/2014/main" id="{0D2206F8-E365-4029-A002-7B7A941B6B6B}"/>
+                <a16:creationId xmlns:a16="http://schemas.microsoft.com/office/drawing/2014/main" id="{83EA8F43-3CD6-4F5E-81BE-AC682B54FBFD}"/>
               </a:ext>
             </a:extLst>
           </p:cNvPr>
@@ -5049,7 +5049,7 @@
           <p:cNvPr id="4" name="">
             <a:extLst xmlns:a="http://schemas.openxmlformats.org/drawingml/2006/main">
               <a:ext uri="{FF2B5EF4-FFF2-40B4-BE49-F238E27FC236}">
-                <a16:creationId xmlns:a16="http://schemas.microsoft.com/office/drawing/2014/main" id="{48B4E38E-E3C5-48F3-9CB7-DB94EBF6E469}"/>
+                <a16:creationId xmlns:a16="http://schemas.microsoft.com/office/drawing/2014/main" id="{CD58A9F7-39E0-4DC8-A06F-85D968AC0D37}"/>
               </a:ext>
             </a:extLst>
           </p:cNvPr>
@@ -5113,7 +5113,7 @@
           <p:cNvPr id="5" name="">
             <a:extLst xmlns:a="http://schemas.openxmlformats.org/drawingml/2006/main">
               <a:ext uri="{FF2B5EF4-FFF2-40B4-BE49-F238E27FC236}">
-                <a16:creationId xmlns:a16="http://schemas.microsoft.com/office/drawing/2014/main" id="{6FCAAC3F-0A2B-483F-95F4-298C2E40A816}"/>
+                <a16:creationId xmlns:a16="http://schemas.microsoft.com/office/drawing/2014/main" id="{0907C498-5186-4FBC-96D4-248F466E94DE}"/>
               </a:ext>
             </a:extLst>
           </p:cNvPr>
@@ -5177,7 +5177,7 @@
           <p:cNvPr id="6" name="">
             <a:extLst xmlns:a="http://schemas.openxmlformats.org/drawingml/2006/main">
               <a:ext uri="{FF2B5EF4-FFF2-40B4-BE49-F238E27FC236}">
-                <a16:creationId xmlns:a16="http://schemas.microsoft.com/office/drawing/2014/main" id="{ADB5A8A1-F9BA-42AE-8D50-F60A9BC601EA}"/>
+                <a16:creationId xmlns:a16="http://schemas.microsoft.com/office/drawing/2014/main" id="{1F88A3A7-938F-4344-B32B-EB603CFD9B91}"/>
               </a:ext>
             </a:extLst>
           </p:cNvPr>
@@ -5241,7 +5241,7 @@
           <p:cNvPr id="7" name="">
             <a:extLst xmlns:a="http://schemas.openxmlformats.org/drawingml/2006/main">
               <a:ext uri="{FF2B5EF4-FFF2-40B4-BE49-F238E27FC236}">
-                <a16:creationId xmlns:a16="http://schemas.microsoft.com/office/drawing/2014/main" id="{84F6135A-176D-42F5-945B-E36926AAA45C}"/>
+                <a16:creationId xmlns:a16="http://schemas.microsoft.com/office/drawing/2014/main" id="{42405C06-163E-460B-B412-66CAFF87A78C}"/>
               </a:ext>
             </a:extLst>
           </p:cNvPr>
@@ -5274,7 +5274,7 @@
           <p:cNvPr id="8" name="">
             <a:extLst xmlns:a="http://schemas.openxmlformats.org/drawingml/2006/main">
               <a:ext uri="{FF2B5EF4-FFF2-40B4-BE49-F238E27FC236}">
-                <a16:creationId xmlns:a16="http://schemas.microsoft.com/office/drawing/2014/main" id="{DA33C3B7-CF6E-4A33-A9AE-E9EBCCE1AC72}"/>
+                <a16:creationId xmlns:a16="http://schemas.microsoft.com/office/drawing/2014/main" id="{A7D24DCA-A30D-4D94-A816-E4F4B3D04701}"/>
               </a:ext>
             </a:extLst>
           </p:cNvPr>
@@ -5338,7 +5338,7 @@
           <p:cNvPr id="9" name="">
             <a:extLst xmlns:a="http://schemas.openxmlformats.org/drawingml/2006/main">
               <a:ext uri="{FF2B5EF4-FFF2-40B4-BE49-F238E27FC236}">
-                <a16:creationId xmlns:a16="http://schemas.microsoft.com/office/drawing/2014/main" id="{13DDB4EF-C36D-4FCC-AA9E-3174AED479D1}"/>
+                <a16:creationId xmlns:a16="http://schemas.microsoft.com/office/drawing/2014/main" id="{A74838A5-2439-4416-AE97-E1539EC8998B}"/>
               </a:ext>
             </a:extLst>
           </p:cNvPr>
@@ -5373,7 +5373,7 @@
           <p:cNvPr id="10" name="">
             <a:extLst xmlns:a="http://schemas.openxmlformats.org/drawingml/2006/main">
               <a:ext uri="{FF2B5EF4-FFF2-40B4-BE49-F238E27FC236}">
-                <a16:creationId xmlns:a16="http://schemas.microsoft.com/office/drawing/2014/main" id="{A82A68D4-E29C-4513-A2C0-EDC9586C9708}"/>
+                <a16:creationId xmlns:a16="http://schemas.microsoft.com/office/drawing/2014/main" id="{11F85159-F396-49C6-948F-56604478B706}"/>
               </a:ext>
             </a:extLst>
           </p:cNvPr>
@@ -5437,7 +5437,7 @@
           <p:cNvPr id="11" name="">
             <a:extLst xmlns:a="http://schemas.openxmlformats.org/drawingml/2006/main">
               <a:ext uri="{FF2B5EF4-FFF2-40B4-BE49-F238E27FC236}">
-                <a16:creationId xmlns:a16="http://schemas.microsoft.com/office/drawing/2014/main" id="{4D007870-A2AA-4659-A0BB-3E1192DD6796}"/>
+                <a16:creationId xmlns:a16="http://schemas.microsoft.com/office/drawing/2014/main" id="{569EA592-EE89-432C-951B-5B12A202A228}"/>
               </a:ext>
             </a:extLst>
           </p:cNvPr>
@@ -5501,7 +5501,7 @@
           <p:cNvPr id="12" name="">
             <a:extLst xmlns:a="http://schemas.openxmlformats.org/drawingml/2006/main">
               <a:ext uri="{FF2B5EF4-FFF2-40B4-BE49-F238E27FC236}">
-                <a16:creationId xmlns:a16="http://schemas.microsoft.com/office/drawing/2014/main" id="{814A20B2-C31F-4D92-ABDC-CF6E50B73DA6}"/>
+                <a16:creationId xmlns:a16="http://schemas.microsoft.com/office/drawing/2014/main" id="{B30BCB8A-9EE9-4213-8DB4-40EA176E214B}"/>
               </a:ext>
             </a:extLst>
           </p:cNvPr>
@@ -5536,7 +5536,7 @@
           <p:cNvPr id="13" name="">
             <a:extLst xmlns:a="http://schemas.openxmlformats.org/drawingml/2006/main">
               <a:ext uri="{FF2B5EF4-FFF2-40B4-BE49-F238E27FC236}">
-                <a16:creationId xmlns:a16="http://schemas.microsoft.com/office/drawing/2014/main" id="{E6387DBC-F581-4FD7-A5CF-B379F46733AC}"/>
+                <a16:creationId xmlns:a16="http://schemas.microsoft.com/office/drawing/2014/main" id="{B26B04FD-E710-4DBC-A96F-4FD4A8E87FC4}"/>
               </a:ext>
             </a:extLst>
           </p:cNvPr>
@@ -5571,7 +5571,7 @@
           <p:cNvPr id="14" name="">
             <a:extLst xmlns:a="http://schemas.openxmlformats.org/drawingml/2006/main">
               <a:ext uri="{FF2B5EF4-FFF2-40B4-BE49-F238E27FC236}">
-                <a16:creationId xmlns:a16="http://schemas.microsoft.com/office/drawing/2014/main" id="{3DEB3713-EB15-4D02-9153-39F1B4F628AA}"/>
+                <a16:creationId xmlns:a16="http://schemas.microsoft.com/office/drawing/2014/main" id="{DCA0EC3C-8E7D-4366-8FDA-E1C4F5F118C4}"/>
               </a:ext>
             </a:extLst>
           </p:cNvPr>
@@ -5606,7 +5606,7 @@
           <p:cNvPr id="15" name="">
             <a:extLst xmlns:a="http://schemas.openxmlformats.org/drawingml/2006/main">
               <a:ext uri="{FF2B5EF4-FFF2-40B4-BE49-F238E27FC236}">
-                <a16:creationId xmlns:a16="http://schemas.microsoft.com/office/drawing/2014/main" id="{4FA0D51D-945A-4082-9C69-DE58D6499AD3}"/>
+                <a16:creationId xmlns:a16="http://schemas.microsoft.com/office/drawing/2014/main" id="{78E4EED0-A827-4D9F-AC22-8D737B3DEB2C}"/>
               </a:ext>
             </a:extLst>
           </p:cNvPr>
@@ -5641,7 +5641,7 @@
           <p:cNvPr id="16" name="">
             <a:extLst xmlns:a="http://schemas.openxmlformats.org/drawingml/2006/main">
               <a:ext uri="{FF2B5EF4-FFF2-40B4-BE49-F238E27FC236}">
-                <a16:creationId xmlns:a16="http://schemas.microsoft.com/office/drawing/2014/main" id="{AC8EC1ED-3AC6-4946-9FB2-26E6FDEDCD3A}"/>
+                <a16:creationId xmlns:a16="http://schemas.microsoft.com/office/drawing/2014/main" id="{95E8CD0B-6309-4C75-9DD2-5602E4060EAA}"/>
               </a:ext>
             </a:extLst>
           </p:cNvPr>
@@ -5676,7 +5676,7 @@
           <p:cNvPr id="17" name="">
             <a:extLst xmlns:a="http://schemas.openxmlformats.org/drawingml/2006/main">
               <a:ext uri="{FF2B5EF4-FFF2-40B4-BE49-F238E27FC236}">
-                <a16:creationId xmlns:a16="http://schemas.microsoft.com/office/drawing/2014/main" id="{EDCA2427-117A-4936-BF0E-198B2618296E}"/>
+                <a16:creationId xmlns:a16="http://schemas.microsoft.com/office/drawing/2014/main" id="{91B8CA3F-4972-47FB-9056-9AE23A22ADC6}"/>
               </a:ext>
             </a:extLst>
           </p:cNvPr>
@@ -5711,7 +5711,7 @@
           <p:cNvPr id="18" name="">
             <a:extLst xmlns:a="http://schemas.openxmlformats.org/drawingml/2006/main">
               <a:ext uri="{FF2B5EF4-FFF2-40B4-BE49-F238E27FC236}">
-                <a16:creationId xmlns:a16="http://schemas.microsoft.com/office/drawing/2014/main" id="{455855DA-FE51-4E13-82D3-523591663A77}"/>
+                <a16:creationId xmlns:a16="http://schemas.microsoft.com/office/drawing/2014/main" id="{BF782DD6-EA80-413C-B525-556FA7A3C8BC}"/>
               </a:ext>
             </a:extLst>
           </p:cNvPr>
@@ -5744,7 +5744,7 @@
           <p:cNvPr id="19" name="">
             <a:extLst xmlns:a="http://schemas.openxmlformats.org/drawingml/2006/main">
               <a:ext uri="{FF2B5EF4-FFF2-40B4-BE49-F238E27FC236}">
-                <a16:creationId xmlns:a16="http://schemas.microsoft.com/office/drawing/2014/main" id="{580A0978-C23E-40F0-A733-40472992ABC3}"/>
+                <a16:creationId xmlns:a16="http://schemas.microsoft.com/office/drawing/2014/main" id="{DC10534D-706F-4211-96D7-2EDAFDA9AF9F}"/>
               </a:ext>
             </a:extLst>
           </p:cNvPr>
@@ -5808,7 +5808,7 @@
           <p:cNvPr id="20" name="">
             <a:extLst xmlns:a="http://schemas.openxmlformats.org/drawingml/2006/main">
               <a:ext uri="{FF2B5EF4-FFF2-40B4-BE49-F238E27FC236}">
-                <a16:creationId xmlns:a16="http://schemas.microsoft.com/office/drawing/2014/main" id="{AA31E898-CE18-4CE2-9361-A098B8589FD1}"/>
+                <a16:creationId xmlns:a16="http://schemas.microsoft.com/office/drawing/2014/main" id="{CF1859C4-5326-493B-829A-02D89DE50B4E}"/>
               </a:ext>
             </a:extLst>
           </p:cNvPr>
@@ -5895,7 +5895,7 @@
           <p:cNvPr id="21" name="">
             <a:extLst xmlns:a="http://schemas.openxmlformats.org/drawingml/2006/main">
               <a:ext uri="{FF2B5EF4-FFF2-40B4-BE49-F238E27FC236}">
-                <a16:creationId xmlns:a16="http://schemas.microsoft.com/office/drawing/2014/main" id="{7B8A59F6-1C71-4284-9994-36DC001075C7}"/>
+                <a16:creationId xmlns:a16="http://schemas.microsoft.com/office/drawing/2014/main" id="{70F342BD-AA89-46C4-AB09-0282B0313F31}"/>
               </a:ext>
             </a:extLst>
           </p:cNvPr>
@@ -5928,7 +5928,7 @@
           <p:cNvPr id="22" name="">
             <a:extLst xmlns:a="http://schemas.openxmlformats.org/drawingml/2006/main">
               <a:ext uri="{FF2B5EF4-FFF2-40B4-BE49-F238E27FC236}">
-                <a16:creationId xmlns:a16="http://schemas.microsoft.com/office/drawing/2014/main" id="{7AEB560D-19EC-4A53-B808-D0A2C892B69D}"/>
+                <a16:creationId xmlns:a16="http://schemas.microsoft.com/office/drawing/2014/main" id="{CDAD7B81-8291-42F3-BED3-E9B675483F9A}"/>
               </a:ext>
             </a:extLst>
           </p:cNvPr>
@@ -5992,7 +5992,7 @@
           <p:cNvPr id="23" name="">
             <a:extLst xmlns:a="http://schemas.openxmlformats.org/drawingml/2006/main">
               <a:ext uri="{FF2B5EF4-FFF2-40B4-BE49-F238E27FC236}">
-                <a16:creationId xmlns:a16="http://schemas.microsoft.com/office/drawing/2014/main" id="{6BF4388A-CB5C-4AC7-A74F-55415AE5F491}"/>
+                <a16:creationId xmlns:a16="http://schemas.microsoft.com/office/drawing/2014/main" id="{23E87CBF-51B6-4A91-8423-2F52E4422A72}"/>
               </a:ext>
             </a:extLst>
           </p:cNvPr>
@@ -6027,7 +6027,7 @@
           <p:cNvPr id="24" name="">
             <a:extLst xmlns:a="http://schemas.openxmlformats.org/drawingml/2006/main">
               <a:ext uri="{FF2B5EF4-FFF2-40B4-BE49-F238E27FC236}">
-                <a16:creationId xmlns:a16="http://schemas.microsoft.com/office/drawing/2014/main" id="{E176350A-D01E-48FF-9275-56A7364DA48B}"/>
+                <a16:creationId xmlns:a16="http://schemas.microsoft.com/office/drawing/2014/main" id="{1EF2A98E-0C4C-4F27-AB0C-495BD63C61C8}"/>
               </a:ext>
             </a:extLst>
           </p:cNvPr>
@@ -6091,7 +6091,7 @@
           <p:cNvPr id="25" name="">
             <a:extLst xmlns:a="http://schemas.openxmlformats.org/drawingml/2006/main">
               <a:ext uri="{FF2B5EF4-FFF2-40B4-BE49-F238E27FC236}">
-                <a16:creationId xmlns:a16="http://schemas.microsoft.com/office/drawing/2014/main" id="{8D459F06-563B-46A6-89FF-C4694B5E12A0}"/>
+                <a16:creationId xmlns:a16="http://schemas.microsoft.com/office/drawing/2014/main" id="{A3C52FF9-21AF-4BBC-918A-EAE94ECCC916}"/>
               </a:ext>
             </a:extLst>
           </p:cNvPr>
@@ -6126,7 +6126,7 @@
           <p:cNvPr id="26" name="">
             <a:extLst xmlns:a="http://schemas.openxmlformats.org/drawingml/2006/main">
               <a:ext uri="{FF2B5EF4-FFF2-40B4-BE49-F238E27FC236}">
-                <a16:creationId xmlns:a16="http://schemas.microsoft.com/office/drawing/2014/main" id="{11D34B0B-B5B8-4A6C-B9DD-B6CA6B17BC0F}"/>
+                <a16:creationId xmlns:a16="http://schemas.microsoft.com/office/drawing/2014/main" id="{320A006A-8EFB-4D93-B24A-7A6274B4126F}"/>
               </a:ext>
             </a:extLst>
           </p:cNvPr>
@@ -6161,7 +6161,7 @@
           <p:cNvPr id="27" name="">
             <a:extLst xmlns:a="http://schemas.openxmlformats.org/drawingml/2006/main">
               <a:ext uri="{FF2B5EF4-FFF2-40B4-BE49-F238E27FC236}">
-                <a16:creationId xmlns:a16="http://schemas.microsoft.com/office/drawing/2014/main" id="{8FA847BE-6FB0-4E8D-9587-9BFDA32300CF}"/>
+                <a16:creationId xmlns:a16="http://schemas.microsoft.com/office/drawing/2014/main" id="{81C90519-9ADA-4ACA-AE8A-B59D6313289B}"/>
               </a:ext>
             </a:extLst>
           </p:cNvPr>
@@ -6196,7 +6196,7 @@
           <p:cNvPr id="28" name="">
             <a:extLst xmlns:a="http://schemas.openxmlformats.org/drawingml/2006/main">
               <a:ext uri="{FF2B5EF4-FFF2-40B4-BE49-F238E27FC236}">
-                <a16:creationId xmlns:a16="http://schemas.microsoft.com/office/drawing/2014/main" id="{30C596A2-DC1A-4C0C-BB3E-4DFAE8BEB727}"/>
+                <a16:creationId xmlns:a16="http://schemas.microsoft.com/office/drawing/2014/main" id="{A16878F1-31BA-4203-A5ED-89B2A3588F4A}"/>
               </a:ext>
             </a:extLst>
           </p:cNvPr>
@@ -6231,7 +6231,7 @@
           <p:cNvPr id="29" name="">
             <a:extLst xmlns:a="http://schemas.openxmlformats.org/drawingml/2006/main">
               <a:ext uri="{FF2B5EF4-FFF2-40B4-BE49-F238E27FC236}">
-                <a16:creationId xmlns:a16="http://schemas.microsoft.com/office/drawing/2014/main" id="{91458108-0E5A-41B8-94DD-EC95FB6CECB6}"/>
+                <a16:creationId xmlns:a16="http://schemas.microsoft.com/office/drawing/2014/main" id="{BDD4D4B5-7D59-4139-BAC8-457BAD8C9107}"/>
               </a:ext>
             </a:extLst>
           </p:cNvPr>
@@ -6266,7 +6266,7 @@
           <p:cNvPr id="30" name="">
             <a:extLst xmlns:a="http://schemas.openxmlformats.org/drawingml/2006/main">
               <a:ext uri="{FF2B5EF4-FFF2-40B4-BE49-F238E27FC236}">
-                <a16:creationId xmlns:a16="http://schemas.microsoft.com/office/drawing/2014/main" id="{54052F8F-D2C1-4D76-AB0E-849289D4783C}"/>
+                <a16:creationId xmlns:a16="http://schemas.microsoft.com/office/drawing/2014/main" id="{B69685F7-CBE0-4564-BA25-8174B6308BD1}"/>
               </a:ext>
             </a:extLst>
           </p:cNvPr>
@@ -6301,7 +6301,7 @@
           <p:cNvPr id="31" name="">
             <a:extLst xmlns:a="http://schemas.openxmlformats.org/drawingml/2006/main">
               <a:ext uri="{FF2B5EF4-FFF2-40B4-BE49-F238E27FC236}">
-                <a16:creationId xmlns:a16="http://schemas.microsoft.com/office/drawing/2014/main" id="{3061117D-D37A-42F0-932E-5F95DC2C76BA}"/>
+                <a16:creationId xmlns:a16="http://schemas.microsoft.com/office/drawing/2014/main" id="{7FE72555-36E0-4829-AA5A-C9A57D740CDA}"/>
               </a:ext>
             </a:extLst>
           </p:cNvPr>
@@ -6336,7 +6336,7 @@
           <p:cNvPr id="32" name="">
             <a:extLst xmlns:a="http://schemas.openxmlformats.org/drawingml/2006/main">
               <a:ext uri="{FF2B5EF4-FFF2-40B4-BE49-F238E27FC236}">
-                <a16:creationId xmlns:a16="http://schemas.microsoft.com/office/drawing/2014/main" id="{CC3A4CBC-F83B-4685-8CB2-6CA299474D71}"/>
+                <a16:creationId xmlns:a16="http://schemas.microsoft.com/office/drawing/2014/main" id="{17AF2D76-E744-48FF-BF5B-FB7D32F65A82}"/>
               </a:ext>
             </a:extLst>
           </p:cNvPr>
@@ -6371,7 +6371,7 @@
           <p:cNvPr id="33" name="">
             <a:extLst xmlns:a="http://schemas.openxmlformats.org/drawingml/2006/main">
               <a:ext uri="{FF2B5EF4-FFF2-40B4-BE49-F238E27FC236}">
-                <a16:creationId xmlns:a16="http://schemas.microsoft.com/office/drawing/2014/main" id="{EFB76F32-ED78-4CF2-B24E-15C6676ABC94}"/>
+                <a16:creationId xmlns:a16="http://schemas.microsoft.com/office/drawing/2014/main" id="{9043A4C5-27BD-4DA4-83F9-9F9693E43BE0}"/>
               </a:ext>
             </a:extLst>
           </p:cNvPr>
@@ -6406,7 +6406,7 @@
           <p:cNvPr id="34" name="">
             <a:extLst xmlns:a="http://schemas.openxmlformats.org/drawingml/2006/main">
               <a:ext uri="{FF2B5EF4-FFF2-40B4-BE49-F238E27FC236}">
-                <a16:creationId xmlns:a16="http://schemas.microsoft.com/office/drawing/2014/main" id="{068EE2E7-E392-416B-929C-34AE53861604}"/>
+                <a16:creationId xmlns:a16="http://schemas.microsoft.com/office/drawing/2014/main" id="{767A461F-DA5E-454E-B85C-91F6701DF503}"/>
               </a:ext>
             </a:extLst>
           </p:cNvPr>
@@ -6439,7 +6439,7 @@
           <p:cNvPr id="35" name="">
             <a:extLst xmlns:a="http://schemas.openxmlformats.org/drawingml/2006/main">
               <a:ext uri="{FF2B5EF4-FFF2-40B4-BE49-F238E27FC236}">
-                <a16:creationId xmlns:a16="http://schemas.microsoft.com/office/drawing/2014/main" id="{7EDCA87A-124B-4FEC-BA81-552721BB13CE}"/>
+                <a16:creationId xmlns:a16="http://schemas.microsoft.com/office/drawing/2014/main" id="{FCCE8FC9-33FC-4E78-8142-375106CD99DE}"/>
               </a:ext>
             </a:extLst>
           </p:cNvPr>
@@ -6503,7 +6503,7 @@
           <p:cNvPr id="36" name="">
             <a:extLst xmlns:a="http://schemas.openxmlformats.org/drawingml/2006/main">
               <a:ext uri="{FF2B5EF4-FFF2-40B4-BE49-F238E27FC236}">
-                <a16:creationId xmlns:a16="http://schemas.microsoft.com/office/drawing/2014/main" id="{9DF2DE45-65CC-448E-BA24-6BE965E58023}"/>
+                <a16:creationId xmlns:a16="http://schemas.microsoft.com/office/drawing/2014/main" id="{D0562945-E3BB-4305-B97A-FB9DBF166862}"/>
               </a:ext>
             </a:extLst>
           </p:cNvPr>
@@ -6590,7 +6590,7 @@
           <p:cNvPr id="37" name="">
             <a:extLst xmlns:a="http://schemas.openxmlformats.org/drawingml/2006/main">
               <a:ext uri="{FF2B5EF4-FFF2-40B4-BE49-F238E27FC236}">
-                <a16:creationId xmlns:a16="http://schemas.microsoft.com/office/drawing/2014/main" id="{D8BB58B6-E750-4D07-8C68-8BA8BD42DADA}"/>
+                <a16:creationId xmlns:a16="http://schemas.microsoft.com/office/drawing/2014/main" id="{9D2FF2AF-C5DD-463A-B000-8E9D0C8D90E5}"/>
               </a:ext>
             </a:extLst>
           </p:cNvPr>
@@ -6654,7 +6654,7 @@
           <p:cNvPr id="38" name="">
             <a:extLst xmlns:a="http://schemas.openxmlformats.org/drawingml/2006/main">
               <a:ext uri="{FF2B5EF4-FFF2-40B4-BE49-F238E27FC236}">
-                <a16:creationId xmlns:a16="http://schemas.microsoft.com/office/drawing/2014/main" id="{5BEC6E52-0624-4E43-9B02-55E7A06F7B25}"/>
+                <a16:creationId xmlns:a16="http://schemas.microsoft.com/office/drawing/2014/main" id="{560BD321-23F3-4B1E-BDDE-3337995302D2}"/>
               </a:ext>
             </a:extLst>
           </p:cNvPr>
@@ -6689,7 +6689,7 @@
           <p:cNvPr id="39" name="">
             <a:extLst xmlns:a="http://schemas.openxmlformats.org/drawingml/2006/main">
               <a:ext uri="{FF2B5EF4-FFF2-40B4-BE49-F238E27FC236}">
-                <a16:creationId xmlns:a16="http://schemas.microsoft.com/office/drawing/2014/main" id="{E5F21599-CF29-4EFF-8FEB-7C599BB8AB5F}"/>
+                <a16:creationId xmlns:a16="http://schemas.microsoft.com/office/drawing/2014/main" id="{2EA2BB9D-5B5F-46AF-B87C-FE24C4851513}"/>
               </a:ext>
             </a:extLst>
           </p:cNvPr>
@@ -6725,7 +6725,7 @@
           <a:lstStyle xmlns:a="http://schemas.openxmlformats.org/drawingml/2006/main"/>
           <a:p xmlns:a="http://schemas.openxmlformats.org/drawingml/2006/main">
             <a:pPr algn="l">
-              <a:defRPr sz="788" b="0">
+              <a:defRPr sz="825" b="0">
                 <a:solidFill>
                   <a:srgbClr val="5F6B7A"/>
                 </a:solidFill>
@@ -6735,7 +6735,7 @@
               </a:defRPr>
             </a:pPr>
             <a:r>
-              <a:rPr sz="788" b="0">
+              <a:rPr sz="825" b="0">
                 <a:solidFill>
                   <a:srgbClr val="5F6B7A"/>
                 </a:solidFill>
@@ -6743,7 +6743,7 @@
                 <a:ea typeface="Aptos"/>
                 <a:cs typeface="Aptos"/>
               </a:rPr>
-              <a:t>Sources: 01_introduction.tex; 04_tauber_transition.tex. Pareto dwell time is a model assumption, not an empirical claim.</a:t>
+              <a:t>Provenance note: 01_introduction.tex; 04_tauber_transition.tex. Pareto dwell time is a model assumption, not an empirical claim.</a:t>
             </a:r>
           </a:p>
         </p:txBody>
@@ -6751,7 +6751,7 @@
     </p:spTree>
     <p:extLst>
       <p:ext uri="{BB962C8B-B14F-4D97-AF65-F5344CB8AC3E}">
-        <p14:creationId xmlns:p14="http://schemas.microsoft.com/office/powerpoint/2010/main" val="1773364478"/>
+        <p14:creationId xmlns:p14="http://schemas.microsoft.com/office/powerpoint/2010/main" val="1686616176"/>
       </p:ext>
     </p:extLst>
   </p:cSld>
@@ -6775,7 +6775,7 @@
           <p:cNvPr id="1" name="">
             <a:extLst xmlns:a="http://schemas.openxmlformats.org/drawingml/2006/main">
               <a:ext uri="{FF2B5EF4-FFF2-40B4-BE49-F238E27FC236}">
-                <a16:creationId xmlns:a16="http://schemas.microsoft.com/office/drawing/2014/main" id="{CCB00377-80B9-4E48-B1B8-8C22F55180FA}"/>
+                <a16:creationId xmlns:a16="http://schemas.microsoft.com/office/drawing/2014/main" id="{256B8C5B-8C9D-49B1-8477-79DA4CFFEF7E}"/>
               </a:ext>
             </a:extLst>
           </p:cNvPr>
@@ -6810,7 +6810,7 @@
           <p:cNvPr id="2" name="">
             <a:extLst xmlns:a="http://schemas.openxmlformats.org/drawingml/2006/main">
               <a:ext uri="{FF2B5EF4-FFF2-40B4-BE49-F238E27FC236}">
-                <a16:creationId xmlns:a16="http://schemas.microsoft.com/office/drawing/2014/main" id="{3FA38B96-A8E9-4416-89A9-318807712E37}"/>
+                <a16:creationId xmlns:a16="http://schemas.microsoft.com/office/drawing/2014/main" id="{C6EAD2AA-5C89-46F9-AB33-52B44E8A64FC}"/>
               </a:ext>
             </a:extLst>
           </p:cNvPr>
@@ -6845,7 +6845,7 @@
           <p:cNvPr id="3" name="">
             <a:extLst xmlns:a="http://schemas.openxmlformats.org/drawingml/2006/main">
               <a:ext uri="{FF2B5EF4-FFF2-40B4-BE49-F238E27FC236}">
-                <a16:creationId xmlns:a16="http://schemas.microsoft.com/office/drawing/2014/main" id="{A22AD0A9-F3F1-4013-BCA4-9BF95E86C710}"/>
+                <a16:creationId xmlns:a16="http://schemas.microsoft.com/office/drawing/2014/main" id="{C634CD00-1DAA-40EF-A9ED-525F3A0C46A0}"/>
               </a:ext>
             </a:extLst>
           </p:cNvPr>
@@ -6909,7 +6909,7 @@
           <p:cNvPr id="4" name="">
             <a:extLst xmlns:a="http://schemas.openxmlformats.org/drawingml/2006/main">
               <a:ext uri="{FF2B5EF4-FFF2-40B4-BE49-F238E27FC236}">
-                <a16:creationId xmlns:a16="http://schemas.microsoft.com/office/drawing/2014/main" id="{CDADEC0B-F2F0-4B3F-B60B-FA2C2DD59EFF}"/>
+                <a16:creationId xmlns:a16="http://schemas.microsoft.com/office/drawing/2014/main" id="{AAD77260-5DCA-4901-A4A6-E1DD63F8F63E}"/>
               </a:ext>
             </a:extLst>
           </p:cNvPr>
@@ -6973,7 +6973,7 @@
           <p:cNvPr id="5" name="">
             <a:extLst xmlns:a="http://schemas.openxmlformats.org/drawingml/2006/main">
               <a:ext uri="{FF2B5EF4-FFF2-40B4-BE49-F238E27FC236}">
-                <a16:creationId xmlns:a16="http://schemas.microsoft.com/office/drawing/2014/main" id="{5691A5C8-D9B3-450F-8498-BAB019C1DA59}"/>
+                <a16:creationId xmlns:a16="http://schemas.microsoft.com/office/drawing/2014/main" id="{B93EC985-8BB9-4946-85FB-EA28E4F67BC6}"/>
               </a:ext>
             </a:extLst>
           </p:cNvPr>
@@ -7037,7 +7037,7 @@
           <p:cNvPr id="6" name="">
             <a:extLst xmlns:a="http://schemas.openxmlformats.org/drawingml/2006/main">
               <a:ext uri="{FF2B5EF4-FFF2-40B4-BE49-F238E27FC236}">
-                <a16:creationId xmlns:a16="http://schemas.microsoft.com/office/drawing/2014/main" id="{6BDEE40A-16B5-4EE7-89F4-ACAF0AA59C50}"/>
+                <a16:creationId xmlns:a16="http://schemas.microsoft.com/office/drawing/2014/main" id="{DF36F3C5-CEE7-4E2E-845F-E2A2CAF7B1E2}"/>
               </a:ext>
             </a:extLst>
           </p:cNvPr>
@@ -7101,7 +7101,7 @@
           <p:cNvPr id="7" name="">
             <a:extLst xmlns:a="http://schemas.openxmlformats.org/drawingml/2006/main">
               <a:ext uri="{FF2B5EF4-FFF2-40B4-BE49-F238E27FC236}">
-                <a16:creationId xmlns:a16="http://schemas.microsoft.com/office/drawing/2014/main" id="{DB973498-A7A5-454A-A3F4-97BA21BAF3AC}"/>
+                <a16:creationId xmlns:a16="http://schemas.microsoft.com/office/drawing/2014/main" id="{BB96269F-BEE6-43B9-9D6E-98B6932BD5BF}"/>
               </a:ext>
             </a:extLst>
           </p:cNvPr>
@@ -7134,7 +7134,7 @@
           <p:cNvPr id="8" name="">
             <a:extLst xmlns:a="http://schemas.openxmlformats.org/drawingml/2006/main">
               <a:ext uri="{FF2B5EF4-FFF2-40B4-BE49-F238E27FC236}">
-                <a16:creationId xmlns:a16="http://schemas.microsoft.com/office/drawing/2014/main" id="{71B316AF-E7EE-423C-9040-2D2FD9AF6BDB}"/>
+                <a16:creationId xmlns:a16="http://schemas.microsoft.com/office/drawing/2014/main" id="{A3A14C6C-6826-4DF8-BD8E-5520B4FF1462}"/>
               </a:ext>
             </a:extLst>
           </p:cNvPr>
@@ -7198,7 +7198,7 @@
           <p:cNvPr id="9" name="">
             <a:extLst xmlns:a="http://schemas.openxmlformats.org/drawingml/2006/main">
               <a:ext uri="{FF2B5EF4-FFF2-40B4-BE49-F238E27FC236}">
-                <a16:creationId xmlns:a16="http://schemas.microsoft.com/office/drawing/2014/main" id="{8995824B-4066-4B6E-A0E0-F6079846A52B}"/>
+                <a16:creationId xmlns:a16="http://schemas.microsoft.com/office/drawing/2014/main" id="{6BF6C22A-0666-40E7-B402-6D02E55B309A}"/>
               </a:ext>
             </a:extLst>
           </p:cNvPr>
@@ -7262,7 +7262,7 @@
           <p:cNvPr id="10" name="">
             <a:extLst xmlns:a="http://schemas.openxmlformats.org/drawingml/2006/main">
               <a:ext uri="{FF2B5EF4-FFF2-40B4-BE49-F238E27FC236}">
-                <a16:creationId xmlns:a16="http://schemas.microsoft.com/office/drawing/2014/main" id="{2A7BEB54-200F-4B2D-AAE2-C16EF5C7464D}"/>
+                <a16:creationId xmlns:a16="http://schemas.microsoft.com/office/drawing/2014/main" id="{F7510E15-BDD2-4596-818B-02829CACAD61}"/>
               </a:ext>
             </a:extLst>
           </p:cNvPr>
@@ -7326,7 +7326,7 @@
           <p:cNvPr id="11" name="">
             <a:extLst xmlns:a="http://schemas.openxmlformats.org/drawingml/2006/main">
               <a:ext uri="{FF2B5EF4-FFF2-40B4-BE49-F238E27FC236}">
-                <a16:creationId xmlns:a16="http://schemas.microsoft.com/office/drawing/2014/main" id="{26774185-0C43-493A-8D92-8A75C89CE2D3}"/>
+                <a16:creationId xmlns:a16="http://schemas.microsoft.com/office/drawing/2014/main" id="{0F280001-72B0-46CD-A4E5-FC9D01986413}"/>
               </a:ext>
             </a:extLst>
           </p:cNvPr>
@@ -7359,7 +7359,7 @@
           <p:cNvPr id="12" name="">
             <a:extLst xmlns:a="http://schemas.openxmlformats.org/drawingml/2006/main">
               <a:ext uri="{FF2B5EF4-FFF2-40B4-BE49-F238E27FC236}">
-                <a16:creationId xmlns:a16="http://schemas.microsoft.com/office/drawing/2014/main" id="{4B83E618-0505-4158-A95F-ADDB8605BE86}"/>
+                <a16:creationId xmlns:a16="http://schemas.microsoft.com/office/drawing/2014/main" id="{5C8D3ABD-AD78-4A51-AC96-EF869C089B3B}"/>
               </a:ext>
             </a:extLst>
           </p:cNvPr>
@@ -7423,7 +7423,7 @@
           <p:cNvPr id="13" name="">
             <a:extLst xmlns:a="http://schemas.openxmlformats.org/drawingml/2006/main">
               <a:ext uri="{FF2B5EF4-FFF2-40B4-BE49-F238E27FC236}">
-                <a16:creationId xmlns:a16="http://schemas.microsoft.com/office/drawing/2014/main" id="{01EB471B-7D98-4837-BD9D-1676BFF431F1}"/>
+                <a16:creationId xmlns:a16="http://schemas.microsoft.com/office/drawing/2014/main" id="{B37AA8A3-27CA-415B-A799-9317C42E91BE}"/>
               </a:ext>
             </a:extLst>
           </p:cNvPr>
@@ -7456,7 +7456,7 @@
           <p:cNvPr id="14" name="">
             <a:extLst xmlns:a="http://schemas.openxmlformats.org/drawingml/2006/main">
               <a:ext uri="{FF2B5EF4-FFF2-40B4-BE49-F238E27FC236}">
-                <a16:creationId xmlns:a16="http://schemas.microsoft.com/office/drawing/2014/main" id="{79C79667-061C-4D0D-97B5-BA36D085E2E6}"/>
+                <a16:creationId xmlns:a16="http://schemas.microsoft.com/office/drawing/2014/main" id="{C6AE0F13-0BDB-40D1-9560-71CD1A775584}"/>
               </a:ext>
             </a:extLst>
           </p:cNvPr>
@@ -7520,7 +7520,7 @@
           <p:cNvPr id="15" name="">
             <a:extLst xmlns:a="http://schemas.openxmlformats.org/drawingml/2006/main">
               <a:ext uri="{FF2B5EF4-FFF2-40B4-BE49-F238E27FC236}">
-                <a16:creationId xmlns:a16="http://schemas.microsoft.com/office/drawing/2014/main" id="{ED574B86-7ACE-465B-9AD7-02876D808F5C}"/>
+                <a16:creationId xmlns:a16="http://schemas.microsoft.com/office/drawing/2014/main" id="{DF2A15C4-4171-474A-9252-8DF82F467756}"/>
               </a:ext>
             </a:extLst>
           </p:cNvPr>
@@ -7553,7 +7553,7 @@
           <p:cNvPr id="16" name="">
             <a:extLst xmlns:a="http://schemas.openxmlformats.org/drawingml/2006/main">
               <a:ext uri="{FF2B5EF4-FFF2-40B4-BE49-F238E27FC236}">
-                <a16:creationId xmlns:a16="http://schemas.microsoft.com/office/drawing/2014/main" id="{E92F38DD-EA04-43A4-BBF5-794AE0D97525}"/>
+                <a16:creationId xmlns:a16="http://schemas.microsoft.com/office/drawing/2014/main" id="{DF367781-E48A-4DD9-A642-59F1C15AAD10}"/>
               </a:ext>
             </a:extLst>
           </p:cNvPr>
@@ -7617,7 +7617,7 @@
           <p:cNvPr id="17" name="">
             <a:extLst xmlns:a="http://schemas.openxmlformats.org/drawingml/2006/main">
               <a:ext uri="{FF2B5EF4-FFF2-40B4-BE49-F238E27FC236}">
-                <a16:creationId xmlns:a16="http://schemas.microsoft.com/office/drawing/2014/main" id="{18B59D26-CFBD-4EC2-994E-67ADC4A198FB}"/>
+                <a16:creationId xmlns:a16="http://schemas.microsoft.com/office/drawing/2014/main" id="{F49564D7-525E-4F32-AC74-3DAEBCE584E7}"/>
               </a:ext>
             </a:extLst>
           </p:cNvPr>
@@ -7650,7 +7650,7 @@
           <p:cNvPr id="18" name="">
             <a:extLst xmlns:a="http://schemas.openxmlformats.org/drawingml/2006/main">
               <a:ext uri="{FF2B5EF4-FFF2-40B4-BE49-F238E27FC236}">
-                <a16:creationId xmlns:a16="http://schemas.microsoft.com/office/drawing/2014/main" id="{E45E4182-1B1B-4CF2-8555-F36B7A9E4479}"/>
+                <a16:creationId xmlns:a16="http://schemas.microsoft.com/office/drawing/2014/main" id="{26F0E6AF-713D-497C-B98C-2616006890CB}"/>
               </a:ext>
             </a:extLst>
           </p:cNvPr>
@@ -7714,18 +7714,18 @@
           <p:cNvPr id="19" name="">
             <a:extLst xmlns:a="http://schemas.openxmlformats.org/drawingml/2006/main">
               <a:ext uri="{FF2B5EF4-FFF2-40B4-BE49-F238E27FC236}">
-                <a16:creationId xmlns:a16="http://schemas.microsoft.com/office/drawing/2014/main" id="{D83B32C8-1ECA-4DA4-B506-2D29587E19F3}"/>
-              </a:ext>
-            </a:extLst>
-          </p:cNvPr>
-          <p:cNvSpPr>
-            <a:spLocks xmlns:a="http://schemas.openxmlformats.org/drawingml/2006/main" noGrp="1"/>
-          </p:cNvSpPr>
-          <p:nvPr/>
-        </p:nvSpPr>
-        <p:spPr>
-          <a:xfrm xmlns:a="http://schemas.openxmlformats.org/drawingml/2006/main">
-            <a:off x="7562850" y="3352800"/>
+                <a16:creationId xmlns:a16="http://schemas.microsoft.com/office/drawing/2014/main" id="{2E949FFC-C90D-413A-BA13-2542D094D910}"/>
+              </a:ext>
+            </a:extLst>
+          </p:cNvPr>
+          <p:cNvSpPr>
+            <a:spLocks xmlns:a="http://schemas.openxmlformats.org/drawingml/2006/main" noGrp="1"/>
+          </p:cNvSpPr>
+          <p:nvPr/>
+        </p:nvSpPr>
+        <p:spPr>
+          <a:xfrm xmlns:a="http://schemas.openxmlformats.org/drawingml/2006/main">
+            <a:off x="7562850" y="3390900"/>
             <a:ext cx="85725" cy="85725"/>
           </a:xfrm>
           <a:prstGeom xmlns:a="http://schemas.openxmlformats.org/drawingml/2006/main" prst="ellipse">
@@ -7749,18 +7749,18 @@
           <p:cNvPr id="20" name="">
             <a:extLst xmlns:a="http://schemas.openxmlformats.org/drawingml/2006/main">
               <a:ext uri="{FF2B5EF4-FFF2-40B4-BE49-F238E27FC236}">
-                <a16:creationId xmlns:a16="http://schemas.microsoft.com/office/drawing/2014/main" id="{10144200-1BA5-4054-92AC-EAF7BD632FB5}"/>
-              </a:ext>
-            </a:extLst>
-          </p:cNvPr>
-          <p:cNvSpPr>
-            <a:spLocks xmlns:a="http://schemas.openxmlformats.org/drawingml/2006/main" noGrp="1"/>
-          </p:cNvSpPr>
-          <p:nvPr/>
-        </p:nvSpPr>
-        <p:spPr>
-          <a:xfrm xmlns:a="http://schemas.openxmlformats.org/drawingml/2006/main">
-            <a:off x="7772400" y="3276600"/>
+                <a16:creationId xmlns:a16="http://schemas.microsoft.com/office/drawing/2014/main" id="{A549E146-F798-415E-8DB4-D07621C1DAB7}"/>
+              </a:ext>
+            </a:extLst>
+          </p:cNvPr>
+          <p:cNvSpPr>
+            <a:spLocks xmlns:a="http://schemas.openxmlformats.org/drawingml/2006/main" noGrp="1"/>
+          </p:cNvSpPr>
+          <p:nvPr/>
+        </p:nvSpPr>
+        <p:spPr>
+          <a:xfrm xmlns:a="http://schemas.openxmlformats.org/drawingml/2006/main">
+            <a:off x="7772400" y="3314700"/>
             <a:ext cx="2781300" cy="552450"/>
           </a:xfrm>
           <a:prstGeom xmlns:a="http://schemas.openxmlformats.org/drawingml/2006/main" prst="rect">
@@ -7785,7 +7785,7 @@
           <a:lstStyle xmlns:a="http://schemas.openxmlformats.org/drawingml/2006/main"/>
           <a:p xmlns:a="http://schemas.openxmlformats.org/drawingml/2006/main">
             <a:pPr algn="l">
-              <a:defRPr sz="1125" b="0">
+              <a:defRPr sz="1275" b="0">
                 <a:solidFill>
                   <a:srgbClr val="171717"/>
                 </a:solidFill>
@@ -7795,7 +7795,7 @@
               </a:defRPr>
             </a:pPr>
             <a:r>
-              <a:rPr sz="1125" b="0">
+              <a:rPr sz="1275" b="0">
                 <a:solidFill>
                   <a:srgbClr val="171717"/>
                 </a:solidFill>
@@ -7803,7 +7803,7 @@
                 <a:ea typeface="Hiragino Sans"/>
                 <a:cs typeface="Hiragino Sans"/>
               </a:rPr>
-              <a:t>損失差が大きいほど、古い清浄点を残す</a:t>
+              <a:t>損失差 → 古い清浄点</a:t>
             </a:r>
           </a:p>
         </p:txBody>
@@ -7813,18 +7813,18 @@
           <p:cNvPr id="21" name="">
             <a:extLst xmlns:a="http://schemas.openxmlformats.org/drawingml/2006/main">
               <a:ext uri="{FF2B5EF4-FFF2-40B4-BE49-F238E27FC236}">
-                <a16:creationId xmlns:a16="http://schemas.microsoft.com/office/drawing/2014/main" id="{F383031E-184B-4503-8E66-1F1FB5B23C13}"/>
-              </a:ext>
-            </a:extLst>
-          </p:cNvPr>
-          <p:cNvSpPr>
-            <a:spLocks xmlns:a="http://schemas.openxmlformats.org/drawingml/2006/main" noGrp="1"/>
-          </p:cNvSpPr>
-          <p:nvPr/>
-        </p:nvSpPr>
-        <p:spPr>
-          <a:xfrm xmlns:a="http://schemas.openxmlformats.org/drawingml/2006/main">
-            <a:off x="7562850" y="4038600"/>
+                <a16:creationId xmlns:a16="http://schemas.microsoft.com/office/drawing/2014/main" id="{EAABC930-CFC9-4703-BF93-DA674EF2D0AF}"/>
+              </a:ext>
+            </a:extLst>
+          </p:cNvPr>
+          <p:cNvSpPr>
+            <a:spLocks xmlns:a="http://schemas.openxmlformats.org/drawingml/2006/main" noGrp="1"/>
+          </p:cNvSpPr>
+          <p:nvPr/>
+        </p:nvSpPr>
+        <p:spPr>
+          <a:xfrm xmlns:a="http://schemas.openxmlformats.org/drawingml/2006/main">
+            <a:off x="7562850" y="4076700"/>
             <a:ext cx="85725" cy="85725"/>
           </a:xfrm>
           <a:prstGeom xmlns:a="http://schemas.openxmlformats.org/drawingml/2006/main" prst="ellipse">
@@ -7848,18 +7848,18 @@
           <p:cNvPr id="22" name="">
             <a:extLst xmlns:a="http://schemas.openxmlformats.org/drawingml/2006/main">
               <a:ext uri="{FF2B5EF4-FFF2-40B4-BE49-F238E27FC236}">
-                <a16:creationId xmlns:a16="http://schemas.microsoft.com/office/drawing/2014/main" id="{191F4728-F299-4DCB-8CF7-18CB9FD9E5A6}"/>
-              </a:ext>
-            </a:extLst>
-          </p:cNvPr>
-          <p:cNvSpPr>
-            <a:spLocks xmlns:a="http://schemas.openxmlformats.org/drawingml/2006/main" noGrp="1"/>
-          </p:cNvSpPr>
-          <p:nvPr/>
-        </p:nvSpPr>
-        <p:spPr>
-          <a:xfrm xmlns:a="http://schemas.openxmlformats.org/drawingml/2006/main">
-            <a:off x="7772400" y="3962400"/>
+                <a16:creationId xmlns:a16="http://schemas.microsoft.com/office/drawing/2014/main" id="{56EBC44F-2C07-4D77-95AA-7C813944996C}"/>
+              </a:ext>
+            </a:extLst>
+          </p:cNvPr>
+          <p:cNvSpPr>
+            <a:spLocks xmlns:a="http://schemas.openxmlformats.org/drawingml/2006/main" noGrp="1"/>
+          </p:cNvSpPr>
+          <p:nvPr/>
+        </p:nvSpPr>
+        <p:spPr>
+          <a:xfrm xmlns:a="http://schemas.openxmlformats.org/drawingml/2006/main">
+            <a:off x="7772400" y="4000500"/>
             <a:ext cx="2781300" cy="552450"/>
           </a:xfrm>
           <a:prstGeom xmlns:a="http://schemas.openxmlformats.org/drawingml/2006/main" prst="rect">
@@ -7884,7 +7884,7 @@
           <a:lstStyle xmlns:a="http://schemas.openxmlformats.org/drawingml/2006/main"/>
           <a:p xmlns:a="http://schemas.openxmlformats.org/drawingml/2006/main">
             <a:pPr algn="l">
-              <a:defRPr sz="1125" b="0">
+              <a:defRPr sz="1275" b="0">
                 <a:solidFill>
                   <a:srgbClr val="171717"/>
                 </a:solidFill>
@@ -7894,7 +7894,7 @@
               </a:defRPr>
             </a:pPr>
             <a:r>
-              <a:rPr sz="1125" b="0">
+              <a:rPr sz="1275" b="0">
                 <a:solidFill>
                   <a:srgbClr val="171717"/>
                 </a:solidFill>
@@ -7902,7 +7902,7 @@
                 <a:ea typeface="Hiragino Sans"/>
                 <a:cs typeface="Hiragino Sans"/>
               </a:rPr>
-              <a:t>τ_R と d₀ は、復旧後も残る損失</a:t>
+              <a:t>τ_R・d₀ → 復旧後も残る損失</a:t>
             </a:r>
           </a:p>
         </p:txBody>
@@ -7912,18 +7912,18 @@
           <p:cNvPr id="23" name="">
             <a:extLst xmlns:a="http://schemas.openxmlformats.org/drawingml/2006/main">
               <a:ext uri="{FF2B5EF4-FFF2-40B4-BE49-F238E27FC236}">
-                <a16:creationId xmlns:a16="http://schemas.microsoft.com/office/drawing/2014/main" id="{412D4697-E13C-43DD-9410-3B37B8785B57}"/>
-              </a:ext>
-            </a:extLst>
-          </p:cNvPr>
-          <p:cNvSpPr>
-            <a:spLocks xmlns:a="http://schemas.openxmlformats.org/drawingml/2006/main" noGrp="1"/>
-          </p:cNvSpPr>
-          <p:nvPr/>
-        </p:nvSpPr>
-        <p:spPr>
-          <a:xfrm xmlns:a="http://schemas.openxmlformats.org/drawingml/2006/main">
-            <a:off x="7562850" y="4667250"/>
+                <a16:creationId xmlns:a16="http://schemas.microsoft.com/office/drawing/2014/main" id="{89E833B1-B64B-4615-A146-20090C2B0943}"/>
+              </a:ext>
+            </a:extLst>
+          </p:cNvPr>
+          <p:cNvSpPr>
+            <a:spLocks xmlns:a="http://schemas.openxmlformats.org/drawingml/2006/main" noGrp="1"/>
+          </p:cNvSpPr>
+          <p:nvPr/>
+        </p:nvSpPr>
+        <p:spPr>
+          <a:xfrm xmlns:a="http://schemas.openxmlformats.org/drawingml/2006/main">
+            <a:off x="7562850" y="4762500"/>
             <a:ext cx="85725" cy="85725"/>
           </a:xfrm>
           <a:prstGeom xmlns:a="http://schemas.openxmlformats.org/drawingml/2006/main" prst="ellipse">
@@ -7947,18 +7947,18 @@
           <p:cNvPr id="24" name="">
             <a:extLst xmlns:a="http://schemas.openxmlformats.org/drawingml/2006/main">
               <a:ext uri="{FF2B5EF4-FFF2-40B4-BE49-F238E27FC236}">
-                <a16:creationId xmlns:a16="http://schemas.microsoft.com/office/drawing/2014/main" id="{EAC33E15-447D-484A-BB2E-540B0E5C17A5}"/>
-              </a:ext>
-            </a:extLst>
-          </p:cNvPr>
-          <p:cNvSpPr>
-            <a:spLocks xmlns:a="http://schemas.openxmlformats.org/drawingml/2006/main" noGrp="1"/>
-          </p:cNvSpPr>
-          <p:nvPr/>
-        </p:nvSpPr>
-        <p:spPr>
-          <a:xfrm xmlns:a="http://schemas.openxmlformats.org/drawingml/2006/main">
-            <a:off x="7772400" y="4591050"/>
+                <a16:creationId xmlns:a16="http://schemas.microsoft.com/office/drawing/2014/main" id="{4DF90852-2683-4B91-9810-8EAA19351812}"/>
+              </a:ext>
+            </a:extLst>
+          </p:cNvPr>
+          <p:cNvSpPr>
+            <a:spLocks xmlns:a="http://schemas.openxmlformats.org/drawingml/2006/main" noGrp="1"/>
+          </p:cNvSpPr>
+          <p:nvPr/>
+        </p:nvSpPr>
+        <p:spPr>
+          <a:xfrm xmlns:a="http://schemas.openxmlformats.org/drawingml/2006/main">
+            <a:off x="7772400" y="4686300"/>
             <a:ext cx="2781300" cy="552450"/>
           </a:xfrm>
           <a:prstGeom xmlns:a="http://schemas.openxmlformats.org/drawingml/2006/main" prst="rect">
@@ -7983,7 +7983,7 @@
           <a:lstStyle xmlns:a="http://schemas.openxmlformats.org/drawingml/2006/main"/>
           <a:p xmlns:a="http://schemas.openxmlformats.org/drawingml/2006/main">
             <a:pPr algn="l">
-              <a:defRPr sz="1125" b="0">
+              <a:defRPr sz="1275" b="0">
                 <a:solidFill>
                   <a:srgbClr val="171717"/>
                 </a:solidFill>
@@ -7993,7 +7993,7 @@
               </a:defRPr>
             </a:pPr>
             <a:r>
-              <a:rPr sz="1125" b="0">
+              <a:rPr sz="1275" b="0">
                 <a:solidFill>
                   <a:srgbClr val="171717"/>
                 </a:solidFill>
@@ -8001,7 +8001,7 @@
                 <a:ea typeface="Hiragino Sans"/>
                 <a:cs typeface="Hiragino Sans"/>
               </a:rPr>
-              <a:t>κ_s は、長く戻るほど増える運用コスト</a:t>
+              <a:t>κ_s → 長く戻る運用コスト</a:t>
             </a:r>
           </a:p>
         </p:txBody>
@@ -8011,7 +8011,7 @@
           <p:cNvPr id="25" name="">
             <a:extLst xmlns:a="http://schemas.openxmlformats.org/drawingml/2006/main">
               <a:ext uri="{FF2B5EF4-FFF2-40B4-BE49-F238E27FC236}">
-                <a16:creationId xmlns:a16="http://schemas.microsoft.com/office/drawing/2014/main" id="{9271E4D9-A292-4C49-80F6-59B44F47EC7C}"/>
+                <a16:creationId xmlns:a16="http://schemas.microsoft.com/office/drawing/2014/main" id="{E5DEDDEF-144B-4E86-98E4-1EE056579292}"/>
               </a:ext>
             </a:extLst>
           </p:cNvPr>
@@ -8046,7 +8046,7 @@
           <p:cNvPr id="26" name="">
             <a:extLst xmlns:a="http://schemas.openxmlformats.org/drawingml/2006/main">
               <a:ext uri="{FF2B5EF4-FFF2-40B4-BE49-F238E27FC236}">
-                <a16:creationId xmlns:a16="http://schemas.microsoft.com/office/drawing/2014/main" id="{EC3AC651-97E7-4ABD-A385-2621640D18EE}"/>
+                <a16:creationId xmlns:a16="http://schemas.microsoft.com/office/drawing/2014/main" id="{4146AE72-9AEB-478D-B5F5-12BC91BD3A5A}"/>
               </a:ext>
             </a:extLst>
           </p:cNvPr>
@@ -8110,7 +8110,7 @@
           <p:cNvPr id="27" name="">
             <a:extLst xmlns:a="http://schemas.openxmlformats.org/drawingml/2006/main">
               <a:ext uri="{FF2B5EF4-FFF2-40B4-BE49-F238E27FC236}">
-                <a16:creationId xmlns:a16="http://schemas.microsoft.com/office/drawing/2014/main" id="{A19226F5-DA6C-4912-90ED-A4A46FC0A687}"/>
+                <a16:creationId xmlns:a16="http://schemas.microsoft.com/office/drawing/2014/main" id="{1A51C2E7-DF2C-4020-9FDA-0A35CEBBAF6A}"/>
               </a:ext>
             </a:extLst>
           </p:cNvPr>
@@ -8145,7 +8145,7 @@
           <p:cNvPr id="28" name="">
             <a:extLst xmlns:a="http://schemas.openxmlformats.org/drawingml/2006/main">
               <a:ext uri="{FF2B5EF4-FFF2-40B4-BE49-F238E27FC236}">
-                <a16:creationId xmlns:a16="http://schemas.microsoft.com/office/drawing/2014/main" id="{F39CB40F-AE64-4E65-A4BE-6F7A0B16043B}"/>
+                <a16:creationId xmlns:a16="http://schemas.microsoft.com/office/drawing/2014/main" id="{CDD95FD9-3740-4B98-A261-AB79DD955E32}"/>
               </a:ext>
             </a:extLst>
           </p:cNvPr>
@@ -8181,7 +8181,7 @@
           <a:lstStyle xmlns:a="http://schemas.openxmlformats.org/drawingml/2006/main"/>
           <a:p xmlns:a="http://schemas.openxmlformats.org/drawingml/2006/main">
             <a:pPr algn="l">
-              <a:defRPr sz="788" b="0">
+              <a:defRPr sz="825" b="0">
                 <a:solidFill>
                   <a:srgbClr val="5F6B7A"/>
                 </a:solidFill>
@@ -8191,7 +8191,7 @@
               </a:defRPr>
             </a:pPr>
             <a:r>
-              <a:rPr sz="788" b="0">
+              <a:rPr sz="825" b="0">
                 <a:solidFill>
                   <a:srgbClr val="5F6B7A"/>
                 </a:solidFill>
@@ -8199,7 +8199,7 @@
                 <a:ea typeface="Aptos"/>
                 <a:cs typeface="Aptos"/>
               </a:rPr>
-              <a:t>Sources: 05_backup_optimization.tex; 08_conclusion.tex. Formula is conditional on the stated interior/admissible design assumptions.</a:t>
+              <a:t>Provenance note: 05_backup_optimization.tex; 08_conclusion.tex. Formula is conditional on the stated interior/admissible design assumptions.</a:t>
             </a:r>
           </a:p>
         </p:txBody>
@@ -8207,7 +8207,7 @@
     </p:spTree>
     <p:extLst>
       <p:ext uri="{BB962C8B-B14F-4D97-AF65-F5344CB8AC3E}">
-        <p14:creationId xmlns:p14="http://schemas.microsoft.com/office/powerpoint/2010/main" val="417110375"/>
+        <p14:creationId xmlns:p14="http://schemas.microsoft.com/office/powerpoint/2010/main" val="1360647430"/>
       </p:ext>
     </p:extLst>
   </p:cSld>
@@ -8231,7 +8231,7 @@
           <p:cNvPr id="1" name="">
             <a:extLst xmlns:a="http://schemas.openxmlformats.org/drawingml/2006/main">
               <a:ext uri="{FF2B5EF4-FFF2-40B4-BE49-F238E27FC236}">
-                <a16:creationId xmlns:a16="http://schemas.microsoft.com/office/drawing/2014/main" id="{50D83A32-37B4-48B8-A3C8-F1E87E024F32}"/>
+                <a16:creationId xmlns:a16="http://schemas.microsoft.com/office/drawing/2014/main" id="{63684DF4-79F4-4D41-8988-1CA3F598319C}"/>
               </a:ext>
             </a:extLst>
           </p:cNvPr>
@@ -8266,7 +8266,7 @@
           <p:cNvPr id="2" name="">
             <a:extLst xmlns:a="http://schemas.openxmlformats.org/drawingml/2006/main">
               <a:ext uri="{FF2B5EF4-FFF2-40B4-BE49-F238E27FC236}">
-                <a16:creationId xmlns:a16="http://schemas.microsoft.com/office/drawing/2014/main" id="{E16E7417-C4E5-4461-A2D0-EC565803529F}"/>
+                <a16:creationId xmlns:a16="http://schemas.microsoft.com/office/drawing/2014/main" id="{2F56EE6E-5E34-4033-982F-FB632FF0A635}"/>
               </a:ext>
             </a:extLst>
           </p:cNvPr>
@@ -8301,7 +8301,7 @@
           <p:cNvPr id="3" name="">
             <a:extLst xmlns:a="http://schemas.openxmlformats.org/drawingml/2006/main">
               <a:ext uri="{FF2B5EF4-FFF2-40B4-BE49-F238E27FC236}">
-                <a16:creationId xmlns:a16="http://schemas.microsoft.com/office/drawing/2014/main" id="{7D57AE44-FEE9-4EFB-99A7-4AA2AE4214A3}"/>
+                <a16:creationId xmlns:a16="http://schemas.microsoft.com/office/drawing/2014/main" id="{2DBC98BB-F65F-408D-A2F6-14FF8B25318A}"/>
               </a:ext>
             </a:extLst>
           </p:cNvPr>
@@ -8365,7 +8365,7 @@
           <p:cNvPr id="4" name="">
             <a:extLst xmlns:a="http://schemas.openxmlformats.org/drawingml/2006/main">
               <a:ext uri="{FF2B5EF4-FFF2-40B4-BE49-F238E27FC236}">
-                <a16:creationId xmlns:a16="http://schemas.microsoft.com/office/drawing/2014/main" id="{0C533A60-C11C-4ED0-868A-25C0D0FC08A0}"/>
+                <a16:creationId xmlns:a16="http://schemas.microsoft.com/office/drawing/2014/main" id="{3B5175AF-F0D2-47A5-A33E-DDCD2B37F1F2}"/>
               </a:ext>
             </a:extLst>
           </p:cNvPr>
@@ -8429,7 +8429,7 @@
           <p:cNvPr id="5" name="">
             <a:extLst xmlns:a="http://schemas.openxmlformats.org/drawingml/2006/main">
               <a:ext uri="{FF2B5EF4-FFF2-40B4-BE49-F238E27FC236}">
-                <a16:creationId xmlns:a16="http://schemas.microsoft.com/office/drawing/2014/main" id="{D3868195-E6A4-45E0-932B-906F8F8ACF99}"/>
+                <a16:creationId xmlns:a16="http://schemas.microsoft.com/office/drawing/2014/main" id="{709D66FE-A9BC-4F4C-8339-76DF00D3631E}"/>
               </a:ext>
             </a:extLst>
           </p:cNvPr>
@@ -8493,7 +8493,7 @@
           <p:cNvPr id="6" name="">
             <a:extLst xmlns:a="http://schemas.openxmlformats.org/drawingml/2006/main">
               <a:ext uri="{FF2B5EF4-FFF2-40B4-BE49-F238E27FC236}">
-                <a16:creationId xmlns:a16="http://schemas.microsoft.com/office/drawing/2014/main" id="{12D64E0B-506A-4442-96A3-F40F3C399CC0}"/>
+                <a16:creationId xmlns:a16="http://schemas.microsoft.com/office/drawing/2014/main" id="{1F8C3A16-6DEF-45D8-8912-CA4BA1400C35}"/>
               </a:ext>
             </a:extLst>
           </p:cNvPr>
@@ -8557,7 +8557,7 @@
           <p:cNvPr id="7" name="">
             <a:extLst xmlns:a="http://schemas.openxmlformats.org/drawingml/2006/main">
               <a:ext uri="{FF2B5EF4-FFF2-40B4-BE49-F238E27FC236}">
-                <a16:creationId xmlns:a16="http://schemas.microsoft.com/office/drawing/2014/main" id="{499B3B4B-917F-4B9F-BAC7-E7660F59DDA1}"/>
+                <a16:creationId xmlns:a16="http://schemas.microsoft.com/office/drawing/2014/main" id="{F3449098-E3B7-4826-96A5-57B9FD5F206B}"/>
               </a:ext>
             </a:extLst>
           </p:cNvPr>
@@ -8590,7 +8590,7 @@
           <p:cNvPr id="8" name="">
             <a:extLst xmlns:a="http://schemas.openxmlformats.org/drawingml/2006/main">
               <a:ext uri="{FF2B5EF4-FFF2-40B4-BE49-F238E27FC236}">
-                <a16:creationId xmlns:a16="http://schemas.microsoft.com/office/drawing/2014/main" id="{F9EFDCEE-5A7A-45DE-AA0F-55C96E4E158E}"/>
+                <a16:creationId xmlns:a16="http://schemas.microsoft.com/office/drawing/2014/main" id="{98F75A3B-B204-4EC1-80C3-40643C59B7DA}"/>
               </a:ext>
             </a:extLst>
           </p:cNvPr>
@@ -8625,7 +8625,7 @@
           <p:cNvPr id="9" name="">
             <a:extLst xmlns:a="http://schemas.openxmlformats.org/drawingml/2006/main">
               <a:ext uri="{FF2B5EF4-FFF2-40B4-BE49-F238E27FC236}">
-                <a16:creationId xmlns:a16="http://schemas.microsoft.com/office/drawing/2014/main" id="{25F9DEF3-95AC-4AF0-8630-4E7B9FAF329A}"/>
+                <a16:creationId xmlns:a16="http://schemas.microsoft.com/office/drawing/2014/main" id="{B9AC6A75-48CC-442B-9FB0-2466DC36C876}"/>
               </a:ext>
             </a:extLst>
           </p:cNvPr>
@@ -8689,7 +8689,7 @@
           <p:cNvPr id="10" name="">
             <a:extLst xmlns:a="http://schemas.openxmlformats.org/drawingml/2006/main">
               <a:ext uri="{FF2B5EF4-FFF2-40B4-BE49-F238E27FC236}">
-                <a16:creationId xmlns:a16="http://schemas.microsoft.com/office/drawing/2014/main" id="{BB7B4D27-45D3-41C5-B442-D7630BF9EF24}"/>
+                <a16:creationId xmlns:a16="http://schemas.microsoft.com/office/drawing/2014/main" id="{2BF0C293-ABB4-4998-B0C1-FE1663DB2C60}"/>
               </a:ext>
             </a:extLst>
           </p:cNvPr>
@@ -8753,7 +8753,7 @@
           <p:cNvPr id="11" name="">
             <a:extLst xmlns:a="http://schemas.openxmlformats.org/drawingml/2006/main">
               <a:ext uri="{FF2B5EF4-FFF2-40B4-BE49-F238E27FC236}">
-                <a16:creationId xmlns:a16="http://schemas.microsoft.com/office/drawing/2014/main" id="{09A4BA22-59DC-437A-B371-F00964E446B3}"/>
+                <a16:creationId xmlns:a16="http://schemas.microsoft.com/office/drawing/2014/main" id="{A2F41319-771E-48EE-9697-A0DC090C4DB1}"/>
               </a:ext>
             </a:extLst>
           </p:cNvPr>
@@ -8789,7 +8789,7 @@
           <a:lstStyle xmlns:a="http://schemas.openxmlformats.org/drawingml/2006/main"/>
           <a:p xmlns:a="http://schemas.openxmlformats.org/drawingml/2006/main">
             <a:pPr algn="l">
-              <a:defRPr sz="1125" b="0">
+              <a:defRPr sz="1275" b="1">
                 <a:solidFill>
                   <a:srgbClr val="171717"/>
                 </a:solidFill>
@@ -8799,7 +8799,7 @@
               </a:defRPr>
             </a:pPr>
             <a:r>
-              <a:rPr sz="1125" b="0">
+              <a:rPr sz="1275" b="1">
                 <a:solidFill>
                   <a:srgbClr val="171717"/>
                 </a:solidFill>
@@ -8807,7 +8807,7 @@
                 <a:ea typeface="Hiragino Sans"/>
                 <a:cs typeface="Hiragino Sans"/>
               </a:rPr>
-              <a:t>全損 L、停止損失 d₁、復旧費 d₀ を見積もる</a:t>
+              <a:t>L、d₁、d₀ を見積もる</a:t>
             </a:r>
           </a:p>
         </p:txBody>
@@ -8817,7 +8817,7 @@
           <p:cNvPr id="12" name="">
             <a:extLst xmlns:a="http://schemas.openxmlformats.org/drawingml/2006/main">
               <a:ext uri="{FF2B5EF4-FFF2-40B4-BE49-F238E27FC236}">
-                <a16:creationId xmlns:a16="http://schemas.microsoft.com/office/drawing/2014/main" id="{4A2B30CF-9DEB-4835-AD35-6C9239BD12A0}"/>
+                <a16:creationId xmlns:a16="http://schemas.microsoft.com/office/drawing/2014/main" id="{84BA9A3B-0655-4B63-90C8-6668BAA8708D}"/>
               </a:ext>
             </a:extLst>
           </p:cNvPr>
@@ -8881,7 +8881,7 @@
           <p:cNvPr id="13" name="">
             <a:extLst xmlns:a="http://schemas.openxmlformats.org/drawingml/2006/main">
               <a:ext uri="{FF2B5EF4-FFF2-40B4-BE49-F238E27FC236}">
-                <a16:creationId xmlns:a16="http://schemas.microsoft.com/office/drawing/2014/main" id="{4803FAB5-0749-457A-9B76-542FCDDC2DDD}"/>
+                <a16:creationId xmlns:a16="http://schemas.microsoft.com/office/drawing/2014/main" id="{C4C2495E-6A97-43D3-B4B9-5C4F00DC9183}"/>
               </a:ext>
             </a:extLst>
           </p:cNvPr>
@@ -8914,7 +8914,7 @@
           <p:cNvPr id="14" name="">
             <a:extLst xmlns:a="http://schemas.openxmlformats.org/drawingml/2006/main">
               <a:ext uri="{FF2B5EF4-FFF2-40B4-BE49-F238E27FC236}">
-                <a16:creationId xmlns:a16="http://schemas.microsoft.com/office/drawing/2014/main" id="{53C82D9C-C8B6-4EBA-BCF2-9C4B5A0C0794}"/>
+                <a16:creationId xmlns:a16="http://schemas.microsoft.com/office/drawing/2014/main" id="{B3DA91B1-90A9-4B36-BD85-215DD5E9A35A}"/>
               </a:ext>
             </a:extLst>
           </p:cNvPr>
@@ -8949,7 +8949,7 @@
           <p:cNvPr id="15" name="">
             <a:extLst xmlns:a="http://schemas.openxmlformats.org/drawingml/2006/main">
               <a:ext uri="{FF2B5EF4-FFF2-40B4-BE49-F238E27FC236}">
-                <a16:creationId xmlns:a16="http://schemas.microsoft.com/office/drawing/2014/main" id="{FC9F8D25-134E-4B7E-8897-959E9FC21319}"/>
+                <a16:creationId xmlns:a16="http://schemas.microsoft.com/office/drawing/2014/main" id="{4AFF65CD-2E36-4609-8FCD-22CB89B7EEDF}"/>
               </a:ext>
             </a:extLst>
           </p:cNvPr>
@@ -9013,7 +9013,7 @@
           <p:cNvPr id="16" name="">
             <a:extLst xmlns:a="http://schemas.openxmlformats.org/drawingml/2006/main">
               <a:ext uri="{FF2B5EF4-FFF2-40B4-BE49-F238E27FC236}">
-                <a16:creationId xmlns:a16="http://schemas.microsoft.com/office/drawing/2014/main" id="{BEC12ECD-FEB5-48C9-9B39-CD0AE9831EF6}"/>
+                <a16:creationId xmlns:a16="http://schemas.microsoft.com/office/drawing/2014/main" id="{E7FF6F36-2D83-430F-A0D9-ED79189EBC48}"/>
               </a:ext>
             </a:extLst>
           </p:cNvPr>
@@ -9077,7 +9077,7 @@
           <p:cNvPr id="17" name="">
             <a:extLst xmlns:a="http://schemas.openxmlformats.org/drawingml/2006/main">
               <a:ext uri="{FF2B5EF4-FFF2-40B4-BE49-F238E27FC236}">
-                <a16:creationId xmlns:a16="http://schemas.microsoft.com/office/drawing/2014/main" id="{5577721A-8279-4598-8D19-295A12D3F896}"/>
+                <a16:creationId xmlns:a16="http://schemas.microsoft.com/office/drawing/2014/main" id="{119C592F-A830-4558-BEAD-9302B2B974B0}"/>
               </a:ext>
             </a:extLst>
           </p:cNvPr>
@@ -9113,7 +9113,7 @@
           <a:lstStyle xmlns:a="http://schemas.openxmlformats.org/drawingml/2006/main"/>
           <a:p xmlns:a="http://schemas.openxmlformats.org/drawingml/2006/main">
             <a:pPr algn="l">
-              <a:defRPr sz="1125" b="0">
+              <a:defRPr sz="1275" b="1">
                 <a:solidFill>
                   <a:srgbClr val="171717"/>
                 </a:solidFill>
@@ -9123,7 +9123,7 @@
               </a:defRPr>
             </a:pPr>
             <a:r>
-              <a:rPr sz="1125" b="0">
+              <a:rPr sz="1275" b="1">
                 <a:solidFill>
                   <a:srgbClr val="171717"/>
                 </a:solidFill>
@@ -9131,7 +9131,7 @@
                 <a:ea typeface="Hiragino Sans"/>
                 <a:cs typeface="Hiragino Sans"/>
               </a:rPr>
-              <a:t>隔離・クローン・再デプロイで τ_R と κ_s を置く</a:t>
+              <a:t>τ_R と κ_s を置く</a:t>
             </a:r>
           </a:p>
         </p:txBody>
@@ -9141,7 +9141,7 @@
           <p:cNvPr id="18" name="">
             <a:extLst xmlns:a="http://schemas.openxmlformats.org/drawingml/2006/main">
               <a:ext uri="{FF2B5EF4-FFF2-40B4-BE49-F238E27FC236}">
-                <a16:creationId xmlns:a16="http://schemas.microsoft.com/office/drawing/2014/main" id="{E5281CA9-9D0C-4C5C-8189-7C22E05588AA}"/>
+                <a16:creationId xmlns:a16="http://schemas.microsoft.com/office/drawing/2014/main" id="{3A24FE38-E751-4BC6-868A-908C5D6DEBAE}"/>
               </a:ext>
             </a:extLst>
           </p:cNvPr>
@@ -9205,7 +9205,7 @@
           <p:cNvPr id="19" name="">
             <a:extLst xmlns:a="http://schemas.openxmlformats.org/drawingml/2006/main">
               <a:ext uri="{FF2B5EF4-FFF2-40B4-BE49-F238E27FC236}">
-                <a16:creationId xmlns:a16="http://schemas.microsoft.com/office/drawing/2014/main" id="{A6480E18-AA3F-49F0-981B-789E74A1F64B}"/>
+                <a16:creationId xmlns:a16="http://schemas.microsoft.com/office/drawing/2014/main" id="{02AB3ADD-3D05-47CB-9E49-C8FCE0239F34}"/>
               </a:ext>
             </a:extLst>
           </p:cNvPr>
@@ -9238,7 +9238,7 @@
           <p:cNvPr id="20" name="">
             <a:extLst xmlns:a="http://schemas.openxmlformats.org/drawingml/2006/main">
               <a:ext uri="{FF2B5EF4-FFF2-40B4-BE49-F238E27FC236}">
-                <a16:creationId xmlns:a16="http://schemas.microsoft.com/office/drawing/2014/main" id="{744D298F-14A3-43CA-890B-7361EF587972}"/>
+                <a16:creationId xmlns:a16="http://schemas.microsoft.com/office/drawing/2014/main" id="{F970B62E-1BEB-4455-8025-E31C9C29F529}"/>
               </a:ext>
             </a:extLst>
           </p:cNvPr>
@@ -9273,7 +9273,7 @@
           <p:cNvPr id="21" name="">
             <a:extLst xmlns:a="http://schemas.openxmlformats.org/drawingml/2006/main">
               <a:ext uri="{FF2B5EF4-FFF2-40B4-BE49-F238E27FC236}">
-                <a16:creationId xmlns:a16="http://schemas.microsoft.com/office/drawing/2014/main" id="{004BA40F-0C4F-4D6E-8BD3-69650C4E9601}"/>
+                <a16:creationId xmlns:a16="http://schemas.microsoft.com/office/drawing/2014/main" id="{40943E97-DF95-4127-9979-0DCBC6113B93}"/>
               </a:ext>
             </a:extLst>
           </p:cNvPr>
@@ -9337,7 +9337,7 @@
           <p:cNvPr id="22" name="">
             <a:extLst xmlns:a="http://schemas.openxmlformats.org/drawingml/2006/main">
               <a:ext uri="{FF2B5EF4-FFF2-40B4-BE49-F238E27FC236}">
-                <a16:creationId xmlns:a16="http://schemas.microsoft.com/office/drawing/2014/main" id="{79D44E98-FB11-4B03-83B8-530DB3A6ED61}"/>
+                <a16:creationId xmlns:a16="http://schemas.microsoft.com/office/drawing/2014/main" id="{288623B9-006D-4DC4-AE2F-EF8339961998}"/>
               </a:ext>
             </a:extLst>
           </p:cNvPr>
@@ -9401,7 +9401,7 @@
           <p:cNvPr id="23" name="">
             <a:extLst xmlns:a="http://schemas.openxmlformats.org/drawingml/2006/main">
               <a:ext uri="{FF2B5EF4-FFF2-40B4-BE49-F238E27FC236}">
-                <a16:creationId xmlns:a16="http://schemas.microsoft.com/office/drawing/2014/main" id="{2A70EF07-F7EE-4CE5-AC02-5ADCC068AB4C}"/>
+                <a16:creationId xmlns:a16="http://schemas.microsoft.com/office/drawing/2014/main" id="{C5C57E2D-1670-45C9-8F2F-A5045C539A12}"/>
               </a:ext>
             </a:extLst>
           </p:cNvPr>
@@ -9437,7 +9437,7 @@
           <a:lstStyle xmlns:a="http://schemas.openxmlformats.org/drawingml/2006/main"/>
           <a:p xmlns:a="http://schemas.openxmlformats.org/drawingml/2006/main">
             <a:pPr algn="l">
-              <a:defRPr sz="1125" b="0">
+              <a:defRPr sz="1275" b="1">
                 <a:solidFill>
                   <a:srgbClr val="171717"/>
                 </a:solidFill>
@@ -9447,7 +9447,7 @@
               </a:defRPr>
             </a:pPr>
             <a:r>
-              <a:rPr sz="1125" b="0">
+              <a:rPr sz="1275" b="1">
                 <a:solidFill>
                   <a:srgbClr val="171717"/>
                 </a:solidFill>
@@ -9455,7 +9455,7 @@
                 <a:ea typeface="Hiragino Sans"/>
                 <a:cs typeface="Hiragino Sans"/>
               </a:rPr>
-              <a:t>検知時点の感染後経過時間が a* を超えないかを見る</a:t>
+              <a:t>感染後経過が a* 内か見る</a:t>
             </a:r>
           </a:p>
         </p:txBody>
@@ -9465,7 +9465,7 @@
           <p:cNvPr id="24" name="">
             <a:extLst xmlns:a="http://schemas.openxmlformats.org/drawingml/2006/main">
               <a:ext uri="{FF2B5EF4-FFF2-40B4-BE49-F238E27FC236}">
-                <a16:creationId xmlns:a16="http://schemas.microsoft.com/office/drawing/2014/main" id="{7AF5E713-8FB0-4AF5-B490-635EAE5ACA36}"/>
+                <a16:creationId xmlns:a16="http://schemas.microsoft.com/office/drawing/2014/main" id="{61B175A0-DEC1-4E03-A3C9-A5BA14E3C77D}"/>
               </a:ext>
             </a:extLst>
           </p:cNvPr>
@@ -9529,7 +9529,7 @@
           <p:cNvPr id="25" name="">
             <a:extLst xmlns:a="http://schemas.openxmlformats.org/drawingml/2006/main">
               <a:ext uri="{FF2B5EF4-FFF2-40B4-BE49-F238E27FC236}">
-                <a16:creationId xmlns:a16="http://schemas.microsoft.com/office/drawing/2014/main" id="{C7D799B3-F2F4-4C92-A927-2F6853FE4F48}"/>
+                <a16:creationId xmlns:a16="http://schemas.microsoft.com/office/drawing/2014/main" id="{3FA2BE7D-00A0-40F2-B2CF-CF8B13B1551D}"/>
               </a:ext>
             </a:extLst>
           </p:cNvPr>
@@ -9562,7 +9562,7 @@
           <p:cNvPr id="26" name="">
             <a:extLst xmlns:a="http://schemas.openxmlformats.org/drawingml/2006/main">
               <a:ext uri="{FF2B5EF4-FFF2-40B4-BE49-F238E27FC236}">
-                <a16:creationId xmlns:a16="http://schemas.microsoft.com/office/drawing/2014/main" id="{6E538AB4-3AC1-48F1-993A-2C7007C94EB0}"/>
+                <a16:creationId xmlns:a16="http://schemas.microsoft.com/office/drawing/2014/main" id="{704AEDF2-A664-4314-AB8A-92F37E5EF944}"/>
               </a:ext>
             </a:extLst>
           </p:cNvPr>
@@ -9597,7 +9597,7 @@
           <p:cNvPr id="27" name="">
             <a:extLst xmlns:a="http://schemas.openxmlformats.org/drawingml/2006/main">
               <a:ext uri="{FF2B5EF4-FFF2-40B4-BE49-F238E27FC236}">
-                <a16:creationId xmlns:a16="http://schemas.microsoft.com/office/drawing/2014/main" id="{99D14F37-DEE9-47BE-AB7D-1FF6A565CDEA}"/>
+                <a16:creationId xmlns:a16="http://schemas.microsoft.com/office/drawing/2014/main" id="{755AC641-C618-4898-A355-C846BA517167}"/>
               </a:ext>
             </a:extLst>
           </p:cNvPr>
@@ -9661,7 +9661,7 @@
           <p:cNvPr id="28" name="">
             <a:extLst xmlns:a="http://schemas.openxmlformats.org/drawingml/2006/main">
               <a:ext uri="{FF2B5EF4-FFF2-40B4-BE49-F238E27FC236}">
-                <a16:creationId xmlns:a16="http://schemas.microsoft.com/office/drawing/2014/main" id="{F35A93E4-F55D-45B7-9262-628FCDA05D50}"/>
+                <a16:creationId xmlns:a16="http://schemas.microsoft.com/office/drawing/2014/main" id="{9CDDA92A-E775-4716-AD05-FBBEE4EF78B6}"/>
               </a:ext>
             </a:extLst>
           </p:cNvPr>
@@ -9725,7 +9725,7 @@
           <p:cNvPr id="29" name="">
             <a:extLst xmlns:a="http://schemas.openxmlformats.org/drawingml/2006/main">
               <a:ext uri="{FF2B5EF4-FFF2-40B4-BE49-F238E27FC236}">
-                <a16:creationId xmlns:a16="http://schemas.microsoft.com/office/drawing/2014/main" id="{034111D3-CC10-4ECD-8561-7F0E7C816CF0}"/>
+                <a16:creationId xmlns:a16="http://schemas.microsoft.com/office/drawing/2014/main" id="{7A81B513-E5AD-46AF-B43B-6F1293CF8F6F}"/>
               </a:ext>
             </a:extLst>
           </p:cNvPr>
@@ -9761,7 +9761,7 @@
           <a:lstStyle xmlns:a="http://schemas.openxmlformats.org/drawingml/2006/main"/>
           <a:p xmlns:a="http://schemas.openxmlformats.org/drawingml/2006/main">
             <a:pPr algn="l">
-              <a:defRPr sz="1125" b="0">
+              <a:defRPr sz="1275" b="1">
                 <a:solidFill>
                   <a:srgbClr val="171717"/>
                 </a:solidFill>
@@ -9771,7 +9771,7 @@
               </a:defRPr>
             </a:pPr>
             <a:r>
-              <a:rPr sz="1125" b="0">
+              <a:rPr sz="1275" b="1">
                 <a:solidFill>
                   <a:srgbClr val="171717"/>
                 </a:solidFill>
@@ -9779,7 +9779,7 @@
                 <a:ea typeface="Hiragino Sans"/>
                 <a:cs typeface="Hiragino Sans"/>
               </a:rPr>
-              <a:t>n と Δ を実装し、追加で何世代伸ばすかを整数評価する</a:t>
+              <a:t>n、Δ、追加世代を評価する</a:t>
             </a:r>
           </a:p>
         </p:txBody>
@@ -9789,7 +9789,7 @@
           <p:cNvPr id="30" name="">
             <a:extLst xmlns:a="http://schemas.openxmlformats.org/drawingml/2006/main">
               <a:ext uri="{FF2B5EF4-FFF2-40B4-BE49-F238E27FC236}">
-                <a16:creationId xmlns:a16="http://schemas.microsoft.com/office/drawing/2014/main" id="{EB3BA01E-E000-4DD7-A81E-9E52A6E31692}"/>
+                <a16:creationId xmlns:a16="http://schemas.microsoft.com/office/drawing/2014/main" id="{0CD5C46E-C806-49A8-AD56-86A5578F21E6}"/>
               </a:ext>
             </a:extLst>
           </p:cNvPr>
@@ -9822,7 +9822,7 @@
           <p:cNvPr id="31" name="">
             <a:extLst xmlns:a="http://schemas.openxmlformats.org/drawingml/2006/main">
               <a:ext uri="{FF2B5EF4-FFF2-40B4-BE49-F238E27FC236}">
-                <a16:creationId xmlns:a16="http://schemas.microsoft.com/office/drawing/2014/main" id="{4374FF03-1893-4A07-9478-2D44D47ED05E}"/>
+                <a16:creationId xmlns:a16="http://schemas.microsoft.com/office/drawing/2014/main" id="{C2322D96-EE50-4FCA-A772-096E714BF94F}"/>
               </a:ext>
             </a:extLst>
           </p:cNvPr>
@@ -9886,7 +9886,7 @@
           <p:cNvPr id="32" name="">
             <a:extLst xmlns:a="http://schemas.openxmlformats.org/drawingml/2006/main">
               <a:ext uri="{FF2B5EF4-FFF2-40B4-BE49-F238E27FC236}">
-                <a16:creationId xmlns:a16="http://schemas.microsoft.com/office/drawing/2014/main" id="{EF551A5D-B3D6-4190-825E-94F92161EF46}"/>
+                <a16:creationId xmlns:a16="http://schemas.microsoft.com/office/drawing/2014/main" id="{A449536A-1874-4FA4-B13E-3BDB701A02E1}"/>
               </a:ext>
             </a:extLst>
           </p:cNvPr>
@@ -9919,7 +9919,7 @@
           <p:cNvPr id="33" name="">
             <a:extLst xmlns:a="http://schemas.openxmlformats.org/drawingml/2006/main">
               <a:ext uri="{FF2B5EF4-FFF2-40B4-BE49-F238E27FC236}">
-                <a16:creationId xmlns:a16="http://schemas.microsoft.com/office/drawing/2014/main" id="{F3FCBA4D-5CC4-4429-9299-11205BB06EFB}"/>
+                <a16:creationId xmlns:a16="http://schemas.microsoft.com/office/drawing/2014/main" id="{763C9F45-2F28-402C-A09B-CD6B13E0F2E1}"/>
               </a:ext>
             </a:extLst>
           </p:cNvPr>
@@ -9983,7 +9983,7 @@
           <p:cNvPr id="34" name="">
             <a:extLst xmlns:a="http://schemas.openxmlformats.org/drawingml/2006/main">
               <a:ext uri="{FF2B5EF4-FFF2-40B4-BE49-F238E27FC236}">
-                <a16:creationId xmlns:a16="http://schemas.microsoft.com/office/drawing/2014/main" id="{E0F81EB6-1FE6-4F3B-888A-4B6DFA326CE3}"/>
+                <a16:creationId xmlns:a16="http://schemas.microsoft.com/office/drawing/2014/main" id="{2B850D6A-B922-4CC3-9AA7-F396B31C805B}"/>
               </a:ext>
             </a:extLst>
           </p:cNvPr>
@@ -10016,7 +10016,7 @@
           <p:cNvPr id="35" name="">
             <a:extLst xmlns:a="http://schemas.openxmlformats.org/drawingml/2006/main">
               <a:ext uri="{FF2B5EF4-FFF2-40B4-BE49-F238E27FC236}">
-                <a16:creationId xmlns:a16="http://schemas.microsoft.com/office/drawing/2014/main" id="{95D620C1-792F-414B-BE8A-6C7C0C1F2224}"/>
+                <a16:creationId xmlns:a16="http://schemas.microsoft.com/office/drawing/2014/main" id="{97AFEAEB-A029-45FB-ABA8-63AD6D7BFF34}"/>
               </a:ext>
             </a:extLst>
           </p:cNvPr>
@@ -10080,7 +10080,7 @@
           <p:cNvPr id="36" name="">
             <a:extLst xmlns:a="http://schemas.openxmlformats.org/drawingml/2006/main">
               <a:ext uri="{FF2B5EF4-FFF2-40B4-BE49-F238E27FC236}">
-                <a16:creationId xmlns:a16="http://schemas.microsoft.com/office/drawing/2014/main" id="{9B8C8352-5B37-48C2-A38C-4B7FBCE0DEFB}"/>
+                <a16:creationId xmlns:a16="http://schemas.microsoft.com/office/drawing/2014/main" id="{F7E47924-76F5-46B5-B4B4-489594A34B44}"/>
               </a:ext>
             </a:extLst>
           </p:cNvPr>
@@ -10144,7 +10144,7 @@
           <p:cNvPr id="37" name="">
             <a:extLst xmlns:a="http://schemas.openxmlformats.org/drawingml/2006/main">
               <a:ext uri="{FF2B5EF4-FFF2-40B4-BE49-F238E27FC236}">
-                <a16:creationId xmlns:a16="http://schemas.microsoft.com/office/drawing/2014/main" id="{2D0C04E2-2CCA-45A6-B765-F739C063B564}"/>
+                <a16:creationId xmlns:a16="http://schemas.microsoft.com/office/drawing/2014/main" id="{35F87C02-A4DD-44FF-9DC6-987692DA00C7}"/>
               </a:ext>
             </a:extLst>
           </p:cNvPr>
@@ -10179,7 +10179,7 @@
           <p:cNvPr id="38" name="">
             <a:extLst xmlns:a="http://schemas.openxmlformats.org/drawingml/2006/main">
               <a:ext uri="{FF2B5EF4-FFF2-40B4-BE49-F238E27FC236}">
-                <a16:creationId xmlns:a16="http://schemas.microsoft.com/office/drawing/2014/main" id="{2C0E16EB-0526-48DC-95D9-33D46531405E}"/>
+                <a16:creationId xmlns:a16="http://schemas.microsoft.com/office/drawing/2014/main" id="{273C869D-0410-400A-9851-7D29B128B3BB}"/>
               </a:ext>
             </a:extLst>
           </p:cNvPr>
@@ -10215,7 +10215,7 @@
           <a:lstStyle xmlns:a="http://schemas.openxmlformats.org/drawingml/2006/main"/>
           <a:p xmlns:a="http://schemas.openxmlformats.org/drawingml/2006/main">
             <a:pPr algn="l">
-              <a:defRPr sz="788" b="0">
+              <a:defRPr sz="825" b="0">
                 <a:solidFill>
                   <a:srgbClr val="5F6B7A"/>
                 </a:solidFill>
@@ -10225,7 +10225,7 @@
               </a:defRPr>
             </a:pPr>
             <a:r>
-              <a:rPr sz="788" b="0">
+              <a:rPr sz="825" b="0">
                 <a:solidFill>
                   <a:srgbClr val="5F6B7A"/>
                 </a:solidFill>
@@ -10233,7 +10233,7 @@
                 <a:ea typeface="Aptos"/>
                 <a:cs typeface="Aptos"/>
               </a:rPr>
-              <a:t>Sources: 05_backup_optimization.tex; 06_dynamic_retention.tex; 07_numerical_examples.tex; docs/evidence/heavy_tail_backup_source_note.md.</a:t>
+              <a:t>Provenance note: 05_backup_optimization.tex; 06_dynamic_retention.tex; 07_numerical_examples.tex; docs/evidence/heavy_tail_backup_source_note.md.</a:t>
             </a:r>
           </a:p>
         </p:txBody>
@@ -10241,7 +10241,7 @@
     </p:spTree>
     <p:extLst>
       <p:ext uri="{BB962C8B-B14F-4D97-AF65-F5344CB8AC3E}">
-        <p14:creationId xmlns:p14="http://schemas.microsoft.com/office/powerpoint/2010/main" val="1462916172"/>
+        <p14:creationId xmlns:p14="http://schemas.microsoft.com/office/powerpoint/2010/main" val="1478719450"/>
       </p:ext>
     </p:extLst>
   </p:cSld>

</xml_diff>